<commit_message>
fix(video): add conversational narration, music, and animated branding
Co-Authored-By: Muhammad Hassan Raza <147485527+hassandev03@users.noreply.github.com>
</commit_message>
<xml_diff>
--- a/presentation/InsightIQ-pitch-enhanced.pptx
+++ b/presentation/InsightIQ-pitch-enhanced.pptx
@@ -2,22 +2,22 @@
 <file path=ppt/presentation.xml><?xml version="1.0" encoding="utf-8"?>
 <p:presentation xmlns:p="http://schemas.openxmlformats.org/presentationml/2006/main">
   <p:sldMasterIdLst>
-    <p:sldMasterId xmlns:r="http://schemas.openxmlformats.org/officeDocument/2006/relationships" id="2147483648" r:id="R78feaaa70f9e4a39"/>
+    <p:sldMasterId xmlns:r="http://schemas.openxmlformats.org/officeDocument/2006/relationships" id="2147483648" r:id="Rabc31960788c45a4"/>
   </p:sldMasterIdLst>
   <p:notesMasterIdLst>
-    <p:notesMasterId xmlns:r="http://schemas.openxmlformats.org/officeDocument/2006/relationships" r:id="R80b96f7db617483b"/>
+    <p:notesMasterId xmlns:r="http://schemas.openxmlformats.org/officeDocument/2006/relationships" r:id="Rcdf1a07cf3f44409"/>
   </p:notesMasterIdLst>
   <p:sldIdLst>
-    <p:sldId xmlns:r="http://schemas.openxmlformats.org/officeDocument/2006/relationships" id="256" r:id="R73b61b77e0bb4a0f"/>
-    <p:sldId xmlns:r="http://schemas.openxmlformats.org/officeDocument/2006/relationships" id="257" r:id="R232f2c2de03c4bdb"/>
-    <p:sldId xmlns:r="http://schemas.openxmlformats.org/officeDocument/2006/relationships" id="258" r:id="Rc1f2c68e180b44bc"/>
-    <p:sldId xmlns:r="http://schemas.openxmlformats.org/officeDocument/2006/relationships" id="259" r:id="R3521ae1676c34d76"/>
-    <p:sldId xmlns:r="http://schemas.openxmlformats.org/officeDocument/2006/relationships" id="260" r:id="R19fb654398074356"/>
-    <p:sldId xmlns:r="http://schemas.openxmlformats.org/officeDocument/2006/relationships" id="261" r:id="R4262ca2b10284322"/>
-    <p:sldId xmlns:r="http://schemas.openxmlformats.org/officeDocument/2006/relationships" id="262" r:id="Rfbaaf35b7de742dd"/>
-    <p:sldId xmlns:r="http://schemas.openxmlformats.org/officeDocument/2006/relationships" id="263" r:id="R4ba4ccb6a240483c"/>
-    <p:sldId xmlns:r="http://schemas.openxmlformats.org/officeDocument/2006/relationships" id="264" r:id="Ref52c1f158a04441"/>
-    <p:sldId xmlns:r="http://schemas.openxmlformats.org/officeDocument/2006/relationships" id="265" r:id="R24f4477354ec4324"/>
+    <p:sldId xmlns:r="http://schemas.openxmlformats.org/officeDocument/2006/relationships" id="256" r:id="Rfb9d16a555fa49c8"/>
+    <p:sldId xmlns:r="http://schemas.openxmlformats.org/officeDocument/2006/relationships" id="257" r:id="R2c7550623ba2478a"/>
+    <p:sldId xmlns:r="http://schemas.openxmlformats.org/officeDocument/2006/relationships" id="258" r:id="R7ee56db81c2a4bab"/>
+    <p:sldId xmlns:r="http://schemas.openxmlformats.org/officeDocument/2006/relationships" id="259" r:id="Rb0b15f849191493f"/>
+    <p:sldId xmlns:r="http://schemas.openxmlformats.org/officeDocument/2006/relationships" id="260" r:id="Ra58cacfafc334538"/>
+    <p:sldId xmlns:r="http://schemas.openxmlformats.org/officeDocument/2006/relationships" id="261" r:id="R8d2bfeee09e948ec"/>
+    <p:sldId xmlns:r="http://schemas.openxmlformats.org/officeDocument/2006/relationships" id="262" r:id="Rbdd51bd1854f48e4"/>
+    <p:sldId xmlns:r="http://schemas.openxmlformats.org/officeDocument/2006/relationships" id="263" r:id="R07eb3be6fd4f4e29"/>
+    <p:sldId xmlns:r="http://schemas.openxmlformats.org/officeDocument/2006/relationships" id="264" r:id="R885f899616c24649"/>
+    <p:sldId xmlns:r="http://schemas.openxmlformats.org/officeDocument/2006/relationships" id="265" r:id="R3718e84a9c174489"/>
   </p:sldIdLst>
   <p:sldSz cx="12192000" cy="6858000"/>
   <p:notesSz cx="6858000" cy="9144000"/>
@@ -451,7 +451,7 @@
           <a:lstStyle xmlns:a="http://schemas.openxmlformats.org/drawingml/2006/main"/>
           <a:p xmlns:a="http://schemas.openxmlformats.org/drawingml/2006/main">
             <a:r>
-              <a:t>Project sources: README.md; InsightIQ-docs/docs/submission/hackathon-submission.md; InsightIQ-docs/docs/engineering/current-status.md. No business performance results or time savings are asserted. Logo: apps/web/public/insightiq-logo.svg. Actual authenticated desktop screenshots captured 2026-09-08 from the local running InsightIQ application. Public-source demo research about Vercel. The research output is AI-generated, with source claims, conditional hypotheses, and questions for human review. Hypotheses are not established prospect needs.</a:t>
+              <a:t>InsightIQ helps people prepare for a sales conversation using public research, their offer, and evidence they can inspect.</a:t>
             </a:r>
           </a:p>
         </p:txBody>
@@ -521,7 +521,7 @@
           <a:lstStyle xmlns:a="http://schemas.openxmlformats.org/drawingml/2006/main"/>
           <a:p xmlns:a="http://schemas.openxmlformats.org/drawingml/2006/main">
             <a:r>
-              <a:t>Contributors confirmed by user: Afnan Ahmad Tariq, Danyal Rana, Hassan. No individual roles inferred. Live product https://insightiq.zerotools.online.</a:t>
+              <a:t>InsightIQ was built by Afnan Ahmad Tariq, Danyal Rana, and Hassan. The product is available at insightiq.zerotools.online.</a:t>
             </a:r>
           </a:p>
         </p:txBody>
@@ -591,7 +591,7 @@
           <a:lstStyle xmlns:a="http://schemas.openxmlformats.org/drawingml/2006/main"/>
           <a:p xmlns:a="http://schemas.openxmlformats.org/drawingml/2006/main">
             <a:r>
-              <a:t>Project sources: README.md; InsightIQ-docs/docs/submission/hackathon-submission.md; InsightIQ-docs/docs/engineering/current-status.md. No business performance results or time savings are asserted.</a:t>
+              <a:t>Our starting point was a common sales problem: knowing a company fact is useful, but knowing how to discuss its possible relevance takes more work. InsightIQ separates the fact, possible fit, and question.</a:t>
             </a:r>
           </a:p>
         </p:txBody>
@@ -661,7 +661,7 @@
           <a:lstStyle xmlns:a="http://schemas.openxmlformats.org/drawingml/2006/main"/>
           <a:p xmlns:a="http://schemas.openxmlformats.org/drawingml/2006/main">
             <a:r>
-              <a:t>Project sources: README.md; InsightIQ-docs/docs/submission/hackathon-submission.md; InsightIQ-docs/docs/engineering/current-status.md. No business performance results or time savings are asserted. Actual authenticated desktop screenshots captured 2026-09-08 from the local running InsightIQ application. Public-source demo research about Vercel. The research output is AI-generated, with source claims, conditional hypotheses, and questions for human review. Hypotheses are not established prospect needs.</a:t>
+              <a:t>The seller chooses meeting preparation or outreach, adds a prospect, and explains the offer. That context shapes the research and output.</a:t>
             </a:r>
           </a:p>
         </p:txBody>
@@ -731,7 +731,7 @@
           <a:lstStyle xmlns:a="http://schemas.openxmlformats.org/drawingml/2006/main"/>
           <a:p xmlns:a="http://schemas.openxmlformats.org/drawingml/2006/main">
             <a:r>
-              <a:t>Project sources: README.md; InsightIQ-docs/docs/submission/hackathon-submission.md; InsightIQ-docs/docs/engineering/current-status.md. No business performance results or time savings are asserted. Workflow source: apps/worker/src/insightiq_worker/graph_brief.py. API saves an immutable snapshot and performs Tavily discovery with Wikipedia fallback; the worker uses Qwen via DashScope and LangGraph. Citation checks match key signals to evidence records, source URLs, and claims.</a:t>
+              <a:t>The workflow saves the context, finds public sources, extracts evidence, and builds a brief. The seller reviews sources and gaps before using the result.</a:t>
             </a:r>
           </a:p>
         </p:txBody>
@@ -801,7 +801,7 @@
           <a:lstStyle xmlns:a="http://schemas.openxmlformats.org/drawingml/2006/main"/>
           <a:p xmlns:a="http://schemas.openxmlformats.org/drawingml/2006/main">
             <a:r>
-              <a:t>Project sources: README.md; InsightIQ-docs/docs/submission/hackathon-submission.md; InsightIQ-docs/docs/engineering/current-status.md. No business performance results or time savings are asserted. Actual authenticated desktop screenshots captured 2026-09-08 from the local running InsightIQ application. Public-source demo research about Vercel. The research output is AI-generated, with source claims, conditional hypotheses, and questions for human review. Hypotheses are not established prospect needs.</a:t>
+              <a:t>This dashboard keeps research progress and saved briefs in the same workspace. A seller can open completed research and continue preparing.</a:t>
             </a:r>
           </a:p>
         </p:txBody>
@@ -871,7 +871,7 @@
           <a:lstStyle xmlns:a="http://schemas.openxmlformats.org/drawingml/2006/main"/>
           <a:p xmlns:a="http://schemas.openxmlformats.org/drawingml/2006/main">
             <a:r>
-              <a:t>Project sources: README.md; InsightIQ-docs/docs/submission/hackathon-submission.md; InsightIQ-docs/docs/engineering/current-status.md. No business performance results or time savings are asserted. Actual authenticated desktop screenshots captured 2026-09-08 from the local running InsightIQ application. Public-source demo research about Vercel. The research output is AI-generated, with source claims, conditional hypotheses, and questions for human review. Hypotheses are not established prospect needs.</a:t>
+              <a:t>This is an example from a Vercel brief. The source claim stays separate from the possible fit. The conditional wording matters: the seller still needs to test the hypothesis by asking the question.</a:t>
             </a:r>
           </a:p>
         </p:txBody>
@@ -941,7 +941,7 @@
           <a:lstStyle xmlns:a="http://schemas.openxmlformats.org/drawingml/2006/main"/>
           <a:p xmlns:a="http://schemas.openxmlformats.org/drawingml/2006/main">
             <a:r>
-              <a:t>Project sources: README.md; InsightIQ-docs/docs/submission/hackathon-submission.md; InsightIQ-docs/docs/engineering/current-status.md. No business performance results or time savings are asserted. Actual authenticated desktop screenshots captured 2026-09-08 from the local running InsightIQ application. Public-source demo research about Vercel. The research output is AI-generated, with source claims, conditional hypotheses, and questions for human review. Hypotheses are not established prospect needs. Citation gate implementation: apps/worker/src/insightiq_worker/graph_brief.py. Citations establish traceability, not guaranteed truth.</a:t>
+              <a:t>A seller can inspect the evidence behind a signal and check source freshness or contradictions. A citation makes a claim traceable, but human judgment still matters.</a:t>
             </a:r>
           </a:p>
         </p:txBody>
@@ -1011,7 +1011,7 @@
           <a:lstStyle xmlns:a="http://schemas.openxmlformats.org/drawingml/2006/main"/>
           <a:p xmlns:a="http://schemas.openxmlformats.org/drawingml/2006/main">
             <a:r>
-              <a:t>Project sources: README.md; InsightIQ-docs/docs/submission/hackathon-submission.md; InsightIQ-docs/docs/engineering/current-status.md. No business performance results or time savings are asserted. Exact nodes and edges from docs/assets/architecture.mmd. This diagram is editable. Dashboard hosted through OpenNext on Cloudflare Workers. API, Python worker and PostgreSQL run with Docker Compose on a VPS. Nginx handles API traffic.</a:t>
+              <a:t>The Next.js dashboard talks to a NestJS API. PostgreSQL stores the workspace and research jobs. A Python and LangGraph worker runs the research, using Tavily discovery and Qwen through DashScope.</a:t>
             </a:r>
           </a:p>
         </p:txBody>
@@ -1081,7 +1081,7 @@
           <a:lstStyle xmlns:a="http://schemas.openxmlformats.org/drawingml/2006/main"/>
           <a:p xmlns:a="http://schemas.openxmlformats.org/drawingml/2006/main">
             <a:r>
-              <a:t>Project sources: README.md; InsightIQ-docs/docs/submission/hackathon-submission.md; InsightIQ-docs/docs/engineering/current-status.md. No business performance results or time savings are asserted. Actual authenticated desktop screenshots captured 2026-09-08 from the local running InsightIQ application. Public-source demo research about Vercel. The research output is AI-generated, with source claims, conditional hypotheses, and questions for human review. Hypotheses are not established prospect needs. The screenshot shows an actual local AI-generated outreach draft. The user remains responsible for reviewing and sending it.</a:t>
+              <a:t>The outreach draft connects the research to the offer and invites a reply. The seller can personalize the message and verify its claims before sending.</a:t>
             </a:r>
           </a:p>
         </p:txBody>
@@ -1149,7 +1149,7 @@
   </p:cSld>
   <p:clrMap bg1="lt1" tx1="dk1" bg2="lt2" tx2="dk2" accent1="accent1" accent2="accent2" accent3="accent3" accent4="accent4" accent5="accent5" accent6="accent6" hlink="hlink" folHlink="folHlink"/>
   <p:sldLayoutIdLst>
-    <p:sldLayoutId xmlns:r="http://schemas.openxmlformats.org/officeDocument/2006/relationships" id="2147483649" r:id="R2f2ab7d630e546e9"/>
+    <p:sldLayoutId xmlns:r="http://schemas.openxmlformats.org/officeDocument/2006/relationships" id="2147483649" r:id="R35a7179dcb284c84"/>
   </p:sldLayoutIdLst>
   <p:txStyles>
     <p:titleStyle>
@@ -1697,20 +1697,20 @@
       </p:grpSpPr>
       <p:pic>
         <p:nvPicPr>
-          <p:cNvPr id="7" name=""/>
+          <p:cNvPr id="6" name=""/>
           <p:cNvPicPr>
             <a:picLocks xmlns:a="http://schemas.openxmlformats.org/drawingml/2006/main" noChangeAspect="1"/>
           </p:cNvPicPr>
           <p:nvPr/>
         </p:nvPicPr>
         <p:blipFill>
-          <a:blip xmlns:r="http://schemas.openxmlformats.org/officeDocument/2006/relationships" xmlns:a="http://schemas.openxmlformats.org/drawingml/2006/main" r:embed="Rf1a81de5c4eb4df0"/>
+          <a:blip xmlns:r="http://schemas.openxmlformats.org/officeDocument/2006/relationships" xmlns:a="http://schemas.openxmlformats.org/drawingml/2006/main" r:embed="Ree3f3351a38d4c0f"/>
           <a:stretch xmlns:a="http://schemas.openxmlformats.org/drawingml/2006/main"/>
         </p:blipFill>
         <p:spPr>
           <a:xfrm xmlns:a="http://schemas.openxmlformats.org/drawingml/2006/main">
-            <a:off x="590550" y="361950"/>
-            <a:ext cx="571500" cy="571500"/>
+            <a:off x="8429625" y="1571625"/>
+            <a:ext cx="2952750" cy="2952750"/>
           </a:xfrm>
           <a:prstGeom xmlns:a="http://schemas.openxmlformats.org/drawingml/2006/main" prst="rect">
             <a:avLst/>
@@ -1722,19 +1722,19 @@
           <p:cNvPr id="2" name="">
             <a:extLst xmlns:a="http://schemas.openxmlformats.org/drawingml/2006/main">
               <a:ext uri="{FF2B5EF4-FFF2-40B4-BE49-F238E27FC236}">
-                <a16:creationId xmlns:a16="http://schemas.microsoft.com/office/drawing/2014/main" id="{E779FFD7-542B-4BE2-83D3-3DC64007B88A}"/>
-              </a:ext>
-            </a:extLst>
-          </p:cNvPr>
-          <p:cNvSpPr>
-            <a:spLocks xmlns:a="http://schemas.openxmlformats.org/drawingml/2006/main" noGrp="1"/>
-          </p:cNvSpPr>
-          <p:nvPr/>
-        </p:nvSpPr>
-        <p:spPr>
-          <a:xfrm xmlns:a="http://schemas.openxmlformats.org/drawingml/2006/main">
-            <a:off x="1266825" y="400050"/>
-            <a:ext cx="3810000" cy="552450"/>
+                <a16:creationId xmlns:a16="http://schemas.microsoft.com/office/drawing/2014/main" id="{439374FE-022A-49B2-9006-EAA67C19487C}"/>
+              </a:ext>
+            </a:extLst>
+          </p:cNvPr>
+          <p:cNvSpPr>
+            <a:spLocks xmlns:a="http://schemas.openxmlformats.org/drawingml/2006/main" noGrp="1"/>
+          </p:cNvSpPr>
+          <p:nvPr/>
+        </p:nvSpPr>
+        <p:spPr>
+          <a:xfrm xmlns:a="http://schemas.openxmlformats.org/drawingml/2006/main">
+            <a:off x="609600" y="1590675"/>
+            <a:ext cx="7239000" cy="1047750"/>
           </a:xfrm>
           <a:prstGeom xmlns:a="http://schemas.openxmlformats.org/drawingml/2006/main" prst="rect">
             <a:avLst/>
@@ -1751,19 +1751,19 @@
           <a:lstStyle xmlns:a="http://schemas.openxmlformats.org/drawingml/2006/main"/>
           <a:p xmlns:a="http://schemas.openxmlformats.org/drawingml/2006/main">
             <a:pPr>
-              <a:defRPr sz="2550" b="1">
-                <a:solidFill>
-                  <a:srgbClr val="123363"/>
-                </a:solidFill>
-                <a:latin typeface="Helvetica Neue"/>
-                <a:ea typeface="Helvetica Neue"/>
-                <a:cs typeface="Helvetica Neue"/>
-              </a:defRPr>
-            </a:pPr>
-            <a:r>
-              <a:rPr sz="2550" b="1">
-                <a:solidFill>
-                  <a:srgbClr val="123363"/>
+              <a:defRPr sz="6150" b="1">
+                <a:solidFill>
+                  <a:srgbClr val="0B214A"/>
+                </a:solidFill>
+                <a:latin typeface="Helvetica Neue"/>
+                <a:ea typeface="Helvetica Neue"/>
+                <a:cs typeface="Helvetica Neue"/>
+              </a:defRPr>
+            </a:pPr>
+            <a:r>
+              <a:rPr sz="6150" b="1">
+                <a:solidFill>
+                  <a:srgbClr val="0B214A"/>
                 </a:solidFill>
                 <a:latin typeface="Helvetica Neue"/>
                 <a:ea typeface="Helvetica Neue"/>
@@ -1779,19 +1779,19 @@
           <p:cNvPr id="3" name="">
             <a:extLst xmlns:a="http://schemas.openxmlformats.org/drawingml/2006/main">
               <a:ext uri="{FF2B5EF4-FFF2-40B4-BE49-F238E27FC236}">
-                <a16:creationId xmlns:a16="http://schemas.microsoft.com/office/drawing/2014/main" id="{2D125830-0002-4FC0-9252-59E61BCBDA9A}"/>
-              </a:ext>
-            </a:extLst>
-          </p:cNvPr>
-          <p:cNvSpPr>
-            <a:spLocks xmlns:a="http://schemas.openxmlformats.org/drawingml/2006/main" noGrp="1"/>
-          </p:cNvSpPr>
-          <p:nvPr/>
-        </p:nvSpPr>
-        <p:spPr>
-          <a:xfrm xmlns:a="http://schemas.openxmlformats.org/drawingml/2006/main">
-            <a:off x="533400" y="1590675"/>
-            <a:ext cx="6143625" cy="2762250"/>
+                <a16:creationId xmlns:a16="http://schemas.microsoft.com/office/drawing/2014/main" id="{97AAD95F-F9BB-4AC4-A7E7-88E4DADD8CA7}"/>
+              </a:ext>
+            </a:extLst>
+          </p:cNvPr>
+          <p:cNvSpPr>
+            <a:spLocks xmlns:a="http://schemas.openxmlformats.org/drawingml/2006/main" noGrp="1"/>
+          </p:cNvSpPr>
+          <p:nvPr/>
+        </p:nvSpPr>
+        <p:spPr>
+          <a:xfrm xmlns:a="http://schemas.openxmlformats.org/drawingml/2006/main">
+            <a:off x="657225" y="2895600"/>
+            <a:ext cx="7429500" cy="1409700"/>
           </a:xfrm>
           <a:prstGeom xmlns:a="http://schemas.openxmlformats.org/drawingml/2006/main" prst="rect">
             <a:avLst/>
@@ -1808,71 +1808,48 @@
           <a:lstStyle xmlns:a="http://schemas.openxmlformats.org/drawingml/2006/main"/>
           <a:p xmlns:a="http://schemas.openxmlformats.org/drawingml/2006/main">
             <a:pPr>
-              <a:defRPr sz="4575" b="1">
-                <a:solidFill>
-                  <a:srgbClr val="0B214A"/>
-                </a:solidFill>
-                <a:latin typeface="Helvetica Neue"/>
-                <a:ea typeface="Helvetica Neue"/>
-                <a:cs typeface="Helvetica Neue"/>
-              </a:defRPr>
-            </a:pPr>
-            <a:r>
-              <a:rPr sz="4575" b="1">
-                <a:solidFill>
-                  <a:srgbClr val="0B214A"/>
-                </a:solidFill>
-                <a:latin typeface="Helvetica Neue"/>
-                <a:ea typeface="Helvetica Neue"/>
-                <a:cs typeface="Helvetica Neue"/>
-              </a:rPr>
-              <a:t>A source claim.</a:t>
-            </a:r>
-          </a:p>
-          <a:p xmlns:a="http://schemas.openxmlformats.org/drawingml/2006/main">
-            <a:pPr>
-              <a:defRPr sz="4575" b="1">
-                <a:solidFill>
-                  <a:srgbClr val="0B214A"/>
-                </a:solidFill>
-                <a:latin typeface="Helvetica Neue"/>
-                <a:ea typeface="Helvetica Neue"/>
-                <a:cs typeface="Helvetica Neue"/>
-              </a:defRPr>
-            </a:pPr>
-            <a:r>
-              <a:rPr sz="4575" b="1">
-                <a:solidFill>
-                  <a:srgbClr val="0B214A"/>
-                </a:solidFill>
-                <a:latin typeface="Helvetica Neue"/>
-                <a:ea typeface="Helvetica Neue"/>
-                <a:cs typeface="Helvetica Neue"/>
-              </a:rPr>
-              <a:t>A hypothesis.</a:t>
-            </a:r>
-          </a:p>
-          <a:p xmlns:a="http://schemas.openxmlformats.org/drawingml/2006/main">
-            <a:pPr>
-              <a:defRPr sz="4575" b="1">
-                <a:solidFill>
-                  <a:srgbClr val="0B214A"/>
-                </a:solidFill>
-                <a:latin typeface="Helvetica Neue"/>
-                <a:ea typeface="Helvetica Neue"/>
-                <a:cs typeface="Helvetica Neue"/>
-              </a:defRPr>
-            </a:pPr>
-            <a:r>
-              <a:rPr sz="4575" b="1">
-                <a:solidFill>
-                  <a:srgbClr val="0B214A"/>
-                </a:solidFill>
-                <a:latin typeface="Helvetica Neue"/>
-                <a:ea typeface="Helvetica Neue"/>
-                <a:cs typeface="Helvetica Neue"/>
-              </a:rPr>
-              <a:t>A better question.</a:t>
+              <a:defRPr sz="3225" b="0">
+                <a:solidFill>
+                  <a:srgbClr val="123363"/>
+                </a:solidFill>
+                <a:latin typeface="Helvetica Neue"/>
+                <a:ea typeface="Helvetica Neue"/>
+                <a:cs typeface="Helvetica Neue"/>
+              </a:defRPr>
+            </a:pPr>
+            <a:r>
+              <a:rPr sz="3225" b="0">
+                <a:solidFill>
+                  <a:srgbClr val="123363"/>
+                </a:solidFill>
+                <a:latin typeface="Helvetica Neue"/>
+                <a:ea typeface="Helvetica Neue"/>
+                <a:cs typeface="Helvetica Neue"/>
+              </a:rPr>
+              <a:t>AI research for your</a:t>
+            </a:r>
+          </a:p>
+          <a:p xmlns:a="http://schemas.openxmlformats.org/drawingml/2006/main">
+            <a:pPr>
+              <a:defRPr sz="3225" b="0">
+                <a:solidFill>
+                  <a:srgbClr val="123363"/>
+                </a:solidFill>
+                <a:latin typeface="Helvetica Neue"/>
+                <a:ea typeface="Helvetica Neue"/>
+                <a:cs typeface="Helvetica Neue"/>
+              </a:defRPr>
+            </a:pPr>
+            <a:r>
+              <a:rPr sz="3225" b="0">
+                <a:solidFill>
+                  <a:srgbClr val="123363"/>
+                </a:solidFill>
+                <a:latin typeface="Helvetica Neue"/>
+                <a:ea typeface="Helvetica Neue"/>
+                <a:cs typeface="Helvetica Neue"/>
+              </a:rPr>
+              <a:t>next sales conversation</a:t>
             </a:r>
           </a:p>
         </p:txBody>
@@ -1882,19 +1859,19 @@
           <p:cNvPr id="4" name="">
             <a:extLst xmlns:a="http://schemas.openxmlformats.org/drawingml/2006/main">
               <a:ext uri="{FF2B5EF4-FFF2-40B4-BE49-F238E27FC236}">
-                <a16:creationId xmlns:a16="http://schemas.microsoft.com/office/drawing/2014/main" id="{E141E788-FEB5-4EEF-B116-9DF5EDD81B1E}"/>
-              </a:ext>
-            </a:extLst>
-          </p:cNvPr>
-          <p:cNvSpPr>
-            <a:spLocks xmlns:a="http://schemas.openxmlformats.org/drawingml/2006/main" noGrp="1"/>
-          </p:cNvSpPr>
-          <p:nvPr/>
-        </p:nvSpPr>
-        <p:spPr>
-          <a:xfrm xmlns:a="http://schemas.openxmlformats.org/drawingml/2006/main">
-            <a:off x="581025" y="4686300"/>
-            <a:ext cx="5638800" cy="962025"/>
+                <a16:creationId xmlns:a16="http://schemas.microsoft.com/office/drawing/2014/main" id="{1DF961B9-F03B-47AD-9A36-7FEF4EF8341E}"/>
+              </a:ext>
+            </a:extLst>
+          </p:cNvPr>
+          <p:cNvSpPr>
+            <a:spLocks xmlns:a="http://schemas.openxmlformats.org/drawingml/2006/main" noGrp="1"/>
+          </p:cNvSpPr>
+          <p:nvPr/>
+        </p:nvSpPr>
+        <p:spPr>
+          <a:xfrm xmlns:a="http://schemas.openxmlformats.org/drawingml/2006/main">
+            <a:off x="657225" y="4743450"/>
+            <a:ext cx="10610850" cy="542925"/>
           </a:xfrm>
           <a:prstGeom xmlns:a="http://schemas.openxmlformats.org/drawingml/2006/main" prst="rect">
             <a:avLst/>
@@ -1929,51 +1906,29 @@
                 <a:ea typeface="Helvetica Neue"/>
                 <a:cs typeface="Helvetica Neue"/>
               </a:rPr>
-              <a:t>InsightIQ connects public claims to your offer and suggests how to test the fit.</a:t>
-            </a:r>
-          </a:p>
-        </p:txBody>
-      </p:sp>
-      <p:pic>
-        <p:nvPicPr>
-          <p:cNvPr id="11" name=""/>
-          <p:cNvPicPr>
-            <a:picLocks xmlns:a="http://schemas.openxmlformats.org/drawingml/2006/main" noChangeAspect="1"/>
-          </p:cNvPicPr>
-          <p:nvPr/>
-        </p:nvPicPr>
-        <p:blipFill>
-          <a:blip xmlns:r="http://schemas.openxmlformats.org/officeDocument/2006/relationships" xmlns:a="http://schemas.openxmlformats.org/drawingml/2006/main" r:embed="R503b2c7dbf274245"/>
-          <a:stretch xmlns:a="http://schemas.openxmlformats.org/drawingml/2006/main"/>
-        </p:blipFill>
-        <p:spPr>
-          <a:xfrm xmlns:a="http://schemas.openxmlformats.org/drawingml/2006/main">
-            <a:off x="6981825" y="2400643"/>
-            <a:ext cx="4695825" cy="2580589"/>
-          </a:xfrm>
-          <a:prstGeom xmlns:a="http://schemas.openxmlformats.org/drawingml/2006/main" prst="rect">
-            <a:avLst/>
-          </a:prstGeom>
-        </p:spPr>
-      </p:pic>
-      <p:sp>
-        <p:nvSpPr>
-          <p:cNvPr id="6" name="">
-            <a:extLst xmlns:a="http://schemas.openxmlformats.org/drawingml/2006/main">
-              <a:ext uri="{FF2B5EF4-FFF2-40B4-BE49-F238E27FC236}">
-                <a16:creationId xmlns:a16="http://schemas.microsoft.com/office/drawing/2014/main" id="{3FE3C2E0-AE93-4BB2-9DC1-CC1CE79EAC52}"/>
-              </a:ext>
-            </a:extLst>
-          </p:cNvPr>
-          <p:cNvSpPr>
-            <a:spLocks xmlns:a="http://schemas.openxmlformats.org/drawingml/2006/main" noGrp="1"/>
-          </p:cNvSpPr>
-          <p:nvPr/>
-        </p:nvSpPr>
-        <p:spPr>
-          <a:xfrm xmlns:a="http://schemas.openxmlformats.org/drawingml/2006/main">
-            <a:off x="590550" y="6153150"/>
-            <a:ext cx="10477500" cy="304800"/>
+              <a:t>Cited claims. Conditional fit. Questions worth asking.</a:t>
+            </a:r>
+          </a:p>
+        </p:txBody>
+      </p:sp>
+      <p:sp>
+        <p:nvSpPr>
+          <p:cNvPr id="5" name="">
+            <a:extLst xmlns:a="http://schemas.openxmlformats.org/drawingml/2006/main">
+              <a:ext uri="{FF2B5EF4-FFF2-40B4-BE49-F238E27FC236}">
+                <a16:creationId xmlns:a16="http://schemas.microsoft.com/office/drawing/2014/main" id="{D3423AF4-F652-449E-A811-AC209A0234DA}"/>
+              </a:ext>
+            </a:extLst>
+          </p:cNvPr>
+          <p:cNvSpPr>
+            <a:spLocks xmlns:a="http://schemas.openxmlformats.org/drawingml/2006/main" noGrp="1"/>
+          </p:cNvSpPr>
+          <p:nvPr/>
+        </p:nvSpPr>
+        <p:spPr>
+          <a:xfrm xmlns:a="http://schemas.openxmlformats.org/drawingml/2006/main">
+            <a:off x="657225" y="5895975"/>
+            <a:ext cx="10477500" cy="323850"/>
           </a:xfrm>
           <a:prstGeom xmlns:a="http://schemas.openxmlformats.org/drawingml/2006/main" prst="rect">
             <a:avLst/>
@@ -1990,7 +1945,7 @@
           <a:lstStyle xmlns:a="http://schemas.openxmlformats.org/drawingml/2006/main"/>
           <a:p xmlns:a="http://schemas.openxmlformats.org/drawingml/2006/main">
             <a:pPr>
-              <a:defRPr sz="1500" b="0">
+              <a:defRPr sz="1575" b="0">
                 <a:solidFill>
                   <a:srgbClr val="58718B"/>
                 </a:solidFill>
@@ -2000,7 +1955,7 @@
               </a:defRPr>
             </a:pPr>
             <a:r>
-              <a:rPr sz="1500" b="0">
+              <a:rPr sz="1575" b="0">
                 <a:solidFill>
                   <a:srgbClr val="58718B"/>
                 </a:solidFill>
@@ -2016,7 +1971,7 @@
     </p:spTree>
     <p:extLst>
       <p:ext uri="{BB962C8B-B14F-4D97-AF65-F5344CB8AC3E}">
-        <p14:creationId xmlns:p14="http://schemas.microsoft.com/office/powerpoint/2010/main" val="1559544860"/>
+        <p14:creationId xmlns:p14="http://schemas.microsoft.com/office/powerpoint/2010/main" val="1872874702"/>
       </p:ext>
     </p:extLst>
   </p:cSld>
@@ -2047,7 +2002,7 @@
           <p:cNvPr id="6" name="">
             <a:extLst xmlns:a="http://schemas.openxmlformats.org/drawingml/2006/main">
               <a:ext uri="{FF2B5EF4-FFF2-40B4-BE49-F238E27FC236}">
-                <a16:creationId xmlns:a16="http://schemas.microsoft.com/office/drawing/2014/main" id="{B93EA0C0-B61B-464E-AFB4-1608E3732BE4}"/>
+                <a16:creationId xmlns:a16="http://schemas.microsoft.com/office/drawing/2014/main" id="{3AA8D79A-7530-419F-A377-66D1C624AA3A}"/>
               </a:ext>
             </a:extLst>
           </p:cNvPr>
@@ -2104,7 +2059,7 @@
           <p:cNvPr id="2" name="">
             <a:extLst xmlns:a="http://schemas.openxmlformats.org/drawingml/2006/main">
               <a:ext uri="{FF2B5EF4-FFF2-40B4-BE49-F238E27FC236}">
-                <a16:creationId xmlns:a16="http://schemas.microsoft.com/office/drawing/2014/main" id="{F17DF673-1EF2-4668-964C-AC86B4A7402B}"/>
+                <a16:creationId xmlns:a16="http://schemas.microsoft.com/office/drawing/2014/main" id="{60578014-F9F2-4E9A-B96B-44185B5E9BFA}"/>
               </a:ext>
             </a:extLst>
           </p:cNvPr>
@@ -2207,7 +2162,7 @@
           <p:cNvPr id="3" name="">
             <a:extLst xmlns:a="http://schemas.openxmlformats.org/drawingml/2006/main">
               <a:ext uri="{FF2B5EF4-FFF2-40B4-BE49-F238E27FC236}">
-                <a16:creationId xmlns:a16="http://schemas.microsoft.com/office/drawing/2014/main" id="{7A1B4662-FE17-4BBC-A126-36704D6BD1A4}"/>
+                <a16:creationId xmlns:a16="http://schemas.microsoft.com/office/drawing/2014/main" id="{565AFA7C-5D3E-4F14-B0BF-CF2AAD2C1A90}"/>
               </a:ext>
             </a:extLst>
           </p:cNvPr>
@@ -2264,7 +2219,7 @@
           <p:cNvPr id="4" name="">
             <a:extLst xmlns:a="http://schemas.openxmlformats.org/drawingml/2006/main">
               <a:ext uri="{FF2B5EF4-FFF2-40B4-BE49-F238E27FC236}">
-                <a16:creationId xmlns:a16="http://schemas.microsoft.com/office/drawing/2014/main" id="{EFA73AC8-010C-48FA-AD88-5A09053C5A85}"/>
+                <a16:creationId xmlns:a16="http://schemas.microsoft.com/office/drawing/2014/main" id="{A1AE31A6-09FC-448C-9D9C-CF33AAD9178E}"/>
               </a:ext>
             </a:extLst>
           </p:cNvPr>
@@ -2377,7 +2332,7 @@
           <p:cNvPr id="5" name="">
             <a:extLst xmlns:a="http://schemas.openxmlformats.org/drawingml/2006/main">
               <a:ext uri="{FF2B5EF4-FFF2-40B4-BE49-F238E27FC236}">
-                <a16:creationId xmlns:a16="http://schemas.microsoft.com/office/drawing/2014/main" id="{DFF3C3E0-B185-4F9F-AA64-DC9739C40C2B}"/>
+                <a16:creationId xmlns:a16="http://schemas.microsoft.com/office/drawing/2014/main" id="{EC282CB8-921D-49FF-8971-6B58DC98D4F5}"/>
               </a:ext>
             </a:extLst>
           </p:cNvPr>
@@ -2432,7 +2387,7 @@
     </p:spTree>
     <p:extLst>
       <p:ext uri="{BB962C8B-B14F-4D97-AF65-F5344CB8AC3E}">
-        <p14:creationId xmlns:p14="http://schemas.microsoft.com/office/powerpoint/2010/main" val="909855111"/>
+        <p14:creationId xmlns:p14="http://schemas.microsoft.com/office/powerpoint/2010/main" val="450573839"/>
       </p:ext>
     </p:extLst>
   </p:cSld>
@@ -2460,22 +2415,22 @@
       </p:grpSpPr>
       <p:sp>
         <p:nvSpPr>
-          <p:cNvPr id="6" name="">
-            <a:extLst xmlns:a="http://schemas.openxmlformats.org/drawingml/2006/main">
-              <a:ext uri="{FF2B5EF4-FFF2-40B4-BE49-F238E27FC236}">
-                <a16:creationId xmlns:a16="http://schemas.microsoft.com/office/drawing/2014/main" id="{44648167-CB20-4357-8CE1-9FE1824F3330}"/>
-              </a:ext>
-            </a:extLst>
-          </p:cNvPr>
-          <p:cNvSpPr>
-            <a:spLocks xmlns:a="http://schemas.openxmlformats.org/drawingml/2006/main" noGrp="1"/>
-          </p:cNvSpPr>
-          <p:nvPr/>
-        </p:nvSpPr>
-        <p:spPr>
-          <a:xfrm xmlns:a="http://schemas.openxmlformats.org/drawingml/2006/main">
-            <a:off x="590550" y="495300"/>
-            <a:ext cx="7620000" cy="619125"/>
+          <p:cNvPr id="8" name="">
+            <a:extLst xmlns:a="http://schemas.openxmlformats.org/drawingml/2006/main">
+              <a:ext uri="{FF2B5EF4-FFF2-40B4-BE49-F238E27FC236}">
+                <a16:creationId xmlns:a16="http://schemas.microsoft.com/office/drawing/2014/main" id="{F31D7BA4-68E8-48C9-B115-A5FC322D433A}"/>
+              </a:ext>
+            </a:extLst>
+          </p:cNvPr>
+          <p:cNvSpPr>
+            <a:spLocks xmlns:a="http://schemas.openxmlformats.org/drawingml/2006/main" noGrp="1"/>
+          </p:cNvSpPr>
+          <p:nvPr/>
+        </p:nvSpPr>
+        <p:spPr>
+          <a:xfrm xmlns:a="http://schemas.openxmlformats.org/drawingml/2006/main">
+            <a:off x="609600" y="457200"/>
+            <a:ext cx="10972800" cy="762000"/>
           </a:xfrm>
           <a:prstGeom xmlns:a="http://schemas.openxmlformats.org/drawingml/2006/main" prst="rect">
             <a:avLst/>
@@ -2492,25 +2447,25 @@
           <a:lstStyle xmlns:a="http://schemas.openxmlformats.org/drawingml/2006/main"/>
           <a:p xmlns:a="http://schemas.openxmlformats.org/drawingml/2006/main">
             <a:pPr>
-              <a:defRPr sz="2025" b="1">
-                <a:solidFill>
-                  <a:srgbClr val="63D7F2"/>
-                </a:solidFill>
-                <a:latin typeface="Helvetica Neue"/>
-                <a:ea typeface="Helvetica Neue"/>
-                <a:cs typeface="Helvetica Neue"/>
-              </a:defRPr>
-            </a:pPr>
-            <a:r>
-              <a:rPr sz="2025" b="1">
-                <a:solidFill>
-                  <a:srgbClr val="63D7F2"/>
-                </a:solidFill>
-                <a:latin typeface="Helvetica Neue"/>
-                <a:ea typeface="Helvetica Neue"/>
-                <a:cs typeface="Helvetica Neue"/>
-              </a:rPr>
-              <a:t>The idea</a:t>
+              <a:defRPr sz="3525" b="1">
+                <a:solidFill>
+                  <a:srgbClr val="FFFFFF"/>
+                </a:solidFill>
+                <a:latin typeface="Helvetica Neue"/>
+                <a:ea typeface="Helvetica Neue"/>
+                <a:cs typeface="Helvetica Neue"/>
+              </a:defRPr>
+            </a:pPr>
+            <a:r>
+              <a:rPr sz="3525" b="1">
+                <a:solidFill>
+                  <a:srgbClr val="FFFFFF"/>
+                </a:solidFill>
+                <a:latin typeface="Helvetica Neue"/>
+                <a:ea typeface="Helvetica Neue"/>
+                <a:cs typeface="Helvetica Neue"/>
+              </a:rPr>
+              <a:t>The idea behind InsightIQ</a:t>
             </a:r>
           </a:p>
         </p:txBody>
@@ -2520,19 +2475,19 @@
           <p:cNvPr id="2" name="">
             <a:extLst xmlns:a="http://schemas.openxmlformats.org/drawingml/2006/main">
               <a:ext uri="{FF2B5EF4-FFF2-40B4-BE49-F238E27FC236}">
-                <a16:creationId xmlns:a16="http://schemas.microsoft.com/office/drawing/2014/main" id="{453CAC39-8FCD-45E1-8250-78ED5F5C8469}"/>
-              </a:ext>
-            </a:extLst>
-          </p:cNvPr>
-          <p:cNvSpPr>
-            <a:spLocks xmlns:a="http://schemas.openxmlformats.org/drawingml/2006/main" noGrp="1"/>
-          </p:cNvSpPr>
-          <p:nvPr/>
-        </p:nvSpPr>
-        <p:spPr>
-          <a:xfrm xmlns:a="http://schemas.openxmlformats.org/drawingml/2006/main">
-            <a:off x="533400" y="1285875"/>
-            <a:ext cx="6496050" cy="2857500"/>
+                <a16:creationId xmlns:a16="http://schemas.microsoft.com/office/drawing/2014/main" id="{CD9243F6-F365-49C0-8E77-66243CF664BC}"/>
+              </a:ext>
+            </a:extLst>
+          </p:cNvPr>
+          <p:cNvSpPr>
+            <a:spLocks xmlns:a="http://schemas.openxmlformats.org/drawingml/2006/main" noGrp="1"/>
+          </p:cNvSpPr>
+          <p:nvPr/>
+        </p:nvSpPr>
+        <p:spPr>
+          <a:xfrm xmlns:a="http://schemas.openxmlformats.org/drawingml/2006/main">
+            <a:off x="657225" y="1866900"/>
+            <a:ext cx="4743450" cy="495300"/>
           </a:xfrm>
           <a:prstGeom xmlns:a="http://schemas.openxmlformats.org/drawingml/2006/main" prst="rect">
             <a:avLst/>
@@ -2549,71 +2504,25 @@
           <a:lstStyle xmlns:a="http://schemas.openxmlformats.org/drawingml/2006/main"/>
           <a:p xmlns:a="http://schemas.openxmlformats.org/drawingml/2006/main">
             <a:pPr>
-              <a:defRPr sz="4575" b="1">
-                <a:solidFill>
-                  <a:srgbClr val="FFFFFF"/>
-                </a:solidFill>
-                <a:latin typeface="Helvetica Neue"/>
-                <a:ea typeface="Helvetica Neue"/>
-                <a:cs typeface="Helvetica Neue"/>
-              </a:defRPr>
-            </a:pPr>
-            <a:r>
-              <a:rPr sz="4575" b="1">
-                <a:solidFill>
-                  <a:srgbClr val="FFFFFF"/>
-                </a:solidFill>
-                <a:latin typeface="Helvetica Neue"/>
-                <a:ea typeface="Helvetica Neue"/>
-                <a:cs typeface="Helvetica Neue"/>
-              </a:rPr>
-              <a:t>The link between</a:t>
-            </a:r>
-          </a:p>
-          <a:p xmlns:a="http://schemas.openxmlformats.org/drawingml/2006/main">
-            <a:pPr>
-              <a:defRPr sz="4575" b="1">
-                <a:solidFill>
-                  <a:srgbClr val="FFFFFF"/>
-                </a:solidFill>
-                <a:latin typeface="Helvetica Neue"/>
-                <a:ea typeface="Helvetica Neue"/>
-                <a:cs typeface="Helvetica Neue"/>
-              </a:defRPr>
-            </a:pPr>
-            <a:r>
-              <a:rPr sz="4575" b="1">
-                <a:solidFill>
-                  <a:srgbClr val="FFFFFF"/>
-                </a:solidFill>
-                <a:latin typeface="Helvetica Neue"/>
-                <a:ea typeface="Helvetica Neue"/>
-                <a:cs typeface="Helvetica Neue"/>
-              </a:rPr>
-              <a:t>a signal and</a:t>
-            </a:r>
-          </a:p>
-          <a:p xmlns:a="http://schemas.openxmlformats.org/drawingml/2006/main">
-            <a:pPr>
-              <a:defRPr sz="4575" b="1">
-                <a:solidFill>
-                  <a:srgbClr val="FFFFFF"/>
-                </a:solidFill>
-                <a:latin typeface="Helvetica Neue"/>
-                <a:ea typeface="Helvetica Neue"/>
-                <a:cs typeface="Helvetica Neue"/>
-              </a:defRPr>
-            </a:pPr>
-            <a:r>
-              <a:rPr sz="4575" b="1">
-                <a:solidFill>
-                  <a:srgbClr val="FFFFFF"/>
-                </a:solidFill>
-                <a:latin typeface="Helvetica Neue"/>
-                <a:ea typeface="Helvetica Neue"/>
-                <a:cs typeface="Helvetica Neue"/>
-              </a:rPr>
-              <a:t>your offer</a:t>
+              <a:defRPr sz="2175" b="1">
+                <a:solidFill>
+                  <a:srgbClr val="63D7F2"/>
+                </a:solidFill>
+                <a:latin typeface="Helvetica Neue"/>
+                <a:ea typeface="Helvetica Neue"/>
+                <a:cs typeface="Helvetica Neue"/>
+              </a:defRPr>
+            </a:pPr>
+            <a:r>
+              <a:rPr sz="2175" b="1">
+                <a:solidFill>
+                  <a:srgbClr val="63D7F2"/>
+                </a:solidFill>
+                <a:latin typeface="Helvetica Neue"/>
+                <a:ea typeface="Helvetica Neue"/>
+                <a:cs typeface="Helvetica Neue"/>
+              </a:rPr>
+              <a:t>For people who sell</a:t>
             </a:r>
           </a:p>
         </p:txBody>
@@ -2623,19 +2532,19 @@
           <p:cNvPr id="3" name="">
             <a:extLst xmlns:a="http://schemas.openxmlformats.org/drawingml/2006/main">
               <a:ext uri="{FF2B5EF4-FFF2-40B4-BE49-F238E27FC236}">
-                <a16:creationId xmlns:a16="http://schemas.microsoft.com/office/drawing/2014/main" id="{E46E18AD-63B8-4FC5-AFFB-19092EF5F3BC}"/>
-              </a:ext>
-            </a:extLst>
-          </p:cNvPr>
-          <p:cNvSpPr>
-            <a:spLocks xmlns:a="http://schemas.openxmlformats.org/drawingml/2006/main" noGrp="1"/>
-          </p:cNvSpPr>
-          <p:nvPr/>
-        </p:nvSpPr>
-        <p:spPr>
-          <a:xfrm xmlns:a="http://schemas.openxmlformats.org/drawingml/2006/main">
-            <a:off x="7296150" y="1657350"/>
-            <a:ext cx="4229100" cy="1676400"/>
+                <a16:creationId xmlns:a16="http://schemas.microsoft.com/office/drawing/2014/main" id="{C336C3A6-A0FA-44A0-B50C-E2BD6D48FBDA}"/>
+              </a:ext>
+            </a:extLst>
+          </p:cNvPr>
+          <p:cNvSpPr>
+            <a:spLocks xmlns:a="http://schemas.openxmlformats.org/drawingml/2006/main" noGrp="1"/>
+          </p:cNvSpPr>
+          <p:nvPr/>
+        </p:nvSpPr>
+        <p:spPr>
+          <a:xfrm xmlns:a="http://schemas.openxmlformats.org/drawingml/2006/main">
+            <a:off x="657225" y="2590800"/>
+            <a:ext cx="4762500" cy="2028825"/>
           </a:xfrm>
           <a:prstGeom xmlns:a="http://schemas.openxmlformats.org/drawingml/2006/main" prst="rect">
             <a:avLst/>
@@ -2652,71 +2561,71 @@
           <a:lstStyle xmlns:a="http://schemas.openxmlformats.org/drawingml/2006/main"/>
           <a:p xmlns:a="http://schemas.openxmlformats.org/drawingml/2006/main">
             <a:pPr>
-              <a:defRPr sz="2775" b="1">
-                <a:solidFill>
-                  <a:srgbClr val="63D7F2"/>
-                </a:solidFill>
-                <a:latin typeface="Helvetica Neue"/>
-                <a:ea typeface="Helvetica Neue"/>
-                <a:cs typeface="Helvetica Neue"/>
-              </a:defRPr>
-            </a:pPr>
-            <a:r>
-              <a:rPr sz="2775" b="1">
-                <a:solidFill>
-                  <a:srgbClr val="63D7F2"/>
-                </a:solidFill>
-                <a:latin typeface="Helvetica Neue"/>
-                <a:ea typeface="Helvetica Neue"/>
-                <a:cs typeface="Helvetica Neue"/>
-              </a:rPr>
-              <a:t>What is sourced?</a:t>
-            </a:r>
-          </a:p>
-          <a:p xmlns:a="http://schemas.openxmlformats.org/drawingml/2006/main">
-            <a:pPr>
-              <a:defRPr sz="2775" b="1">
-                <a:solidFill>
-                  <a:srgbClr val="63D7F2"/>
-                </a:solidFill>
-                <a:latin typeface="Helvetica Neue"/>
-                <a:ea typeface="Helvetica Neue"/>
-                <a:cs typeface="Helvetica Neue"/>
-              </a:defRPr>
-            </a:pPr>
-            <a:r>
-              <a:rPr sz="2775" b="1">
-                <a:solidFill>
-                  <a:srgbClr val="63D7F2"/>
-                </a:solidFill>
-                <a:latin typeface="Helvetica Neue"/>
-                <a:ea typeface="Helvetica Neue"/>
-                <a:cs typeface="Helvetica Neue"/>
-              </a:rPr>
-              <a:t>What is inferred?</a:t>
-            </a:r>
-          </a:p>
-          <a:p xmlns:a="http://schemas.openxmlformats.org/drawingml/2006/main">
-            <a:pPr>
-              <a:defRPr sz="2775" b="1">
-                <a:solidFill>
-                  <a:srgbClr val="63D7F2"/>
-                </a:solidFill>
-                <a:latin typeface="Helvetica Neue"/>
-                <a:ea typeface="Helvetica Neue"/>
-                <a:cs typeface="Helvetica Neue"/>
-              </a:defRPr>
-            </a:pPr>
-            <a:r>
-              <a:rPr sz="2775" b="1">
-                <a:solidFill>
-                  <a:srgbClr val="63D7F2"/>
-                </a:solidFill>
-                <a:latin typeface="Helvetica Neue"/>
-                <a:ea typeface="Helvetica Neue"/>
-                <a:cs typeface="Helvetica Neue"/>
-              </a:rPr>
-              <a:t>What should I ask?</a:t>
+              <a:defRPr sz="2325" b="0">
+                <a:solidFill>
+                  <a:srgbClr val="FFFFFF"/>
+                </a:solidFill>
+                <a:latin typeface="Helvetica Neue"/>
+                <a:ea typeface="Helvetica Neue"/>
+                <a:cs typeface="Helvetica Neue"/>
+              </a:defRPr>
+            </a:pPr>
+            <a:r>
+              <a:rPr sz="2325" b="0">
+                <a:solidFill>
+                  <a:srgbClr val="FFFFFF"/>
+                </a:solidFill>
+                <a:latin typeface="Helvetica Neue"/>
+                <a:ea typeface="Helvetica Neue"/>
+                <a:cs typeface="Helvetica Neue"/>
+              </a:rPr>
+              <a:t>B2B sales teams</a:t>
+            </a:r>
+          </a:p>
+          <a:p xmlns:a="http://schemas.openxmlformats.org/drawingml/2006/main">
+            <a:pPr>
+              <a:defRPr sz="2325" b="0">
+                <a:solidFill>
+                  <a:srgbClr val="FFFFFF"/>
+                </a:solidFill>
+                <a:latin typeface="Helvetica Neue"/>
+                <a:ea typeface="Helvetica Neue"/>
+                <a:cs typeface="Helvetica Neue"/>
+              </a:defRPr>
+            </a:pPr>
+            <a:r>
+              <a:rPr sz="2325" b="0">
+                <a:solidFill>
+                  <a:srgbClr val="FFFFFF"/>
+                </a:solidFill>
+                <a:latin typeface="Helvetica Neue"/>
+                <a:ea typeface="Helvetica Neue"/>
+                <a:cs typeface="Helvetica Neue"/>
+              </a:rPr>
+              <a:t>Agencies pitching clients</a:t>
+            </a:r>
+          </a:p>
+          <a:p xmlns:a="http://schemas.openxmlformats.org/drawingml/2006/main">
+            <a:pPr>
+              <a:defRPr sz="2325" b="0">
+                <a:solidFill>
+                  <a:srgbClr val="FFFFFF"/>
+                </a:solidFill>
+                <a:latin typeface="Helvetica Neue"/>
+                <a:ea typeface="Helvetica Neue"/>
+                <a:cs typeface="Helvetica Neue"/>
+              </a:defRPr>
+            </a:pPr>
+            <a:r>
+              <a:rPr sz="2325" b="0">
+                <a:solidFill>
+                  <a:srgbClr val="FFFFFF"/>
+                </a:solidFill>
+                <a:latin typeface="Helvetica Neue"/>
+                <a:ea typeface="Helvetica Neue"/>
+                <a:cs typeface="Helvetica Neue"/>
+              </a:rPr>
+              <a:t>Founders finding customers</a:t>
             </a:r>
           </a:p>
         </p:txBody>
@@ -2726,19 +2635,19 @@
           <p:cNvPr id="4" name="">
             <a:extLst xmlns:a="http://schemas.openxmlformats.org/drawingml/2006/main">
               <a:ext uri="{FF2B5EF4-FFF2-40B4-BE49-F238E27FC236}">
-                <a16:creationId xmlns:a16="http://schemas.microsoft.com/office/drawing/2014/main" id="{B8544FBD-D341-4D93-9A51-978E75A8A909}"/>
-              </a:ext>
-            </a:extLst>
-          </p:cNvPr>
-          <p:cNvSpPr>
-            <a:spLocks xmlns:a="http://schemas.openxmlformats.org/drawingml/2006/main" noGrp="1"/>
-          </p:cNvSpPr>
-          <p:nvPr/>
-        </p:nvSpPr>
-        <p:spPr>
-          <a:xfrm xmlns:a="http://schemas.openxmlformats.org/drawingml/2006/main">
-            <a:off x="7296150" y="3543300"/>
-            <a:ext cx="4162425" cy="1581150"/>
+                <a16:creationId xmlns:a16="http://schemas.microsoft.com/office/drawing/2014/main" id="{055AE6E6-C662-4637-8138-3EBC08F24CFF}"/>
+              </a:ext>
+            </a:extLst>
+          </p:cNvPr>
+          <p:cNvSpPr>
+            <a:spLocks xmlns:a="http://schemas.openxmlformats.org/drawingml/2006/main" noGrp="1"/>
+          </p:cNvSpPr>
+          <p:nvPr/>
+        </p:nvSpPr>
+        <p:spPr>
+          <a:xfrm xmlns:a="http://schemas.openxmlformats.org/drawingml/2006/main">
+            <a:off x="6400800" y="1866900"/>
+            <a:ext cx="5143500" cy="495300"/>
           </a:xfrm>
           <a:prstGeom xmlns:a="http://schemas.openxmlformats.org/drawingml/2006/main" prst="rect">
             <a:avLst/>
@@ -2755,25 +2664,25 @@
           <a:lstStyle xmlns:a="http://schemas.openxmlformats.org/drawingml/2006/main"/>
           <a:p xmlns:a="http://schemas.openxmlformats.org/drawingml/2006/main">
             <a:pPr>
-              <a:defRPr sz="2025" b="0">
-                <a:solidFill>
-                  <a:srgbClr val="FFFFFF"/>
-                </a:solidFill>
-                <a:latin typeface="Helvetica Neue"/>
-                <a:ea typeface="Helvetica Neue"/>
-                <a:cs typeface="Helvetica Neue"/>
-              </a:defRPr>
-            </a:pPr>
-            <a:r>
-              <a:rPr sz="2025" b="0">
-                <a:solidFill>
-                  <a:srgbClr val="FFFFFF"/>
-                </a:solidFill>
-                <a:latin typeface="Helvetica Neue"/>
-                <a:ea typeface="Helvetica Neue"/>
-                <a:cs typeface="Helvetica Neue"/>
-              </a:rPr>
-              <a:t>Each conversation angle separates the source claim from a conditional hypothesis and a question to validate it.</a:t>
+              <a:defRPr sz="2175" b="1">
+                <a:solidFill>
+                  <a:srgbClr val="63D7F2"/>
+                </a:solidFill>
+                <a:latin typeface="Helvetica Neue"/>
+                <a:ea typeface="Helvetica Neue"/>
+                <a:cs typeface="Helvetica Neue"/>
+              </a:defRPr>
+            </a:pPr>
+            <a:r>
+              <a:rPr sz="2175" b="1">
+                <a:solidFill>
+                  <a:srgbClr val="63D7F2"/>
+                </a:solidFill>
+                <a:latin typeface="Helvetica Neue"/>
+                <a:ea typeface="Helvetica Neue"/>
+                <a:cs typeface="Helvetica Neue"/>
+              </a:rPr>
+              <a:t>Before the conversation</a:t>
             </a:r>
           </a:p>
         </p:txBody>
@@ -2783,19 +2692,19 @@
           <p:cNvPr id="5" name="">
             <a:extLst xmlns:a="http://schemas.openxmlformats.org/drawingml/2006/main">
               <a:ext uri="{FF2B5EF4-FFF2-40B4-BE49-F238E27FC236}">
-                <a16:creationId xmlns:a16="http://schemas.microsoft.com/office/drawing/2014/main" id="{C00D9211-B45E-466D-8186-F28C185BD2AE}"/>
-              </a:ext>
-            </a:extLst>
-          </p:cNvPr>
-          <p:cNvSpPr>
-            <a:spLocks xmlns:a="http://schemas.openxmlformats.org/drawingml/2006/main" noGrp="1"/>
-          </p:cNvSpPr>
-          <p:nvPr/>
-        </p:nvSpPr>
-        <p:spPr>
-          <a:xfrm xmlns:a="http://schemas.openxmlformats.org/drawingml/2006/main">
-            <a:off x="590550" y="5819775"/>
-            <a:ext cx="10848975" cy="609600"/>
+                <a16:creationId xmlns:a16="http://schemas.microsoft.com/office/drawing/2014/main" id="{C7753819-FFAA-43A4-A358-F536BC71FE87}"/>
+              </a:ext>
+            </a:extLst>
+          </p:cNvPr>
+          <p:cNvSpPr>
+            <a:spLocks xmlns:a="http://schemas.openxmlformats.org/drawingml/2006/main" noGrp="1"/>
+          </p:cNvSpPr>
+          <p:nvPr/>
+        </p:nvSpPr>
+        <p:spPr>
+          <a:xfrm xmlns:a="http://schemas.openxmlformats.org/drawingml/2006/main">
+            <a:off x="6400800" y="2590800"/>
+            <a:ext cx="5143500" cy="2028825"/>
           </a:xfrm>
           <a:prstGeom xmlns:a="http://schemas.openxmlformats.org/drawingml/2006/main" prst="rect">
             <a:avLst/>
@@ -2812,7 +2721,7 @@
           <a:lstStyle xmlns:a="http://schemas.openxmlformats.org/drawingml/2006/main"/>
           <a:p xmlns:a="http://schemas.openxmlformats.org/drawingml/2006/main">
             <a:pPr>
-              <a:defRPr sz="2100" b="0">
+              <a:defRPr sz="2325" b="0">
                 <a:solidFill>
                   <a:srgbClr val="FFFFFF"/>
                 </a:solidFill>
@@ -2822,7 +2731,7 @@
               </a:defRPr>
             </a:pPr>
             <a:r>
-              <a:rPr sz="2100" b="0">
+              <a:rPr sz="2325" b="0">
                 <a:solidFill>
                   <a:srgbClr val="FFFFFF"/>
                 </a:solidFill>
@@ -2830,7 +2739,167 @@
                 <a:ea typeface="Helvetica Neue"/>
                 <a:cs typeface="Helvetica Neue"/>
               </a:rPr>
-              <a:t>For B2B sales teams, agencies, and founders doing their own sales.</a:t>
+              <a:t>What is sourced?</a:t>
+            </a:r>
+          </a:p>
+          <a:p xmlns:a="http://schemas.openxmlformats.org/drawingml/2006/main">
+            <a:pPr>
+              <a:defRPr sz="2325" b="0">
+                <a:solidFill>
+                  <a:srgbClr val="FFFFFF"/>
+                </a:solidFill>
+                <a:latin typeface="Helvetica Neue"/>
+                <a:ea typeface="Helvetica Neue"/>
+                <a:cs typeface="Helvetica Neue"/>
+              </a:defRPr>
+            </a:pPr>
+            <a:r>
+              <a:rPr sz="2325" b="0">
+                <a:solidFill>
+                  <a:srgbClr val="FFFFFF"/>
+                </a:solidFill>
+                <a:latin typeface="Helvetica Neue"/>
+                <a:ea typeface="Helvetica Neue"/>
+                <a:cs typeface="Helvetica Neue"/>
+              </a:rPr>
+              <a:t>What is inferred?</a:t>
+            </a:r>
+          </a:p>
+          <a:p xmlns:a="http://schemas.openxmlformats.org/drawingml/2006/main">
+            <a:pPr>
+              <a:defRPr sz="2325" b="0">
+                <a:solidFill>
+                  <a:srgbClr val="FFFFFF"/>
+                </a:solidFill>
+                <a:latin typeface="Helvetica Neue"/>
+                <a:ea typeface="Helvetica Neue"/>
+                <a:cs typeface="Helvetica Neue"/>
+              </a:defRPr>
+            </a:pPr>
+            <a:r>
+              <a:rPr sz="2325" b="0">
+                <a:solidFill>
+                  <a:srgbClr val="FFFFFF"/>
+                </a:solidFill>
+                <a:latin typeface="Helvetica Neue"/>
+                <a:ea typeface="Helvetica Neue"/>
+                <a:cs typeface="Helvetica Neue"/>
+              </a:rPr>
+              <a:t>What should I ask?</a:t>
+            </a:r>
+          </a:p>
+        </p:txBody>
+      </p:sp>
+      <p:sp>
+        <p:nvSpPr>
+          <p:cNvPr id="6" name="">
+            <a:extLst xmlns:a="http://schemas.openxmlformats.org/drawingml/2006/main">
+              <a:ext uri="{FF2B5EF4-FFF2-40B4-BE49-F238E27FC236}">
+                <a16:creationId xmlns:a16="http://schemas.microsoft.com/office/drawing/2014/main" id="{2B798C74-91A6-4A30-B5C8-2BD21D6A9F3B}"/>
+              </a:ext>
+            </a:extLst>
+          </p:cNvPr>
+          <p:cNvSpPr>
+            <a:spLocks xmlns:a="http://schemas.openxmlformats.org/drawingml/2006/main" noGrp="1"/>
+          </p:cNvSpPr>
+          <p:nvPr/>
+        </p:nvSpPr>
+        <p:spPr>
+          <a:xfrm xmlns:a="http://schemas.openxmlformats.org/drawingml/2006/main">
+            <a:off x="657225" y="5267325"/>
+            <a:ext cx="10896600" cy="466725"/>
+          </a:xfrm>
+          <a:prstGeom xmlns:a="http://schemas.openxmlformats.org/drawingml/2006/main" prst="rect">
+            <a:avLst/>
+          </a:prstGeom>
+          <a:noFill xmlns:a="http://schemas.openxmlformats.org/drawingml/2006/main"/>
+          <a:ln xmlns:a="http://schemas.openxmlformats.org/drawingml/2006/main" w="0">
+            <a:noFill/>
+          </a:ln>
+        </p:spPr>
+        <p:txBody>
+          <a:bodyPr xmlns:a="http://schemas.openxmlformats.org/drawingml/2006/main">
+            <a:noAutofit/>
+          </a:bodyPr>
+          <a:lstStyle xmlns:a="http://schemas.openxmlformats.org/drawingml/2006/main"/>
+          <a:p xmlns:a="http://schemas.openxmlformats.org/drawingml/2006/main">
+            <a:pPr>
+              <a:defRPr sz="2325" b="1">
+                <a:solidFill>
+                  <a:srgbClr val="FFFFFF"/>
+                </a:solidFill>
+                <a:latin typeface="Helvetica Neue"/>
+                <a:ea typeface="Helvetica Neue"/>
+                <a:cs typeface="Helvetica Neue"/>
+              </a:defRPr>
+            </a:pPr>
+            <a:r>
+              <a:rPr sz="2325" b="1">
+                <a:solidFill>
+                  <a:srgbClr val="FFFFFF"/>
+                </a:solidFill>
+                <a:latin typeface="Helvetica Neue"/>
+                <a:ea typeface="Helvetica Neue"/>
+                <a:cs typeface="Helvetica Neue"/>
+              </a:rPr>
+              <a:t>Each angle connects a public claim to your offer.</a:t>
+            </a:r>
+          </a:p>
+        </p:txBody>
+      </p:sp>
+      <p:sp>
+        <p:nvSpPr>
+          <p:cNvPr id="7" name="">
+            <a:extLst xmlns:a="http://schemas.openxmlformats.org/drawingml/2006/main">
+              <a:ext uri="{FF2B5EF4-FFF2-40B4-BE49-F238E27FC236}">
+                <a16:creationId xmlns:a16="http://schemas.microsoft.com/office/drawing/2014/main" id="{B5D43C3C-7F7E-4BD6-A80E-D95EFC98C1D1}"/>
+              </a:ext>
+            </a:extLst>
+          </p:cNvPr>
+          <p:cNvSpPr>
+            <a:spLocks xmlns:a="http://schemas.openxmlformats.org/drawingml/2006/main" noGrp="1"/>
+          </p:cNvSpPr>
+          <p:nvPr/>
+        </p:nvSpPr>
+        <p:spPr>
+          <a:xfrm xmlns:a="http://schemas.openxmlformats.org/drawingml/2006/main">
+            <a:off x="657225" y="5905500"/>
+            <a:ext cx="10896600" cy="514350"/>
+          </a:xfrm>
+          <a:prstGeom xmlns:a="http://schemas.openxmlformats.org/drawingml/2006/main" prst="rect">
+            <a:avLst/>
+          </a:prstGeom>
+          <a:noFill xmlns:a="http://schemas.openxmlformats.org/drawingml/2006/main"/>
+          <a:ln xmlns:a="http://schemas.openxmlformats.org/drawingml/2006/main" w="0">
+            <a:noFill/>
+          </a:ln>
+        </p:spPr>
+        <p:txBody>
+          <a:bodyPr xmlns:a="http://schemas.openxmlformats.org/drawingml/2006/main">
+            <a:noAutofit/>
+          </a:bodyPr>
+          <a:lstStyle xmlns:a="http://schemas.openxmlformats.org/drawingml/2006/main"/>
+          <a:p xmlns:a="http://schemas.openxmlformats.org/drawingml/2006/main">
+            <a:pPr>
+              <a:defRPr sz="2025" b="0">
+                <a:solidFill>
+                  <a:srgbClr val="63D7F2"/>
+                </a:solidFill>
+                <a:latin typeface="Helvetica Neue"/>
+                <a:ea typeface="Helvetica Neue"/>
+                <a:cs typeface="Helvetica Neue"/>
+              </a:defRPr>
+            </a:pPr>
+            <a:r>
+              <a:rPr sz="2025" b="0">
+                <a:solidFill>
+                  <a:srgbClr val="63D7F2"/>
+                </a:solidFill>
+                <a:latin typeface="Helvetica Neue"/>
+                <a:ea typeface="Helvetica Neue"/>
+                <a:cs typeface="Helvetica Neue"/>
+              </a:rPr>
+              <a:t>A hypothesis explains the possible fit. A question helps you test it.</a:t>
             </a:r>
           </a:p>
         </p:txBody>
@@ -2838,7 +2907,7 @@
     </p:spTree>
     <p:extLst>
       <p:ext uri="{BB962C8B-B14F-4D97-AF65-F5344CB8AC3E}">
-        <p14:creationId xmlns:p14="http://schemas.microsoft.com/office/powerpoint/2010/main" val="1395757029"/>
+        <p14:creationId xmlns:p14="http://schemas.microsoft.com/office/powerpoint/2010/main" val="30850842"/>
       </p:ext>
     </p:extLst>
   </p:cSld>
@@ -2869,7 +2938,7 @@
           <p:cNvPr id="7" name="">
             <a:extLst xmlns:a="http://schemas.openxmlformats.org/drawingml/2006/main">
               <a:ext uri="{FF2B5EF4-FFF2-40B4-BE49-F238E27FC236}">
-                <a16:creationId xmlns:a16="http://schemas.microsoft.com/office/drawing/2014/main" id="{9925181C-2A59-479E-8C0D-546FAB15135B}"/>
+                <a16:creationId xmlns:a16="http://schemas.microsoft.com/office/drawing/2014/main" id="{376A7CD5-AE24-457D-8835-636D35324B60}"/>
               </a:ext>
             </a:extLst>
           </p:cNvPr>
@@ -2949,7 +3018,7 @@
           <p:cNvPr id="2" name="">
             <a:extLst xmlns:a="http://schemas.openxmlformats.org/drawingml/2006/main">
               <a:ext uri="{FF2B5EF4-FFF2-40B4-BE49-F238E27FC236}">
-                <a16:creationId xmlns:a16="http://schemas.microsoft.com/office/drawing/2014/main" id="{3060ACB6-5934-4EED-A9FE-CF23AB1E9EAF}"/>
+                <a16:creationId xmlns:a16="http://schemas.microsoft.com/office/drawing/2014/main" id="{C7C5DDAC-5FD2-45AA-9A4B-0F2FC99DA4A6}"/>
               </a:ext>
             </a:extLst>
           </p:cNvPr>
@@ -3006,7 +3075,7 @@
           <p:cNvPr id="3" name="">
             <a:extLst xmlns:a="http://schemas.openxmlformats.org/drawingml/2006/main">
               <a:ext uri="{FF2B5EF4-FFF2-40B4-BE49-F238E27FC236}">
-                <a16:creationId xmlns:a16="http://schemas.microsoft.com/office/drawing/2014/main" id="{6B2C9B6B-0A16-46C9-A681-7EB62A0F8735}"/>
+                <a16:creationId xmlns:a16="http://schemas.microsoft.com/office/drawing/2014/main" id="{1BFFE550-10A4-48A0-B1D6-EAF2E7AAD0BA}"/>
               </a:ext>
             </a:extLst>
           </p:cNvPr>
@@ -3113,7 +3182,7 @@
           <p:nvPr/>
         </p:nvPicPr>
         <p:blipFill>
-          <a:blip xmlns:r="http://schemas.openxmlformats.org/officeDocument/2006/relationships" xmlns:a="http://schemas.openxmlformats.org/drawingml/2006/main" r:embed="R5f20e3b5e6be4a53"/>
+          <a:blip xmlns:r="http://schemas.openxmlformats.org/officeDocument/2006/relationships" xmlns:a="http://schemas.openxmlformats.org/drawingml/2006/main" r:embed="R1a30b88975eb4ebd"/>
           <a:stretch xmlns:a="http://schemas.openxmlformats.org/drawingml/2006/main"/>
         </p:blipFill>
         <p:spPr>
@@ -3131,7 +3200,7 @@
           <p:cNvPr id="5" name="">
             <a:extLst xmlns:a="http://schemas.openxmlformats.org/drawingml/2006/main">
               <a:ext uri="{FF2B5EF4-FFF2-40B4-BE49-F238E27FC236}">
-                <a16:creationId xmlns:a16="http://schemas.microsoft.com/office/drawing/2014/main" id="{9A285826-A06A-4775-B1B2-13B5993DD040}"/>
+                <a16:creationId xmlns:a16="http://schemas.microsoft.com/office/drawing/2014/main" id="{CEA9ECBC-C4EA-470F-9450-6D48B8708A56}"/>
               </a:ext>
             </a:extLst>
           </p:cNvPr>
@@ -3188,7 +3257,7 @@
           <p:cNvPr id="6" name="">
             <a:extLst xmlns:a="http://schemas.openxmlformats.org/drawingml/2006/main">
               <a:ext uri="{FF2B5EF4-FFF2-40B4-BE49-F238E27FC236}">
-                <a16:creationId xmlns:a16="http://schemas.microsoft.com/office/drawing/2014/main" id="{13148D17-C6D7-4916-81C6-24808E53E3EF}"/>
+                <a16:creationId xmlns:a16="http://schemas.microsoft.com/office/drawing/2014/main" id="{8D857EDA-26E0-4874-9FBA-6B3A1350C398}"/>
               </a:ext>
             </a:extLst>
           </p:cNvPr>
@@ -3243,7 +3312,7 @@
     </p:spTree>
     <p:extLst>
       <p:ext uri="{BB962C8B-B14F-4D97-AF65-F5344CB8AC3E}">
-        <p14:creationId xmlns:p14="http://schemas.microsoft.com/office/powerpoint/2010/main" val="1385834170"/>
+        <p14:creationId xmlns:p14="http://schemas.microsoft.com/office/powerpoint/2010/main" val="774352000"/>
       </p:ext>
     </p:extLst>
   </p:cSld>
@@ -3271,10 +3340,10 @@
       </p:grpSpPr>
       <p:sp>
         <p:nvSpPr>
-          <p:cNvPr id="27" name="">
-            <a:extLst xmlns:a="http://schemas.openxmlformats.org/drawingml/2006/main">
-              <a:ext uri="{FF2B5EF4-FFF2-40B4-BE49-F238E27FC236}">
-                <a16:creationId xmlns:a16="http://schemas.microsoft.com/office/drawing/2014/main" id="{C7321673-B03E-4E7C-A782-841F848E973D}"/>
+          <p:cNvPr id="22" name="">
+            <a:extLst xmlns:a="http://schemas.openxmlformats.org/drawingml/2006/main">
+              <a:ext uri="{FF2B5EF4-FFF2-40B4-BE49-F238E27FC236}">
+                <a16:creationId xmlns:a16="http://schemas.microsoft.com/office/drawing/2014/main" id="{BFFA76ED-4C20-479C-8414-8E5956C277E1}"/>
               </a:ext>
             </a:extLst>
           </p:cNvPr>
@@ -3331,7 +3400,7 @@
           <p:cNvPr id="2" name="">
             <a:extLst xmlns:a="http://schemas.openxmlformats.org/drawingml/2006/main">
               <a:ext uri="{FF2B5EF4-FFF2-40B4-BE49-F238E27FC236}">
-                <a16:creationId xmlns:a16="http://schemas.microsoft.com/office/drawing/2014/main" id="{C7BCE41E-2BCD-4221-8189-C0D43FE786C5}"/>
+                <a16:creationId xmlns:a16="http://schemas.microsoft.com/office/drawing/2014/main" id="{1DBA740A-126E-4E38-8F6E-08764A1FB9C9}"/>
               </a:ext>
             </a:extLst>
           </p:cNvPr>
@@ -3357,25 +3426,54 @@
             </a:solidFill>
           </a:ln>
         </p:spPr>
+        <p:txBody>
+          <a:bodyPr xmlns:a="http://schemas.openxmlformats.org/drawingml/2006/main" lIns="0" tIns="0" rIns="0" bIns="0" anchor="ctr">
+            <a:noAutofit/>
+          </a:bodyPr>
+          <a:lstStyle xmlns:a="http://schemas.openxmlformats.org/drawingml/2006/main"/>
+          <a:p xmlns:a="http://schemas.openxmlformats.org/drawingml/2006/main">
+            <a:pPr algn="ctr">
+              <a:defRPr sz="2775" b="1">
+                <a:solidFill>
+                  <a:srgbClr val="63D7F2"/>
+                </a:solidFill>
+                <a:latin typeface="Helvetica Neue"/>
+                <a:ea typeface="Helvetica Neue"/>
+                <a:cs typeface="Helvetica Neue"/>
+              </a:defRPr>
+            </a:pPr>
+            <a:r>
+              <a:rPr sz="2775" b="1">
+                <a:solidFill>
+                  <a:srgbClr val="63D7F2"/>
+                </a:solidFill>
+                <a:latin typeface="Helvetica Neue"/>
+                <a:ea typeface="Helvetica Neue"/>
+                <a:cs typeface="Helvetica Neue"/>
+              </a:rPr>
+              <a:t>01</a:t>
+            </a:r>
+          </a:p>
+        </p:txBody>
       </p:sp>
       <p:sp>
         <p:nvSpPr>
           <p:cNvPr id="3" name="">
             <a:extLst xmlns:a="http://schemas.openxmlformats.org/drawingml/2006/main">
               <a:ext uri="{FF2B5EF4-FFF2-40B4-BE49-F238E27FC236}">
-                <a16:creationId xmlns:a16="http://schemas.microsoft.com/office/drawing/2014/main" id="{5C2194A4-BBA5-4B9B-992A-19957DAFD697}"/>
-              </a:ext>
-            </a:extLst>
-          </p:cNvPr>
-          <p:cNvSpPr>
-            <a:spLocks xmlns:a="http://schemas.openxmlformats.org/drawingml/2006/main" noGrp="1"/>
-          </p:cNvSpPr>
-          <p:nvPr/>
-        </p:nvSpPr>
-        <p:spPr>
-          <a:xfrm xmlns:a="http://schemas.openxmlformats.org/drawingml/2006/main">
-            <a:off x="657225" y="2162175"/>
-            <a:ext cx="723900" cy="590550"/>
+                <a16:creationId xmlns:a16="http://schemas.microsoft.com/office/drawing/2014/main" id="{6F337BEA-8336-4B52-81F9-FD3181723A43}"/>
+              </a:ext>
+            </a:extLst>
+          </p:cNvPr>
+          <p:cNvSpPr>
+            <a:spLocks xmlns:a="http://schemas.openxmlformats.org/drawingml/2006/main" noGrp="1"/>
+          </p:cNvSpPr>
+          <p:nvPr/>
+        </p:nvSpPr>
+        <p:spPr>
+          <a:xfrm xmlns:a="http://schemas.openxmlformats.org/drawingml/2006/main">
+            <a:off x="561975" y="3324225"/>
+            <a:ext cx="2047875" cy="533400"/>
           </a:xfrm>
           <a:prstGeom xmlns:a="http://schemas.openxmlformats.org/drawingml/2006/main" prst="rect">
             <a:avLst/>
@@ -3392,25 +3490,25 @@
           <a:lstStyle xmlns:a="http://schemas.openxmlformats.org/drawingml/2006/main"/>
           <a:p xmlns:a="http://schemas.openxmlformats.org/drawingml/2006/main">
             <a:pPr>
-              <a:defRPr sz="2775" b="1">
-                <a:solidFill>
-                  <a:srgbClr val="63D7F2"/>
-                </a:solidFill>
-                <a:latin typeface="Helvetica Neue"/>
-                <a:ea typeface="Helvetica Neue"/>
-                <a:cs typeface="Helvetica Neue"/>
-              </a:defRPr>
-            </a:pPr>
-            <a:r>
-              <a:rPr sz="2775" b="1">
-                <a:solidFill>
-                  <a:srgbClr val="63D7F2"/>
-                </a:solidFill>
-                <a:latin typeface="Helvetica Neue"/>
-                <a:ea typeface="Helvetica Neue"/>
-                <a:cs typeface="Helvetica Neue"/>
-              </a:rPr>
-              <a:t>01</a:t>
+              <a:defRPr sz="2325" b="1">
+                <a:solidFill>
+                  <a:srgbClr val="FFFFFF"/>
+                </a:solidFill>
+                <a:latin typeface="Helvetica Neue"/>
+                <a:ea typeface="Helvetica Neue"/>
+                <a:cs typeface="Helvetica Neue"/>
+              </a:defRPr>
+            </a:pPr>
+            <a:r>
+              <a:rPr sz="2325" b="1">
+                <a:solidFill>
+                  <a:srgbClr val="FFFFFF"/>
+                </a:solidFill>
+                <a:latin typeface="Helvetica Neue"/>
+                <a:ea typeface="Helvetica Neue"/>
+                <a:cs typeface="Helvetica Neue"/>
+              </a:rPr>
+              <a:t>Context</a:t>
             </a:r>
           </a:p>
         </p:txBody>
@@ -3420,19 +3518,19 @@
           <p:cNvPr id="4" name="">
             <a:extLst xmlns:a="http://schemas.openxmlformats.org/drawingml/2006/main">
               <a:ext uri="{FF2B5EF4-FFF2-40B4-BE49-F238E27FC236}">
-                <a16:creationId xmlns:a16="http://schemas.microsoft.com/office/drawing/2014/main" id="{5092E990-655C-41CA-B54E-15BA4107E7F4}"/>
-              </a:ext>
-            </a:extLst>
-          </p:cNvPr>
-          <p:cNvSpPr>
-            <a:spLocks xmlns:a="http://schemas.openxmlformats.org/drawingml/2006/main" noGrp="1"/>
-          </p:cNvSpPr>
-          <p:nvPr/>
-        </p:nvSpPr>
-        <p:spPr>
-          <a:xfrm xmlns:a="http://schemas.openxmlformats.org/drawingml/2006/main">
-            <a:off x="561975" y="3324225"/>
-            <a:ext cx="2047875" cy="533400"/>
+                <a16:creationId xmlns:a16="http://schemas.microsoft.com/office/drawing/2014/main" id="{AF2A7377-D59A-4467-9DDC-57472307EF39}"/>
+              </a:ext>
+            </a:extLst>
+          </p:cNvPr>
+          <p:cNvSpPr>
+            <a:spLocks xmlns:a="http://schemas.openxmlformats.org/drawingml/2006/main" noGrp="1"/>
+          </p:cNvSpPr>
+          <p:nvPr/>
+        </p:nvSpPr>
+        <p:spPr>
+          <a:xfrm xmlns:a="http://schemas.openxmlformats.org/drawingml/2006/main">
+            <a:off x="561975" y="4048125"/>
+            <a:ext cx="2105025" cy="1133475"/>
           </a:xfrm>
           <a:prstGeom xmlns:a="http://schemas.openxmlformats.org/drawingml/2006/main" prst="rect">
             <a:avLst/>
@@ -3449,7 +3547,7 @@
           <a:lstStyle xmlns:a="http://schemas.openxmlformats.org/drawingml/2006/main"/>
           <a:p xmlns:a="http://schemas.openxmlformats.org/drawingml/2006/main">
             <a:pPr>
-              <a:defRPr sz="2325" b="1">
+              <a:defRPr sz="1950" b="0">
                 <a:solidFill>
                   <a:srgbClr val="FFFFFF"/>
                 </a:solidFill>
@@ -3459,7 +3557,7 @@
               </a:defRPr>
             </a:pPr>
             <a:r>
-              <a:rPr sz="2325" b="1">
+              <a:rPr sz="1950" b="0">
                 <a:solidFill>
                   <a:srgbClr val="FFFFFF"/>
                 </a:solidFill>
@@ -3467,7 +3565,30 @@
                 <a:ea typeface="Helvetica Neue"/>
                 <a:cs typeface="Helvetica Neue"/>
               </a:rPr>
-              <a:t>Context</a:t>
+              <a:t>Prospect, offer,</a:t>
+            </a:r>
+          </a:p>
+          <a:p xmlns:a="http://schemas.openxmlformats.org/drawingml/2006/main">
+            <a:pPr>
+              <a:defRPr sz="1950" b="0">
+                <a:solidFill>
+                  <a:srgbClr val="FFFFFF"/>
+                </a:solidFill>
+                <a:latin typeface="Helvetica Neue"/>
+                <a:ea typeface="Helvetica Neue"/>
+                <a:cs typeface="Helvetica Neue"/>
+              </a:defRPr>
+            </a:pPr>
+            <a:r>
+              <a:rPr sz="1950" b="0">
+                <a:solidFill>
+                  <a:srgbClr val="FFFFFF"/>
+                </a:solidFill>
+                <a:latin typeface="Helvetica Neue"/>
+                <a:ea typeface="Helvetica Neue"/>
+                <a:cs typeface="Helvetica Neue"/>
+              </a:rPr>
+              <a:t>and chosen goal</a:t>
             </a:r>
           </a:p>
         </p:txBody>
@@ -3477,87 +3598,7 @@
           <p:cNvPr id="5" name="">
             <a:extLst xmlns:a="http://schemas.openxmlformats.org/drawingml/2006/main">
               <a:ext uri="{FF2B5EF4-FFF2-40B4-BE49-F238E27FC236}">
-                <a16:creationId xmlns:a16="http://schemas.microsoft.com/office/drawing/2014/main" id="{24724A7E-A198-4423-AABB-ABE25C4EE467}"/>
-              </a:ext>
-            </a:extLst>
-          </p:cNvPr>
-          <p:cNvSpPr>
-            <a:spLocks xmlns:a="http://schemas.openxmlformats.org/drawingml/2006/main" noGrp="1"/>
-          </p:cNvSpPr>
-          <p:nvPr/>
-        </p:nvSpPr>
-        <p:spPr>
-          <a:xfrm xmlns:a="http://schemas.openxmlformats.org/drawingml/2006/main">
-            <a:off x="561975" y="4048125"/>
-            <a:ext cx="2105025" cy="1133475"/>
-          </a:xfrm>
-          <a:prstGeom xmlns:a="http://schemas.openxmlformats.org/drawingml/2006/main" prst="rect">
-            <a:avLst/>
-          </a:prstGeom>
-          <a:noFill xmlns:a="http://schemas.openxmlformats.org/drawingml/2006/main"/>
-          <a:ln xmlns:a="http://schemas.openxmlformats.org/drawingml/2006/main" w="0">
-            <a:noFill/>
-          </a:ln>
-        </p:spPr>
-        <p:txBody>
-          <a:bodyPr xmlns:a="http://schemas.openxmlformats.org/drawingml/2006/main">
-            <a:noAutofit/>
-          </a:bodyPr>
-          <a:lstStyle xmlns:a="http://schemas.openxmlformats.org/drawingml/2006/main"/>
-          <a:p xmlns:a="http://schemas.openxmlformats.org/drawingml/2006/main">
-            <a:pPr>
-              <a:defRPr sz="1950" b="0">
-                <a:solidFill>
-                  <a:srgbClr val="FFFFFF"/>
-                </a:solidFill>
-                <a:latin typeface="Helvetica Neue"/>
-                <a:ea typeface="Helvetica Neue"/>
-                <a:cs typeface="Helvetica Neue"/>
-              </a:defRPr>
-            </a:pPr>
-            <a:r>
-              <a:rPr sz="1950" b="0">
-                <a:solidFill>
-                  <a:srgbClr val="FFFFFF"/>
-                </a:solidFill>
-                <a:latin typeface="Helvetica Neue"/>
-                <a:ea typeface="Helvetica Neue"/>
-                <a:cs typeface="Helvetica Neue"/>
-              </a:rPr>
-              <a:t>Prospect, offer,</a:t>
-            </a:r>
-          </a:p>
-          <a:p xmlns:a="http://schemas.openxmlformats.org/drawingml/2006/main">
-            <a:pPr>
-              <a:defRPr sz="1950" b="0">
-                <a:solidFill>
-                  <a:srgbClr val="FFFFFF"/>
-                </a:solidFill>
-                <a:latin typeface="Helvetica Neue"/>
-                <a:ea typeface="Helvetica Neue"/>
-                <a:cs typeface="Helvetica Neue"/>
-              </a:defRPr>
-            </a:pPr>
-            <a:r>
-              <a:rPr sz="1950" b="0">
-                <a:solidFill>
-                  <a:srgbClr val="FFFFFF"/>
-                </a:solidFill>
-                <a:latin typeface="Helvetica Neue"/>
-                <a:ea typeface="Helvetica Neue"/>
-                <a:cs typeface="Helvetica Neue"/>
-              </a:rPr>
-              <a:t>and chosen goal</a:t>
-            </a:r>
-          </a:p>
-        </p:txBody>
-      </p:sp>
-      <p:sp>
-        <p:nvSpPr>
-          <p:cNvPr id="6" name="">
-            <a:extLst xmlns:a="http://schemas.openxmlformats.org/drawingml/2006/main">
-              <a:ext uri="{FF2B5EF4-FFF2-40B4-BE49-F238E27FC236}">
-                <a16:creationId xmlns:a16="http://schemas.microsoft.com/office/drawing/2014/main" id="{21B1ED6F-218A-440F-94DE-7577D703C0FD}"/>
+                <a16:creationId xmlns:a16="http://schemas.microsoft.com/office/drawing/2014/main" id="{309D132F-B9E6-454B-8D10-C62BC126D0F1}"/>
               </a:ext>
             </a:extLst>
           </p:cNvPr>
@@ -3583,25 +3624,54 @@
             </a:solidFill>
           </a:ln>
         </p:spPr>
-      </p:sp>
-      <p:sp>
-        <p:nvSpPr>
-          <p:cNvPr id="7" name="">
-            <a:extLst xmlns:a="http://schemas.openxmlformats.org/drawingml/2006/main">
-              <a:ext uri="{FF2B5EF4-FFF2-40B4-BE49-F238E27FC236}">
-                <a16:creationId xmlns:a16="http://schemas.microsoft.com/office/drawing/2014/main" id="{330ABE6B-65D5-4E03-AD4A-CD63C271E09C}"/>
-              </a:ext>
-            </a:extLst>
-          </p:cNvPr>
-          <p:cNvSpPr>
-            <a:spLocks xmlns:a="http://schemas.openxmlformats.org/drawingml/2006/main" noGrp="1"/>
-          </p:cNvSpPr>
-          <p:nvPr/>
-        </p:nvSpPr>
-        <p:spPr>
-          <a:xfrm xmlns:a="http://schemas.openxmlformats.org/drawingml/2006/main">
-            <a:off x="2886075" y="2162175"/>
-            <a:ext cx="723900" cy="590550"/>
+        <p:txBody>
+          <a:bodyPr xmlns:a="http://schemas.openxmlformats.org/drawingml/2006/main" lIns="0" tIns="0" rIns="0" bIns="0" anchor="ctr">
+            <a:noAutofit/>
+          </a:bodyPr>
+          <a:lstStyle xmlns:a="http://schemas.openxmlformats.org/drawingml/2006/main"/>
+          <a:p xmlns:a="http://schemas.openxmlformats.org/drawingml/2006/main">
+            <a:pPr algn="ctr">
+              <a:defRPr sz="2775" b="1">
+                <a:solidFill>
+                  <a:srgbClr val="63D7F2"/>
+                </a:solidFill>
+                <a:latin typeface="Helvetica Neue"/>
+                <a:ea typeface="Helvetica Neue"/>
+                <a:cs typeface="Helvetica Neue"/>
+              </a:defRPr>
+            </a:pPr>
+            <a:r>
+              <a:rPr sz="2775" b="1">
+                <a:solidFill>
+                  <a:srgbClr val="63D7F2"/>
+                </a:solidFill>
+                <a:latin typeface="Helvetica Neue"/>
+                <a:ea typeface="Helvetica Neue"/>
+                <a:cs typeface="Helvetica Neue"/>
+              </a:rPr>
+              <a:t>02</a:t>
+            </a:r>
+          </a:p>
+        </p:txBody>
+      </p:sp>
+      <p:sp>
+        <p:nvSpPr>
+          <p:cNvPr id="6" name="">
+            <a:extLst xmlns:a="http://schemas.openxmlformats.org/drawingml/2006/main">
+              <a:ext uri="{FF2B5EF4-FFF2-40B4-BE49-F238E27FC236}">
+                <a16:creationId xmlns:a16="http://schemas.microsoft.com/office/drawing/2014/main" id="{D663AE85-F261-44D8-AC0E-8BB9668898D0}"/>
+              </a:ext>
+            </a:extLst>
+          </p:cNvPr>
+          <p:cNvSpPr>
+            <a:spLocks xmlns:a="http://schemas.openxmlformats.org/drawingml/2006/main" noGrp="1"/>
+          </p:cNvSpPr>
+          <p:nvPr/>
+        </p:nvSpPr>
+        <p:spPr>
+          <a:xfrm xmlns:a="http://schemas.openxmlformats.org/drawingml/2006/main">
+            <a:off x="2790825" y="3324225"/>
+            <a:ext cx="2047875" cy="533400"/>
           </a:xfrm>
           <a:prstGeom xmlns:a="http://schemas.openxmlformats.org/drawingml/2006/main" prst="rect">
             <a:avLst/>
@@ -3618,47 +3688,47 @@
           <a:lstStyle xmlns:a="http://schemas.openxmlformats.org/drawingml/2006/main"/>
           <a:p xmlns:a="http://schemas.openxmlformats.org/drawingml/2006/main">
             <a:pPr>
-              <a:defRPr sz="2775" b="1">
-                <a:solidFill>
-                  <a:srgbClr val="63D7F2"/>
-                </a:solidFill>
-                <a:latin typeface="Helvetica Neue"/>
-                <a:ea typeface="Helvetica Neue"/>
-                <a:cs typeface="Helvetica Neue"/>
-              </a:defRPr>
-            </a:pPr>
-            <a:r>
-              <a:rPr sz="2775" b="1">
-                <a:solidFill>
-                  <a:srgbClr val="63D7F2"/>
-                </a:solidFill>
-                <a:latin typeface="Helvetica Neue"/>
-                <a:ea typeface="Helvetica Neue"/>
-                <a:cs typeface="Helvetica Neue"/>
-              </a:rPr>
-              <a:t>02</a:t>
-            </a:r>
-          </a:p>
-        </p:txBody>
-      </p:sp>
-      <p:sp>
-        <p:nvSpPr>
-          <p:cNvPr id="8" name="">
-            <a:extLst xmlns:a="http://schemas.openxmlformats.org/drawingml/2006/main">
-              <a:ext uri="{FF2B5EF4-FFF2-40B4-BE49-F238E27FC236}">
-                <a16:creationId xmlns:a16="http://schemas.microsoft.com/office/drawing/2014/main" id="{CA8F083F-23E0-4467-9624-B0D9FA91A7ED}"/>
-              </a:ext>
-            </a:extLst>
-          </p:cNvPr>
-          <p:cNvSpPr>
-            <a:spLocks xmlns:a="http://schemas.openxmlformats.org/drawingml/2006/main" noGrp="1"/>
-          </p:cNvSpPr>
-          <p:nvPr/>
-        </p:nvSpPr>
-        <p:spPr>
-          <a:xfrm xmlns:a="http://schemas.openxmlformats.org/drawingml/2006/main">
-            <a:off x="2790825" y="3324225"/>
-            <a:ext cx="2047875" cy="533400"/>
+              <a:defRPr sz="2325" b="1">
+                <a:solidFill>
+                  <a:srgbClr val="FFFFFF"/>
+                </a:solidFill>
+                <a:latin typeface="Helvetica Neue"/>
+                <a:ea typeface="Helvetica Neue"/>
+                <a:cs typeface="Helvetica Neue"/>
+              </a:defRPr>
+            </a:pPr>
+            <a:r>
+              <a:rPr sz="2325" b="1">
+                <a:solidFill>
+                  <a:srgbClr val="FFFFFF"/>
+                </a:solidFill>
+                <a:latin typeface="Helvetica Neue"/>
+                <a:ea typeface="Helvetica Neue"/>
+                <a:cs typeface="Helvetica Neue"/>
+              </a:rPr>
+              <a:t>Discovery</a:t>
+            </a:r>
+          </a:p>
+        </p:txBody>
+      </p:sp>
+      <p:sp>
+        <p:nvSpPr>
+          <p:cNvPr id="7" name="">
+            <a:extLst xmlns:a="http://schemas.openxmlformats.org/drawingml/2006/main">
+              <a:ext uri="{FF2B5EF4-FFF2-40B4-BE49-F238E27FC236}">
+                <a16:creationId xmlns:a16="http://schemas.microsoft.com/office/drawing/2014/main" id="{F41A3E4D-236D-40BD-88CB-C0329DDA4DD8}"/>
+              </a:ext>
+            </a:extLst>
+          </p:cNvPr>
+          <p:cNvSpPr>
+            <a:spLocks xmlns:a="http://schemas.openxmlformats.org/drawingml/2006/main" noGrp="1"/>
+          </p:cNvSpPr>
+          <p:nvPr/>
+        </p:nvSpPr>
+        <p:spPr>
+          <a:xfrm xmlns:a="http://schemas.openxmlformats.org/drawingml/2006/main">
+            <a:off x="2790825" y="4048125"/>
+            <a:ext cx="2105025" cy="1133475"/>
           </a:xfrm>
           <a:prstGeom xmlns:a="http://schemas.openxmlformats.org/drawingml/2006/main" prst="rect">
             <a:avLst/>
@@ -3675,63 +3745,6 @@
           <a:lstStyle xmlns:a="http://schemas.openxmlformats.org/drawingml/2006/main"/>
           <a:p xmlns:a="http://schemas.openxmlformats.org/drawingml/2006/main">
             <a:pPr>
-              <a:defRPr sz="2325" b="1">
-                <a:solidFill>
-                  <a:srgbClr val="FFFFFF"/>
-                </a:solidFill>
-                <a:latin typeface="Helvetica Neue"/>
-                <a:ea typeface="Helvetica Neue"/>
-                <a:cs typeface="Helvetica Neue"/>
-              </a:defRPr>
-            </a:pPr>
-            <a:r>
-              <a:rPr sz="2325" b="1">
-                <a:solidFill>
-                  <a:srgbClr val="FFFFFF"/>
-                </a:solidFill>
-                <a:latin typeface="Helvetica Neue"/>
-                <a:ea typeface="Helvetica Neue"/>
-                <a:cs typeface="Helvetica Neue"/>
-              </a:rPr>
-              <a:t>Discovery</a:t>
-            </a:r>
-          </a:p>
-        </p:txBody>
-      </p:sp>
-      <p:sp>
-        <p:nvSpPr>
-          <p:cNvPr id="9" name="">
-            <a:extLst xmlns:a="http://schemas.openxmlformats.org/drawingml/2006/main">
-              <a:ext uri="{FF2B5EF4-FFF2-40B4-BE49-F238E27FC236}">
-                <a16:creationId xmlns:a16="http://schemas.microsoft.com/office/drawing/2014/main" id="{EF0EB84D-6BA4-4FBC-A0AA-1BFC59DC36F7}"/>
-              </a:ext>
-            </a:extLst>
-          </p:cNvPr>
-          <p:cNvSpPr>
-            <a:spLocks xmlns:a="http://schemas.openxmlformats.org/drawingml/2006/main" noGrp="1"/>
-          </p:cNvSpPr>
-          <p:nvPr/>
-        </p:nvSpPr>
-        <p:spPr>
-          <a:xfrm xmlns:a="http://schemas.openxmlformats.org/drawingml/2006/main">
-            <a:off x="2790825" y="4048125"/>
-            <a:ext cx="2105025" cy="1133475"/>
-          </a:xfrm>
-          <a:prstGeom xmlns:a="http://schemas.openxmlformats.org/drawingml/2006/main" prst="rect">
-            <a:avLst/>
-          </a:prstGeom>
-          <a:noFill xmlns:a="http://schemas.openxmlformats.org/drawingml/2006/main"/>
-          <a:ln xmlns:a="http://schemas.openxmlformats.org/drawingml/2006/main" w="0">
-            <a:noFill/>
-          </a:ln>
-        </p:spPr>
-        <p:txBody>
-          <a:bodyPr xmlns:a="http://schemas.openxmlformats.org/drawingml/2006/main">
-            <a:noAutofit/>
-          </a:bodyPr>
-          <a:lstStyle xmlns:a="http://schemas.openxmlformats.org/drawingml/2006/main"/>
-          <a:p xmlns:a="http://schemas.openxmlformats.org/drawingml/2006/main">
-            <a:pPr>
               <a:defRPr sz="1950" b="0">
                 <a:solidFill>
                   <a:srgbClr val="FFFFFF"/>
@@ -3780,10 +3793,10 @@
       </p:sp>
       <p:cxnSp>
         <p:nvCxnSpPr>
-          <p:cNvPr id="36" name=""/>
+          <p:cNvPr id="29" name=""/>
           <p:cNvCxnSpPr>
             <a:stCxn xmlns:a="http://schemas.openxmlformats.org/drawingml/2006/main" id="2" idx="6"/>
-            <a:endCxn xmlns:a="http://schemas.openxmlformats.org/drawingml/2006/main" id="6" idx="2"/>
+            <a:endCxn xmlns:a="http://schemas.openxmlformats.org/drawingml/2006/main" id="5" idx="2"/>
           </p:cNvCxnSpPr>
           <p:nvPr/>
         </p:nvCxnSpPr>
@@ -3805,10 +3818,10 @@
       </p:cxnSp>
       <p:sp>
         <p:nvSpPr>
-          <p:cNvPr id="11" name="">
-            <a:extLst xmlns:a="http://schemas.openxmlformats.org/drawingml/2006/main">
-              <a:ext uri="{FF2B5EF4-FFF2-40B4-BE49-F238E27FC236}">
-                <a16:creationId xmlns:a16="http://schemas.microsoft.com/office/drawing/2014/main" id="{AE976B38-393F-49F2-A52D-9ED75521051B}"/>
+          <p:cNvPr id="9" name="">
+            <a:extLst xmlns:a="http://schemas.openxmlformats.org/drawingml/2006/main">
+              <a:ext uri="{FF2B5EF4-FFF2-40B4-BE49-F238E27FC236}">
+                <a16:creationId xmlns:a16="http://schemas.microsoft.com/office/drawing/2014/main" id="{C954254D-395A-4390-A6AB-D1392E86BA11}"/>
               </a:ext>
             </a:extLst>
           </p:cNvPr>
@@ -3834,25 +3847,54 @@
             </a:solidFill>
           </a:ln>
         </p:spPr>
-      </p:sp>
-      <p:sp>
-        <p:nvSpPr>
-          <p:cNvPr id="12" name="">
-            <a:extLst xmlns:a="http://schemas.openxmlformats.org/drawingml/2006/main">
-              <a:ext uri="{FF2B5EF4-FFF2-40B4-BE49-F238E27FC236}">
-                <a16:creationId xmlns:a16="http://schemas.microsoft.com/office/drawing/2014/main" id="{4B7713D1-88E2-44C5-896C-0976AD23D23D}"/>
-              </a:ext>
-            </a:extLst>
-          </p:cNvPr>
-          <p:cNvSpPr>
-            <a:spLocks xmlns:a="http://schemas.openxmlformats.org/drawingml/2006/main" noGrp="1"/>
-          </p:cNvSpPr>
-          <p:nvPr/>
-        </p:nvSpPr>
-        <p:spPr>
-          <a:xfrm xmlns:a="http://schemas.openxmlformats.org/drawingml/2006/main">
-            <a:off x="5114925" y="2162175"/>
-            <a:ext cx="723900" cy="590550"/>
+        <p:txBody>
+          <a:bodyPr xmlns:a="http://schemas.openxmlformats.org/drawingml/2006/main" lIns="0" tIns="0" rIns="0" bIns="0" anchor="ctr">
+            <a:noAutofit/>
+          </a:bodyPr>
+          <a:lstStyle xmlns:a="http://schemas.openxmlformats.org/drawingml/2006/main"/>
+          <a:p xmlns:a="http://schemas.openxmlformats.org/drawingml/2006/main">
+            <a:pPr algn="ctr">
+              <a:defRPr sz="2775" b="1">
+                <a:solidFill>
+                  <a:srgbClr val="63D7F2"/>
+                </a:solidFill>
+                <a:latin typeface="Helvetica Neue"/>
+                <a:ea typeface="Helvetica Neue"/>
+                <a:cs typeface="Helvetica Neue"/>
+              </a:defRPr>
+            </a:pPr>
+            <a:r>
+              <a:rPr sz="2775" b="1">
+                <a:solidFill>
+                  <a:srgbClr val="63D7F2"/>
+                </a:solidFill>
+                <a:latin typeface="Helvetica Neue"/>
+                <a:ea typeface="Helvetica Neue"/>
+                <a:cs typeface="Helvetica Neue"/>
+              </a:rPr>
+              <a:t>03</a:t>
+            </a:r>
+          </a:p>
+        </p:txBody>
+      </p:sp>
+      <p:sp>
+        <p:nvSpPr>
+          <p:cNvPr id="10" name="">
+            <a:extLst xmlns:a="http://schemas.openxmlformats.org/drawingml/2006/main">
+              <a:ext uri="{FF2B5EF4-FFF2-40B4-BE49-F238E27FC236}">
+                <a16:creationId xmlns:a16="http://schemas.microsoft.com/office/drawing/2014/main" id="{D78DAD8B-1FCA-48A5-B16C-E37F9232ACAE}"/>
+              </a:ext>
+            </a:extLst>
+          </p:cNvPr>
+          <p:cNvSpPr>
+            <a:spLocks xmlns:a="http://schemas.openxmlformats.org/drawingml/2006/main" noGrp="1"/>
+          </p:cNvSpPr>
+          <p:nvPr/>
+        </p:nvSpPr>
+        <p:spPr>
+          <a:xfrm xmlns:a="http://schemas.openxmlformats.org/drawingml/2006/main">
+            <a:off x="5019675" y="3324225"/>
+            <a:ext cx="2047875" cy="533400"/>
           </a:xfrm>
           <a:prstGeom xmlns:a="http://schemas.openxmlformats.org/drawingml/2006/main" prst="rect">
             <a:avLst/>
@@ -3869,47 +3911,47 @@
           <a:lstStyle xmlns:a="http://schemas.openxmlformats.org/drawingml/2006/main"/>
           <a:p xmlns:a="http://schemas.openxmlformats.org/drawingml/2006/main">
             <a:pPr>
-              <a:defRPr sz="2775" b="1">
-                <a:solidFill>
-                  <a:srgbClr val="63D7F2"/>
-                </a:solidFill>
-                <a:latin typeface="Helvetica Neue"/>
-                <a:ea typeface="Helvetica Neue"/>
-                <a:cs typeface="Helvetica Neue"/>
-              </a:defRPr>
-            </a:pPr>
-            <a:r>
-              <a:rPr sz="2775" b="1">
-                <a:solidFill>
-                  <a:srgbClr val="63D7F2"/>
-                </a:solidFill>
-                <a:latin typeface="Helvetica Neue"/>
-                <a:ea typeface="Helvetica Neue"/>
-                <a:cs typeface="Helvetica Neue"/>
-              </a:rPr>
-              <a:t>03</a:t>
-            </a:r>
-          </a:p>
-        </p:txBody>
-      </p:sp>
-      <p:sp>
-        <p:nvSpPr>
-          <p:cNvPr id="13" name="">
-            <a:extLst xmlns:a="http://schemas.openxmlformats.org/drawingml/2006/main">
-              <a:ext uri="{FF2B5EF4-FFF2-40B4-BE49-F238E27FC236}">
-                <a16:creationId xmlns:a16="http://schemas.microsoft.com/office/drawing/2014/main" id="{57727B57-F7A5-4A4A-9EE8-B4094285E936}"/>
-              </a:ext>
-            </a:extLst>
-          </p:cNvPr>
-          <p:cNvSpPr>
-            <a:spLocks xmlns:a="http://schemas.openxmlformats.org/drawingml/2006/main" noGrp="1"/>
-          </p:cNvSpPr>
-          <p:nvPr/>
-        </p:nvSpPr>
-        <p:spPr>
-          <a:xfrm xmlns:a="http://schemas.openxmlformats.org/drawingml/2006/main">
-            <a:off x="5019675" y="3324225"/>
-            <a:ext cx="2047875" cy="533400"/>
+              <a:defRPr sz="2325" b="1">
+                <a:solidFill>
+                  <a:srgbClr val="FFFFFF"/>
+                </a:solidFill>
+                <a:latin typeface="Helvetica Neue"/>
+                <a:ea typeface="Helvetica Neue"/>
+                <a:cs typeface="Helvetica Neue"/>
+              </a:defRPr>
+            </a:pPr>
+            <a:r>
+              <a:rPr sz="2325" b="1">
+                <a:solidFill>
+                  <a:srgbClr val="FFFFFF"/>
+                </a:solidFill>
+                <a:latin typeface="Helvetica Neue"/>
+                <a:ea typeface="Helvetica Neue"/>
+                <a:cs typeface="Helvetica Neue"/>
+              </a:rPr>
+              <a:t>Evidence</a:t>
+            </a:r>
+          </a:p>
+        </p:txBody>
+      </p:sp>
+      <p:sp>
+        <p:nvSpPr>
+          <p:cNvPr id="11" name="">
+            <a:extLst xmlns:a="http://schemas.openxmlformats.org/drawingml/2006/main">
+              <a:ext uri="{FF2B5EF4-FFF2-40B4-BE49-F238E27FC236}">
+                <a16:creationId xmlns:a16="http://schemas.microsoft.com/office/drawing/2014/main" id="{4D81DF86-28A2-4C8C-8923-81175DC551AF}"/>
+              </a:ext>
+            </a:extLst>
+          </p:cNvPr>
+          <p:cNvSpPr>
+            <a:spLocks xmlns:a="http://schemas.openxmlformats.org/drawingml/2006/main" noGrp="1"/>
+          </p:cNvSpPr>
+          <p:nvPr/>
+        </p:nvSpPr>
+        <p:spPr>
+          <a:xfrm xmlns:a="http://schemas.openxmlformats.org/drawingml/2006/main">
+            <a:off x="5019675" y="4048125"/>
+            <a:ext cx="2105025" cy="1133475"/>
           </a:xfrm>
           <a:prstGeom xmlns:a="http://schemas.openxmlformats.org/drawingml/2006/main" prst="rect">
             <a:avLst/>
@@ -3926,7 +3968,7 @@
           <a:lstStyle xmlns:a="http://schemas.openxmlformats.org/drawingml/2006/main"/>
           <a:p xmlns:a="http://schemas.openxmlformats.org/drawingml/2006/main">
             <a:pPr>
-              <a:defRPr sz="2325" b="1">
+              <a:defRPr sz="1950" b="0">
                 <a:solidFill>
                   <a:srgbClr val="FFFFFF"/>
                 </a:solidFill>
@@ -3936,7 +3978,7 @@
               </a:defRPr>
             </a:pPr>
             <a:r>
-              <a:rPr sz="2325" b="1">
+              <a:rPr sz="1950" b="0">
                 <a:solidFill>
                   <a:srgbClr val="FFFFFF"/>
                 </a:solidFill>
@@ -3944,64 +3986,7 @@
                 <a:ea typeface="Helvetica Neue"/>
                 <a:cs typeface="Helvetica Neue"/>
               </a:rPr>
-              <a:t>Evidence</a:t>
-            </a:r>
-          </a:p>
-        </p:txBody>
-      </p:sp>
-      <p:sp>
-        <p:nvSpPr>
-          <p:cNvPr id="14" name="">
-            <a:extLst xmlns:a="http://schemas.openxmlformats.org/drawingml/2006/main">
-              <a:ext uri="{FF2B5EF4-FFF2-40B4-BE49-F238E27FC236}">
-                <a16:creationId xmlns:a16="http://schemas.microsoft.com/office/drawing/2014/main" id="{E4DC7E5D-0147-470A-BEDB-601BF455388A}"/>
-              </a:ext>
-            </a:extLst>
-          </p:cNvPr>
-          <p:cNvSpPr>
-            <a:spLocks xmlns:a="http://schemas.openxmlformats.org/drawingml/2006/main" noGrp="1"/>
-          </p:cNvSpPr>
-          <p:nvPr/>
-        </p:nvSpPr>
-        <p:spPr>
-          <a:xfrm xmlns:a="http://schemas.openxmlformats.org/drawingml/2006/main">
-            <a:off x="5019675" y="4048125"/>
-            <a:ext cx="2105025" cy="1133475"/>
-          </a:xfrm>
-          <a:prstGeom xmlns:a="http://schemas.openxmlformats.org/drawingml/2006/main" prst="rect">
-            <a:avLst/>
-          </a:prstGeom>
-          <a:noFill xmlns:a="http://schemas.openxmlformats.org/drawingml/2006/main"/>
-          <a:ln xmlns:a="http://schemas.openxmlformats.org/drawingml/2006/main" w="0">
-            <a:noFill/>
-          </a:ln>
-        </p:spPr>
-        <p:txBody>
-          <a:bodyPr xmlns:a="http://schemas.openxmlformats.org/drawingml/2006/main">
-            <a:noAutofit/>
-          </a:bodyPr>
-          <a:lstStyle xmlns:a="http://schemas.openxmlformats.org/drawingml/2006/main"/>
-          <a:p xmlns:a="http://schemas.openxmlformats.org/drawingml/2006/main">
-            <a:pPr>
-              <a:defRPr sz="1950" b="0">
-                <a:solidFill>
-                  <a:srgbClr val="FFFFFF"/>
-                </a:solidFill>
-                <a:latin typeface="Helvetica Neue"/>
-                <a:ea typeface="Helvetica Neue"/>
-                <a:cs typeface="Helvetica Neue"/>
-              </a:defRPr>
-            </a:pPr>
-            <a:r>
-              <a:rPr sz="1950" b="0">
-                <a:solidFill>
-                  <a:srgbClr val="FFFFFF"/>
-                </a:solidFill>
-                <a:latin typeface="Helvetica Neue"/>
-                <a:ea typeface="Helvetica Neue"/>
-                <a:cs typeface="Helvetica Neue"/>
-              </a:rPr>
-              <a:t>Stored claims with</a:t>
+              <a:t>Claims with</a:t>
             </a:r>
           </a:p>
           <a:p xmlns:a="http://schemas.openxmlformats.org/drawingml/2006/main">
@@ -4031,10 +4016,10 @@
       </p:sp>
       <p:cxnSp>
         <p:nvCxnSpPr>
-          <p:cNvPr id="41" name=""/>
+          <p:cNvPr id="33" name=""/>
           <p:cNvCxnSpPr>
-            <a:stCxn xmlns:a="http://schemas.openxmlformats.org/drawingml/2006/main" id="6" idx="6"/>
-            <a:endCxn xmlns:a="http://schemas.openxmlformats.org/drawingml/2006/main" id="11" idx="2"/>
+            <a:stCxn xmlns:a="http://schemas.openxmlformats.org/drawingml/2006/main" id="5" idx="6"/>
+            <a:endCxn xmlns:a="http://schemas.openxmlformats.org/drawingml/2006/main" id="9" idx="2"/>
           </p:cNvCxnSpPr>
           <p:nvPr/>
         </p:nvCxnSpPr>
@@ -4056,10 +4041,10 @@
       </p:cxnSp>
       <p:sp>
         <p:nvSpPr>
-          <p:cNvPr id="16" name="">
-            <a:extLst xmlns:a="http://schemas.openxmlformats.org/drawingml/2006/main">
-              <a:ext uri="{FF2B5EF4-FFF2-40B4-BE49-F238E27FC236}">
-                <a16:creationId xmlns:a16="http://schemas.microsoft.com/office/drawing/2014/main" id="{19F58622-C77D-4F15-BFA4-1FCAD407779C}"/>
+          <p:cNvPr id="13" name="">
+            <a:extLst xmlns:a="http://schemas.openxmlformats.org/drawingml/2006/main">
+              <a:ext uri="{FF2B5EF4-FFF2-40B4-BE49-F238E27FC236}">
+                <a16:creationId xmlns:a16="http://schemas.microsoft.com/office/drawing/2014/main" id="{5FA5C47F-7C66-4285-81BD-A215B0B8DA83}"/>
               </a:ext>
             </a:extLst>
           </p:cNvPr>
@@ -4085,25 +4070,54 @@
             </a:solidFill>
           </a:ln>
         </p:spPr>
-      </p:sp>
-      <p:sp>
-        <p:nvSpPr>
-          <p:cNvPr id="17" name="">
-            <a:extLst xmlns:a="http://schemas.openxmlformats.org/drawingml/2006/main">
-              <a:ext uri="{FF2B5EF4-FFF2-40B4-BE49-F238E27FC236}">
-                <a16:creationId xmlns:a16="http://schemas.microsoft.com/office/drawing/2014/main" id="{75689D62-CD35-4A5C-85D5-3C4DA64ED5D0}"/>
-              </a:ext>
-            </a:extLst>
-          </p:cNvPr>
-          <p:cNvSpPr>
-            <a:spLocks xmlns:a="http://schemas.openxmlformats.org/drawingml/2006/main" noGrp="1"/>
-          </p:cNvSpPr>
-          <p:nvPr/>
-        </p:nvSpPr>
-        <p:spPr>
-          <a:xfrm xmlns:a="http://schemas.openxmlformats.org/drawingml/2006/main">
-            <a:off x="7343775" y="2162175"/>
-            <a:ext cx="723900" cy="590550"/>
+        <p:txBody>
+          <a:bodyPr xmlns:a="http://schemas.openxmlformats.org/drawingml/2006/main" lIns="0" tIns="0" rIns="0" bIns="0" anchor="ctr">
+            <a:noAutofit/>
+          </a:bodyPr>
+          <a:lstStyle xmlns:a="http://schemas.openxmlformats.org/drawingml/2006/main"/>
+          <a:p xmlns:a="http://schemas.openxmlformats.org/drawingml/2006/main">
+            <a:pPr algn="ctr">
+              <a:defRPr sz="2775" b="1">
+                <a:solidFill>
+                  <a:srgbClr val="63D7F2"/>
+                </a:solidFill>
+                <a:latin typeface="Helvetica Neue"/>
+                <a:ea typeface="Helvetica Neue"/>
+                <a:cs typeface="Helvetica Neue"/>
+              </a:defRPr>
+            </a:pPr>
+            <a:r>
+              <a:rPr sz="2775" b="1">
+                <a:solidFill>
+                  <a:srgbClr val="63D7F2"/>
+                </a:solidFill>
+                <a:latin typeface="Helvetica Neue"/>
+                <a:ea typeface="Helvetica Neue"/>
+                <a:cs typeface="Helvetica Neue"/>
+              </a:rPr>
+              <a:t>04</a:t>
+            </a:r>
+          </a:p>
+        </p:txBody>
+      </p:sp>
+      <p:sp>
+        <p:nvSpPr>
+          <p:cNvPr id="14" name="">
+            <a:extLst xmlns:a="http://schemas.openxmlformats.org/drawingml/2006/main">
+              <a:ext uri="{FF2B5EF4-FFF2-40B4-BE49-F238E27FC236}">
+                <a16:creationId xmlns:a16="http://schemas.microsoft.com/office/drawing/2014/main" id="{68AE5AD9-3C44-4118-AF54-1C459CEA68BC}"/>
+              </a:ext>
+            </a:extLst>
+          </p:cNvPr>
+          <p:cNvSpPr>
+            <a:spLocks xmlns:a="http://schemas.openxmlformats.org/drawingml/2006/main" noGrp="1"/>
+          </p:cNvSpPr>
+          <p:nvPr/>
+        </p:nvSpPr>
+        <p:spPr>
+          <a:xfrm xmlns:a="http://schemas.openxmlformats.org/drawingml/2006/main">
+            <a:off x="7248525" y="3324225"/>
+            <a:ext cx="2047875" cy="533400"/>
           </a:xfrm>
           <a:prstGeom xmlns:a="http://schemas.openxmlformats.org/drawingml/2006/main" prst="rect">
             <a:avLst/>
@@ -4120,47 +4134,47 @@
           <a:lstStyle xmlns:a="http://schemas.openxmlformats.org/drawingml/2006/main"/>
           <a:p xmlns:a="http://schemas.openxmlformats.org/drawingml/2006/main">
             <a:pPr>
-              <a:defRPr sz="2775" b="1">
-                <a:solidFill>
-                  <a:srgbClr val="63D7F2"/>
-                </a:solidFill>
-                <a:latin typeface="Helvetica Neue"/>
-                <a:ea typeface="Helvetica Neue"/>
-                <a:cs typeface="Helvetica Neue"/>
-              </a:defRPr>
-            </a:pPr>
-            <a:r>
-              <a:rPr sz="2775" b="1">
-                <a:solidFill>
-                  <a:srgbClr val="63D7F2"/>
-                </a:solidFill>
-                <a:latin typeface="Helvetica Neue"/>
-                <a:ea typeface="Helvetica Neue"/>
-                <a:cs typeface="Helvetica Neue"/>
-              </a:rPr>
-              <a:t>04</a:t>
-            </a:r>
-          </a:p>
-        </p:txBody>
-      </p:sp>
-      <p:sp>
-        <p:nvSpPr>
-          <p:cNvPr id="18" name="">
-            <a:extLst xmlns:a="http://schemas.openxmlformats.org/drawingml/2006/main">
-              <a:ext uri="{FF2B5EF4-FFF2-40B4-BE49-F238E27FC236}">
-                <a16:creationId xmlns:a16="http://schemas.microsoft.com/office/drawing/2014/main" id="{C005BF08-692C-47B4-BA31-86FD8B63612E}"/>
-              </a:ext>
-            </a:extLst>
-          </p:cNvPr>
-          <p:cNvSpPr>
-            <a:spLocks xmlns:a="http://schemas.openxmlformats.org/drawingml/2006/main" noGrp="1"/>
-          </p:cNvSpPr>
-          <p:nvPr/>
-        </p:nvSpPr>
-        <p:spPr>
-          <a:xfrm xmlns:a="http://schemas.openxmlformats.org/drawingml/2006/main">
-            <a:off x="7248525" y="3324225"/>
-            <a:ext cx="2047875" cy="533400"/>
+              <a:defRPr sz="2325" b="1">
+                <a:solidFill>
+                  <a:srgbClr val="FFFFFF"/>
+                </a:solidFill>
+                <a:latin typeface="Helvetica Neue"/>
+                <a:ea typeface="Helvetica Neue"/>
+                <a:cs typeface="Helvetica Neue"/>
+              </a:defRPr>
+            </a:pPr>
+            <a:r>
+              <a:rPr sz="2325" b="1">
+                <a:solidFill>
+                  <a:srgbClr val="FFFFFF"/>
+                </a:solidFill>
+                <a:latin typeface="Helvetica Neue"/>
+                <a:ea typeface="Helvetica Neue"/>
+                <a:cs typeface="Helvetica Neue"/>
+              </a:rPr>
+              <a:t>Brief</a:t>
+            </a:r>
+          </a:p>
+        </p:txBody>
+      </p:sp>
+      <p:sp>
+        <p:nvSpPr>
+          <p:cNvPr id="15" name="">
+            <a:extLst xmlns:a="http://schemas.openxmlformats.org/drawingml/2006/main">
+              <a:ext uri="{FF2B5EF4-FFF2-40B4-BE49-F238E27FC236}">
+                <a16:creationId xmlns:a16="http://schemas.microsoft.com/office/drawing/2014/main" id="{548C6C94-384F-4179-BB64-462230346556}"/>
+              </a:ext>
+            </a:extLst>
+          </p:cNvPr>
+          <p:cNvSpPr>
+            <a:spLocks xmlns:a="http://schemas.openxmlformats.org/drawingml/2006/main" noGrp="1"/>
+          </p:cNvSpPr>
+          <p:nvPr/>
+        </p:nvSpPr>
+        <p:spPr>
+          <a:xfrm xmlns:a="http://schemas.openxmlformats.org/drawingml/2006/main">
+            <a:off x="7248525" y="4048125"/>
+            <a:ext cx="2105025" cy="1133475"/>
           </a:xfrm>
           <a:prstGeom xmlns:a="http://schemas.openxmlformats.org/drawingml/2006/main" prst="rect">
             <a:avLst/>
@@ -4177,7 +4191,7 @@
           <a:lstStyle xmlns:a="http://schemas.openxmlformats.org/drawingml/2006/main"/>
           <a:p xmlns:a="http://schemas.openxmlformats.org/drawingml/2006/main">
             <a:pPr>
-              <a:defRPr sz="2325" b="1">
+              <a:defRPr sz="1950" b="0">
                 <a:solidFill>
                   <a:srgbClr val="FFFFFF"/>
                 </a:solidFill>
@@ -4187,7 +4201,7 @@
               </a:defRPr>
             </a:pPr>
             <a:r>
-              <a:rPr sz="2325" b="1">
+              <a:rPr sz="1950" b="0">
                 <a:solidFill>
                   <a:srgbClr val="FFFFFF"/>
                 </a:solidFill>
@@ -4195,43 +4209,9 @@
                 <a:ea typeface="Helvetica Neue"/>
                 <a:cs typeface="Helvetica Neue"/>
               </a:rPr>
-              <a:t>Brief</a:t>
-            </a:r>
-          </a:p>
-        </p:txBody>
-      </p:sp>
-      <p:sp>
-        <p:nvSpPr>
-          <p:cNvPr id="19" name="">
-            <a:extLst xmlns:a="http://schemas.openxmlformats.org/drawingml/2006/main">
-              <a:ext uri="{FF2B5EF4-FFF2-40B4-BE49-F238E27FC236}">
-                <a16:creationId xmlns:a16="http://schemas.microsoft.com/office/drawing/2014/main" id="{2DC59FAD-FB61-4EC5-97D5-AFCCDA7AAD78}"/>
-              </a:ext>
-            </a:extLst>
-          </p:cNvPr>
-          <p:cNvSpPr>
-            <a:spLocks xmlns:a="http://schemas.openxmlformats.org/drawingml/2006/main" noGrp="1"/>
-          </p:cNvSpPr>
-          <p:nvPr/>
-        </p:nvSpPr>
-        <p:spPr>
-          <a:xfrm xmlns:a="http://schemas.openxmlformats.org/drawingml/2006/main">
-            <a:off x="7248525" y="4048125"/>
-            <a:ext cx="2105025" cy="1133475"/>
-          </a:xfrm>
-          <a:prstGeom xmlns:a="http://schemas.openxmlformats.org/drawingml/2006/main" prst="rect">
-            <a:avLst/>
-          </a:prstGeom>
-          <a:noFill xmlns:a="http://schemas.openxmlformats.org/drawingml/2006/main"/>
-          <a:ln xmlns:a="http://schemas.openxmlformats.org/drawingml/2006/main" w="0">
-            <a:noFill/>
-          </a:ln>
-        </p:spPr>
-        <p:txBody>
-          <a:bodyPr xmlns:a="http://schemas.openxmlformats.org/drawingml/2006/main">
-            <a:noAutofit/>
-          </a:bodyPr>
-          <a:lstStyle xmlns:a="http://schemas.openxmlformats.org/drawingml/2006/main"/>
+              <a:t>Brief and</a:t>
+            </a:r>
+          </a:p>
           <a:p xmlns:a="http://schemas.openxmlformats.org/drawingml/2006/main">
             <a:pPr>
               <a:defRPr sz="1950" b="0">
@@ -4252,40 +4232,17 @@
                 <a:ea typeface="Helvetica Neue"/>
                 <a:cs typeface="Helvetica Neue"/>
               </a:rPr>
-              <a:t>Goal-specific output</a:t>
-            </a:r>
-          </a:p>
-          <a:p xmlns:a="http://schemas.openxmlformats.org/drawingml/2006/main">
-            <a:pPr>
-              <a:defRPr sz="1950" b="0">
-                <a:solidFill>
-                  <a:srgbClr val="FFFFFF"/>
-                </a:solidFill>
-                <a:latin typeface="Helvetica Neue"/>
-                <a:ea typeface="Helvetica Neue"/>
-                <a:cs typeface="Helvetica Neue"/>
-              </a:defRPr>
-            </a:pPr>
-            <a:r>
-              <a:rPr sz="1950" b="0">
-                <a:solidFill>
-                  <a:srgbClr val="FFFFFF"/>
-                </a:solidFill>
-                <a:latin typeface="Helvetica Neue"/>
-                <a:ea typeface="Helvetica Neue"/>
-                <a:cs typeface="Helvetica Neue"/>
-              </a:rPr>
-              <a:t>and citation checks</a:t>
+              <a:t>citation checks</a:t>
             </a:r>
           </a:p>
         </p:txBody>
       </p:sp>
       <p:cxnSp>
         <p:nvCxnSpPr>
-          <p:cNvPr id="46" name=""/>
+          <p:cNvPr id="37" name=""/>
           <p:cNvCxnSpPr>
-            <a:stCxn xmlns:a="http://schemas.openxmlformats.org/drawingml/2006/main" id="11" idx="6"/>
-            <a:endCxn xmlns:a="http://schemas.openxmlformats.org/drawingml/2006/main" id="16" idx="2"/>
+            <a:stCxn xmlns:a="http://schemas.openxmlformats.org/drawingml/2006/main" id="9" idx="6"/>
+            <a:endCxn xmlns:a="http://schemas.openxmlformats.org/drawingml/2006/main" id="13" idx="2"/>
           </p:cNvCxnSpPr>
           <p:nvPr/>
         </p:nvCxnSpPr>
@@ -4307,10 +4264,10 @@
       </p:cxnSp>
       <p:sp>
         <p:nvSpPr>
-          <p:cNvPr id="21" name="">
-            <a:extLst xmlns:a="http://schemas.openxmlformats.org/drawingml/2006/main">
-              <a:ext uri="{FF2B5EF4-FFF2-40B4-BE49-F238E27FC236}">
-                <a16:creationId xmlns:a16="http://schemas.microsoft.com/office/drawing/2014/main" id="{3B364BB3-81F2-4D2F-A8A1-2FA28404D34E}"/>
+          <p:cNvPr id="17" name="">
+            <a:extLst xmlns:a="http://schemas.openxmlformats.org/drawingml/2006/main">
+              <a:ext uri="{FF2B5EF4-FFF2-40B4-BE49-F238E27FC236}">
+                <a16:creationId xmlns:a16="http://schemas.microsoft.com/office/drawing/2014/main" id="{40B1E0CB-D8BE-4ABD-B9F4-C86F66D256C4}"/>
               </a:ext>
             </a:extLst>
           </p:cNvPr>
@@ -4336,25 +4293,54 @@
             </a:solidFill>
           </a:ln>
         </p:spPr>
-      </p:sp>
-      <p:sp>
-        <p:nvSpPr>
-          <p:cNvPr id="22" name="">
-            <a:extLst xmlns:a="http://schemas.openxmlformats.org/drawingml/2006/main">
-              <a:ext uri="{FF2B5EF4-FFF2-40B4-BE49-F238E27FC236}">
-                <a16:creationId xmlns:a16="http://schemas.microsoft.com/office/drawing/2014/main" id="{5A7D8C79-2164-4AC6-822E-9E508CE4C43A}"/>
-              </a:ext>
-            </a:extLst>
-          </p:cNvPr>
-          <p:cNvSpPr>
-            <a:spLocks xmlns:a="http://schemas.openxmlformats.org/drawingml/2006/main" noGrp="1"/>
-          </p:cNvSpPr>
-          <p:nvPr/>
-        </p:nvSpPr>
-        <p:spPr>
-          <a:xfrm xmlns:a="http://schemas.openxmlformats.org/drawingml/2006/main">
-            <a:off x="9572625" y="2162175"/>
-            <a:ext cx="723900" cy="590550"/>
+        <p:txBody>
+          <a:bodyPr xmlns:a="http://schemas.openxmlformats.org/drawingml/2006/main" lIns="0" tIns="0" rIns="0" bIns="0" anchor="ctr">
+            <a:noAutofit/>
+          </a:bodyPr>
+          <a:lstStyle xmlns:a="http://schemas.openxmlformats.org/drawingml/2006/main"/>
+          <a:p xmlns:a="http://schemas.openxmlformats.org/drawingml/2006/main">
+            <a:pPr algn="ctr">
+              <a:defRPr sz="2775" b="1">
+                <a:solidFill>
+                  <a:srgbClr val="0B214A"/>
+                </a:solidFill>
+                <a:latin typeface="Helvetica Neue"/>
+                <a:ea typeface="Helvetica Neue"/>
+                <a:cs typeface="Helvetica Neue"/>
+              </a:defRPr>
+            </a:pPr>
+            <a:r>
+              <a:rPr sz="2775" b="1">
+                <a:solidFill>
+                  <a:srgbClr val="0B214A"/>
+                </a:solidFill>
+                <a:latin typeface="Helvetica Neue"/>
+                <a:ea typeface="Helvetica Neue"/>
+                <a:cs typeface="Helvetica Neue"/>
+              </a:rPr>
+              <a:t>05</a:t>
+            </a:r>
+          </a:p>
+        </p:txBody>
+      </p:sp>
+      <p:sp>
+        <p:nvSpPr>
+          <p:cNvPr id="18" name="">
+            <a:extLst xmlns:a="http://schemas.openxmlformats.org/drawingml/2006/main">
+              <a:ext uri="{FF2B5EF4-FFF2-40B4-BE49-F238E27FC236}">
+                <a16:creationId xmlns:a16="http://schemas.microsoft.com/office/drawing/2014/main" id="{464DFAFD-3F67-496B-82EA-902F33C34EA2}"/>
+              </a:ext>
+            </a:extLst>
+          </p:cNvPr>
+          <p:cNvSpPr>
+            <a:spLocks xmlns:a="http://schemas.openxmlformats.org/drawingml/2006/main" noGrp="1"/>
+          </p:cNvSpPr>
+          <p:nvPr/>
+        </p:nvSpPr>
+        <p:spPr>
+          <a:xfrm xmlns:a="http://schemas.openxmlformats.org/drawingml/2006/main">
+            <a:off x="9477375" y="3324225"/>
+            <a:ext cx="2047875" cy="533400"/>
           </a:xfrm>
           <a:prstGeom xmlns:a="http://schemas.openxmlformats.org/drawingml/2006/main" prst="rect">
             <a:avLst/>
@@ -4371,47 +4357,47 @@
           <a:lstStyle xmlns:a="http://schemas.openxmlformats.org/drawingml/2006/main"/>
           <a:p xmlns:a="http://schemas.openxmlformats.org/drawingml/2006/main">
             <a:pPr>
-              <a:defRPr sz="2775" b="1">
-                <a:solidFill>
-                  <a:srgbClr val="0B214A"/>
-                </a:solidFill>
-                <a:latin typeface="Helvetica Neue"/>
-                <a:ea typeface="Helvetica Neue"/>
-                <a:cs typeface="Helvetica Neue"/>
-              </a:defRPr>
-            </a:pPr>
-            <a:r>
-              <a:rPr sz="2775" b="1">
-                <a:solidFill>
-                  <a:srgbClr val="0B214A"/>
-                </a:solidFill>
-                <a:latin typeface="Helvetica Neue"/>
-                <a:ea typeface="Helvetica Neue"/>
-                <a:cs typeface="Helvetica Neue"/>
-              </a:rPr>
-              <a:t>05</a:t>
-            </a:r>
-          </a:p>
-        </p:txBody>
-      </p:sp>
-      <p:sp>
-        <p:nvSpPr>
-          <p:cNvPr id="23" name="">
-            <a:extLst xmlns:a="http://schemas.openxmlformats.org/drawingml/2006/main">
-              <a:ext uri="{FF2B5EF4-FFF2-40B4-BE49-F238E27FC236}">
-                <a16:creationId xmlns:a16="http://schemas.microsoft.com/office/drawing/2014/main" id="{46C9517E-58D4-4AB7-B32A-315EC6A9883D}"/>
-              </a:ext>
-            </a:extLst>
-          </p:cNvPr>
-          <p:cNvSpPr>
-            <a:spLocks xmlns:a="http://schemas.openxmlformats.org/drawingml/2006/main" noGrp="1"/>
-          </p:cNvSpPr>
-          <p:nvPr/>
-        </p:nvSpPr>
-        <p:spPr>
-          <a:xfrm xmlns:a="http://schemas.openxmlformats.org/drawingml/2006/main">
-            <a:off x="9477375" y="3324225"/>
-            <a:ext cx="2047875" cy="533400"/>
+              <a:defRPr sz="2325" b="1">
+                <a:solidFill>
+                  <a:srgbClr val="FFFFFF"/>
+                </a:solidFill>
+                <a:latin typeface="Helvetica Neue"/>
+                <a:ea typeface="Helvetica Neue"/>
+                <a:cs typeface="Helvetica Neue"/>
+              </a:defRPr>
+            </a:pPr>
+            <a:r>
+              <a:rPr sz="2325" b="1">
+                <a:solidFill>
+                  <a:srgbClr val="FFFFFF"/>
+                </a:solidFill>
+                <a:latin typeface="Helvetica Neue"/>
+                <a:ea typeface="Helvetica Neue"/>
+                <a:cs typeface="Helvetica Neue"/>
+              </a:rPr>
+              <a:t>Review</a:t>
+            </a:r>
+          </a:p>
+        </p:txBody>
+      </p:sp>
+      <p:sp>
+        <p:nvSpPr>
+          <p:cNvPr id="19" name="">
+            <a:extLst xmlns:a="http://schemas.openxmlformats.org/drawingml/2006/main">
+              <a:ext uri="{FF2B5EF4-FFF2-40B4-BE49-F238E27FC236}">
+                <a16:creationId xmlns:a16="http://schemas.microsoft.com/office/drawing/2014/main" id="{227D46AE-E76A-480B-B14C-7B08CC503CFD}"/>
+              </a:ext>
+            </a:extLst>
+          </p:cNvPr>
+          <p:cNvSpPr>
+            <a:spLocks xmlns:a="http://schemas.openxmlformats.org/drawingml/2006/main" noGrp="1"/>
+          </p:cNvSpPr>
+          <p:nvPr/>
+        </p:nvSpPr>
+        <p:spPr>
+          <a:xfrm xmlns:a="http://schemas.openxmlformats.org/drawingml/2006/main">
+            <a:off x="9477375" y="4048125"/>
+            <a:ext cx="2105025" cy="1133475"/>
           </a:xfrm>
           <a:prstGeom xmlns:a="http://schemas.openxmlformats.org/drawingml/2006/main" prst="rect">
             <a:avLst/>
@@ -4428,63 +4414,6 @@
           <a:lstStyle xmlns:a="http://schemas.openxmlformats.org/drawingml/2006/main"/>
           <a:p xmlns:a="http://schemas.openxmlformats.org/drawingml/2006/main">
             <a:pPr>
-              <a:defRPr sz="2325" b="1">
-                <a:solidFill>
-                  <a:srgbClr val="FFFFFF"/>
-                </a:solidFill>
-                <a:latin typeface="Helvetica Neue"/>
-                <a:ea typeface="Helvetica Neue"/>
-                <a:cs typeface="Helvetica Neue"/>
-              </a:defRPr>
-            </a:pPr>
-            <a:r>
-              <a:rPr sz="2325" b="1">
-                <a:solidFill>
-                  <a:srgbClr val="FFFFFF"/>
-                </a:solidFill>
-                <a:latin typeface="Helvetica Neue"/>
-                <a:ea typeface="Helvetica Neue"/>
-                <a:cs typeface="Helvetica Neue"/>
-              </a:rPr>
-              <a:t>Review</a:t>
-            </a:r>
-          </a:p>
-        </p:txBody>
-      </p:sp>
-      <p:sp>
-        <p:nvSpPr>
-          <p:cNvPr id="24" name="">
-            <a:extLst xmlns:a="http://schemas.openxmlformats.org/drawingml/2006/main">
-              <a:ext uri="{FF2B5EF4-FFF2-40B4-BE49-F238E27FC236}">
-                <a16:creationId xmlns:a16="http://schemas.microsoft.com/office/drawing/2014/main" id="{4BA747C5-5B9F-46D0-A65C-3371A887A612}"/>
-              </a:ext>
-            </a:extLst>
-          </p:cNvPr>
-          <p:cNvSpPr>
-            <a:spLocks xmlns:a="http://schemas.openxmlformats.org/drawingml/2006/main" noGrp="1"/>
-          </p:cNvSpPr>
-          <p:nvPr/>
-        </p:nvSpPr>
-        <p:spPr>
-          <a:xfrm xmlns:a="http://schemas.openxmlformats.org/drawingml/2006/main">
-            <a:off x="9477375" y="4048125"/>
-            <a:ext cx="2105025" cy="1133475"/>
-          </a:xfrm>
-          <a:prstGeom xmlns:a="http://schemas.openxmlformats.org/drawingml/2006/main" prst="rect">
-            <a:avLst/>
-          </a:prstGeom>
-          <a:noFill xmlns:a="http://schemas.openxmlformats.org/drawingml/2006/main"/>
-          <a:ln xmlns:a="http://schemas.openxmlformats.org/drawingml/2006/main" w="0">
-            <a:noFill/>
-          </a:ln>
-        </p:spPr>
-        <p:txBody>
-          <a:bodyPr xmlns:a="http://schemas.openxmlformats.org/drawingml/2006/main">
-            <a:noAutofit/>
-          </a:bodyPr>
-          <a:lstStyle xmlns:a="http://schemas.openxmlformats.org/drawingml/2006/main"/>
-          <a:p xmlns:a="http://schemas.openxmlformats.org/drawingml/2006/main">
-            <a:pPr>
               <a:defRPr sz="1950" b="0">
                 <a:solidFill>
                   <a:srgbClr val="FFFFFF"/>
@@ -4533,10 +4462,10 @@
       </p:sp>
       <p:cxnSp>
         <p:nvCxnSpPr>
-          <p:cNvPr id="51" name=""/>
+          <p:cNvPr id="41" name=""/>
           <p:cNvCxnSpPr>
-            <a:stCxn xmlns:a="http://schemas.openxmlformats.org/drawingml/2006/main" id="16" idx="6"/>
-            <a:endCxn xmlns:a="http://schemas.openxmlformats.org/drawingml/2006/main" id="21" idx="2"/>
+            <a:stCxn xmlns:a="http://schemas.openxmlformats.org/drawingml/2006/main" id="13" idx="6"/>
+            <a:endCxn xmlns:a="http://schemas.openxmlformats.org/drawingml/2006/main" id="17" idx="2"/>
           </p:cNvCxnSpPr>
           <p:nvPr/>
         </p:nvCxnSpPr>
@@ -4558,10 +4487,10 @@
       </p:cxnSp>
       <p:sp>
         <p:nvSpPr>
-          <p:cNvPr id="26" name="">
-            <a:extLst xmlns:a="http://schemas.openxmlformats.org/drawingml/2006/main">
-              <a:ext uri="{FF2B5EF4-FFF2-40B4-BE49-F238E27FC236}">
-                <a16:creationId xmlns:a16="http://schemas.microsoft.com/office/drawing/2014/main" id="{D5C251A3-453C-4245-93F4-6718ECDFB1D5}"/>
+          <p:cNvPr id="21" name="">
+            <a:extLst xmlns:a="http://schemas.openxmlformats.org/drawingml/2006/main">
+              <a:ext uri="{FF2B5EF4-FFF2-40B4-BE49-F238E27FC236}">
+                <a16:creationId xmlns:a16="http://schemas.microsoft.com/office/drawing/2014/main" id="{C85298A6-D248-4C87-AFE2-0839476EFAA7}"/>
               </a:ext>
             </a:extLst>
           </p:cNvPr>
@@ -4616,7 +4545,7 @@
     </p:spTree>
     <p:extLst>
       <p:ext uri="{BB962C8B-B14F-4D97-AF65-F5344CB8AC3E}">
-        <p14:creationId xmlns:p14="http://schemas.microsoft.com/office/powerpoint/2010/main" val="257414173"/>
+        <p14:creationId xmlns:p14="http://schemas.microsoft.com/office/powerpoint/2010/main" val="106431827"/>
       </p:ext>
     </p:extLst>
   </p:cSld>
@@ -4629,7 +4558,7 @@
     <p:bg>
       <p:bgPr>
         <a:solidFill xmlns:a="http://schemas.openxmlformats.org/drawingml/2006/main">
-          <a:srgbClr val="EDF5FC"/>
+          <a:srgbClr val="FFFFFF"/>
         </a:solidFill>
       </p:bgPr>
     </p:bg>
@@ -4644,22 +4573,22 @@
       </p:grpSpPr>
       <p:sp>
         <p:nvSpPr>
-          <p:cNvPr id="7" name="">
-            <a:extLst xmlns:a="http://schemas.openxmlformats.org/drawingml/2006/main">
-              <a:ext uri="{FF2B5EF4-FFF2-40B4-BE49-F238E27FC236}">
-                <a16:creationId xmlns:a16="http://schemas.microsoft.com/office/drawing/2014/main" id="{D48DBCD9-9C5F-4874-B02F-E6C5508BA02D}"/>
-              </a:ext>
-            </a:extLst>
-          </p:cNvPr>
-          <p:cNvSpPr>
-            <a:spLocks xmlns:a="http://schemas.openxmlformats.org/drawingml/2006/main" noGrp="1"/>
-          </p:cNvSpPr>
-          <p:nvPr/>
-        </p:nvSpPr>
-        <p:spPr>
-          <a:xfrm xmlns:a="http://schemas.openxmlformats.org/drawingml/2006/main">
-            <a:off x="533400" y="342900"/>
-            <a:ext cx="11239500" cy="695325"/>
+          <p:cNvPr id="9" name="">
+            <a:extLst xmlns:a="http://schemas.openxmlformats.org/drawingml/2006/main">
+              <a:ext uri="{FF2B5EF4-FFF2-40B4-BE49-F238E27FC236}">
+                <a16:creationId xmlns:a16="http://schemas.microsoft.com/office/drawing/2014/main" id="{9311C953-25D8-4A72-94D9-7FA81C39B456}"/>
+              </a:ext>
+            </a:extLst>
+          </p:cNvPr>
+          <p:cNvSpPr>
+            <a:spLocks xmlns:a="http://schemas.openxmlformats.org/drawingml/2006/main" noGrp="1"/>
+          </p:cNvSpPr>
+          <p:nvPr/>
+        </p:nvSpPr>
+        <p:spPr>
+          <a:xfrm xmlns:a="http://schemas.openxmlformats.org/drawingml/2006/main">
+            <a:off x="609600" y="457200"/>
+            <a:ext cx="10972800" cy="762000"/>
           </a:xfrm>
           <a:prstGeom xmlns:a="http://schemas.openxmlformats.org/drawingml/2006/main" prst="rect">
             <a:avLst/>
@@ -4676,7 +4605,7 @@
           <a:lstStyle xmlns:a="http://schemas.openxmlformats.org/drawingml/2006/main"/>
           <a:p xmlns:a="http://schemas.openxmlformats.org/drawingml/2006/main">
             <a:pPr>
-              <a:defRPr sz="3900" b="1">
+              <a:defRPr sz="3525" b="1">
                 <a:solidFill>
                   <a:srgbClr val="0B214A"/>
                 </a:solidFill>
@@ -4686,7 +4615,7 @@
               </a:defRPr>
             </a:pPr>
             <a:r>
-              <a:rPr sz="3900" b="1">
+              <a:rPr sz="3525" b="1">
                 <a:solidFill>
                   <a:srgbClr val="0B214A"/>
                 </a:solidFill>
@@ -4694,27 +4623,27 @@
                 <a:ea typeface="Helvetica Neue"/>
                 <a:cs typeface="Helvetica Neue"/>
               </a:rPr>
-              <a:t>One workspace. A clear next step.</a:t>
+              <a:t>Your research, in one workspace</a:t>
             </a:r>
           </a:p>
         </p:txBody>
       </p:sp>
       <p:pic>
         <p:nvPicPr>
-          <p:cNvPr id="8" name=""/>
+          <p:cNvPr id="10" name=""/>
           <p:cNvPicPr>
             <a:picLocks xmlns:a="http://schemas.openxmlformats.org/drawingml/2006/main" noChangeAspect="1"/>
           </p:cNvPicPr>
           <p:nvPr/>
         </p:nvPicPr>
         <p:blipFill>
-          <a:blip xmlns:r="http://schemas.openxmlformats.org/officeDocument/2006/relationships" xmlns:a="http://schemas.openxmlformats.org/drawingml/2006/main" r:embed="Rfa289e1d8c8f49f1"/>
+          <a:blip xmlns:r="http://schemas.openxmlformats.org/officeDocument/2006/relationships" xmlns:a="http://schemas.openxmlformats.org/drawingml/2006/main" r:embed="R7f59ccfb4e2c4af0"/>
           <a:stretch xmlns:a="http://schemas.openxmlformats.org/drawingml/2006/main"/>
         </p:blipFill>
         <p:spPr>
           <a:xfrm xmlns:a="http://schemas.openxmlformats.org/drawingml/2006/main">
-            <a:off x="1019810" y="1190625"/>
-            <a:ext cx="8952229" cy="5038725"/>
+            <a:off x="540089" y="1666875"/>
+            <a:ext cx="7987622" cy="4495800"/>
           </a:xfrm>
           <a:prstGeom xmlns:a="http://schemas.openxmlformats.org/drawingml/2006/main" prst="rect">
             <a:avLst/>
@@ -4726,19 +4655,19 @@
           <p:cNvPr id="3" name="">
             <a:extLst xmlns:a="http://schemas.openxmlformats.org/drawingml/2006/main">
               <a:ext uri="{FF2B5EF4-FFF2-40B4-BE49-F238E27FC236}">
-                <a16:creationId xmlns:a16="http://schemas.microsoft.com/office/drawing/2014/main" id="{58B43AAD-4166-475C-84E0-F6A1D3DB5C95}"/>
-              </a:ext>
-            </a:extLst>
-          </p:cNvPr>
-          <p:cNvSpPr>
-            <a:spLocks xmlns:a="http://schemas.openxmlformats.org/drawingml/2006/main" noGrp="1"/>
-          </p:cNvSpPr>
-          <p:nvPr/>
-        </p:nvSpPr>
-        <p:spPr>
-          <a:xfrm xmlns:a="http://schemas.openxmlformats.org/drawingml/2006/main">
-            <a:off x="10620375" y="2181225"/>
-            <a:ext cx="1323975" cy="752475"/>
+                <a16:creationId xmlns:a16="http://schemas.microsoft.com/office/drawing/2014/main" id="{6D4B3D26-960D-4EE6-9561-80539284A247}"/>
+              </a:ext>
+            </a:extLst>
+          </p:cNvPr>
+          <p:cNvSpPr>
+            <a:spLocks xmlns:a="http://schemas.openxmlformats.org/drawingml/2006/main" noGrp="1"/>
+          </p:cNvSpPr>
+          <p:nvPr/>
+        </p:nvSpPr>
+        <p:spPr>
+          <a:xfrm xmlns:a="http://schemas.openxmlformats.org/drawingml/2006/main">
+            <a:off x="8953500" y="1809750"/>
+            <a:ext cx="2619375" cy="447675"/>
           </a:xfrm>
           <a:prstGeom xmlns:a="http://schemas.openxmlformats.org/drawingml/2006/main" prst="rect">
             <a:avLst/>
@@ -4755,7 +4684,7 @@
           <a:lstStyle xmlns:a="http://schemas.openxmlformats.org/drawingml/2006/main"/>
           <a:p xmlns:a="http://schemas.openxmlformats.org/drawingml/2006/main">
             <a:pPr>
-              <a:defRPr sz="1725" b="1">
+              <a:defRPr sz="2025" b="1">
                 <a:solidFill>
                   <a:srgbClr val="126FCE"/>
                 </a:solidFill>
@@ -4765,7 +4694,7 @@
               </a:defRPr>
             </a:pPr>
             <a:r>
-              <a:rPr sz="1725" b="1">
+              <a:rPr sz="2025" b="1">
                 <a:solidFill>
                   <a:srgbClr val="126FCE"/>
                 </a:solidFill>
@@ -4773,30 +4702,7 @@
                 <a:ea typeface="Helvetica Neue"/>
                 <a:cs typeface="Helvetica Neue"/>
               </a:rPr>
-              <a:t>Research</a:t>
-            </a:r>
-          </a:p>
-          <a:p xmlns:a="http://schemas.openxmlformats.org/drawingml/2006/main">
-            <a:pPr>
-              <a:defRPr sz="1725" b="1">
-                <a:solidFill>
-                  <a:srgbClr val="126FCE"/>
-                </a:solidFill>
-                <a:latin typeface="Helvetica Neue"/>
-                <a:ea typeface="Helvetica Neue"/>
-                <a:cs typeface="Helvetica Neue"/>
-              </a:defRPr>
-            </a:pPr>
-            <a:r>
-              <a:rPr sz="1725" b="1">
-                <a:solidFill>
-                  <a:srgbClr val="126FCE"/>
-                </a:solidFill>
-                <a:latin typeface="Helvetica Neue"/>
-                <a:ea typeface="Helvetica Neue"/>
-                <a:cs typeface="Helvetica Neue"/>
-              </a:rPr>
-              <a:t>progress</a:t>
+              <a:t>Research progress</a:t>
             </a:r>
           </a:p>
         </p:txBody>
@@ -4806,19 +4712,19 @@
           <p:cNvPr id="4" name="">
             <a:extLst xmlns:a="http://schemas.openxmlformats.org/drawingml/2006/main">
               <a:ext uri="{FF2B5EF4-FFF2-40B4-BE49-F238E27FC236}">
-                <a16:creationId xmlns:a16="http://schemas.microsoft.com/office/drawing/2014/main" id="{02017C63-EA63-4AFA-B340-B3305D4E0F77}"/>
-              </a:ext>
-            </a:extLst>
-          </p:cNvPr>
-          <p:cNvSpPr>
-            <a:spLocks xmlns:a="http://schemas.openxmlformats.org/drawingml/2006/main" noGrp="1"/>
-          </p:cNvSpPr>
-          <p:nvPr/>
-        </p:nvSpPr>
-        <p:spPr>
-          <a:xfrm xmlns:a="http://schemas.openxmlformats.org/drawingml/2006/main">
-            <a:off x="10620375" y="3514725"/>
-            <a:ext cx="1323975" cy="752475"/>
+                <a16:creationId xmlns:a16="http://schemas.microsoft.com/office/drawing/2014/main" id="{79EBDED9-B7B0-4396-8DB1-3AEC410453B7}"/>
+              </a:ext>
+            </a:extLst>
+          </p:cNvPr>
+          <p:cNvSpPr>
+            <a:spLocks xmlns:a="http://schemas.openxmlformats.org/drawingml/2006/main" noGrp="1"/>
+          </p:cNvSpPr>
+          <p:nvPr/>
+        </p:nvSpPr>
+        <p:spPr>
+          <a:xfrm xmlns:a="http://schemas.openxmlformats.org/drawingml/2006/main">
+            <a:off x="8953500" y="2343150"/>
+            <a:ext cx="2619375" cy="819150"/>
           </a:xfrm>
           <a:prstGeom xmlns:a="http://schemas.openxmlformats.org/drawingml/2006/main" prst="rect">
             <a:avLst/>
@@ -4835,48 +4741,25 @@
           <a:lstStyle xmlns:a="http://schemas.openxmlformats.org/drawingml/2006/main"/>
           <a:p xmlns:a="http://schemas.openxmlformats.org/drawingml/2006/main">
             <a:pPr>
-              <a:defRPr sz="1725" b="1">
-                <a:solidFill>
-                  <a:srgbClr val="126FCE"/>
-                </a:solidFill>
-                <a:latin typeface="Helvetica Neue"/>
-                <a:ea typeface="Helvetica Neue"/>
-                <a:cs typeface="Helvetica Neue"/>
-              </a:defRPr>
-            </a:pPr>
-            <a:r>
-              <a:rPr sz="1725" b="1">
-                <a:solidFill>
-                  <a:srgbClr val="126FCE"/>
-                </a:solidFill>
-                <a:latin typeface="Helvetica Neue"/>
-                <a:ea typeface="Helvetica Neue"/>
-                <a:cs typeface="Helvetica Neue"/>
-              </a:rPr>
-              <a:t>Saved</a:t>
-            </a:r>
-          </a:p>
-          <a:p xmlns:a="http://schemas.openxmlformats.org/drawingml/2006/main">
-            <a:pPr>
-              <a:defRPr sz="1725" b="1">
-                <a:solidFill>
-                  <a:srgbClr val="126FCE"/>
-                </a:solidFill>
-                <a:latin typeface="Helvetica Neue"/>
-                <a:ea typeface="Helvetica Neue"/>
-                <a:cs typeface="Helvetica Neue"/>
-              </a:defRPr>
-            </a:pPr>
-            <a:r>
-              <a:rPr sz="1725" b="1">
-                <a:solidFill>
-                  <a:srgbClr val="126FCE"/>
-                </a:solidFill>
-                <a:latin typeface="Helvetica Neue"/>
-                <a:ea typeface="Helvetica Neue"/>
-                <a:cs typeface="Helvetica Neue"/>
-              </a:rPr>
-              <a:t>briefs</a:t>
+              <a:defRPr sz="1875" b="0">
+                <a:solidFill>
+                  <a:srgbClr val="123363"/>
+                </a:solidFill>
+                <a:latin typeface="Helvetica Neue"/>
+                <a:ea typeface="Helvetica Neue"/>
+                <a:cs typeface="Helvetica Neue"/>
+              </a:defRPr>
+            </a:pPr>
+            <a:r>
+              <a:rPr sz="1875" b="0">
+                <a:solidFill>
+                  <a:srgbClr val="123363"/>
+                </a:solidFill>
+                <a:latin typeface="Helvetica Neue"/>
+                <a:ea typeface="Helvetica Neue"/>
+                <a:cs typeface="Helvetica Neue"/>
+              </a:rPr>
+              <a:t>See what is running and what is ready.</a:t>
             </a:r>
           </a:p>
         </p:txBody>
@@ -4886,19 +4769,19 @@
           <p:cNvPr id="5" name="">
             <a:extLst xmlns:a="http://schemas.openxmlformats.org/drawingml/2006/main">
               <a:ext uri="{FF2B5EF4-FFF2-40B4-BE49-F238E27FC236}">
-                <a16:creationId xmlns:a16="http://schemas.microsoft.com/office/drawing/2014/main" id="{CAEBC583-A62B-4B82-B36D-ECFEFA2EC077}"/>
-              </a:ext>
-            </a:extLst>
-          </p:cNvPr>
-          <p:cNvSpPr>
-            <a:spLocks xmlns:a="http://schemas.openxmlformats.org/drawingml/2006/main" noGrp="1"/>
-          </p:cNvSpPr>
-          <p:nvPr/>
-        </p:nvSpPr>
-        <p:spPr>
-          <a:xfrm xmlns:a="http://schemas.openxmlformats.org/drawingml/2006/main">
-            <a:off x="10553700" y="4848225"/>
-            <a:ext cx="1571625" cy="752475"/>
+                <a16:creationId xmlns:a16="http://schemas.microsoft.com/office/drawing/2014/main" id="{D495551F-3E43-4BDB-8B00-99CE6415D692}"/>
+              </a:ext>
+            </a:extLst>
+          </p:cNvPr>
+          <p:cNvSpPr>
+            <a:spLocks xmlns:a="http://schemas.openxmlformats.org/drawingml/2006/main" noGrp="1"/>
+          </p:cNvSpPr>
+          <p:nvPr/>
+        </p:nvSpPr>
+        <p:spPr>
+          <a:xfrm xmlns:a="http://schemas.openxmlformats.org/drawingml/2006/main">
+            <a:off x="8953500" y="3438525"/>
+            <a:ext cx="2619375" cy="447675"/>
           </a:xfrm>
           <a:prstGeom xmlns:a="http://schemas.openxmlformats.org/drawingml/2006/main" prst="rect">
             <a:avLst/>
@@ -4915,7 +4798,7 @@
           <a:lstStyle xmlns:a="http://schemas.openxmlformats.org/drawingml/2006/main"/>
           <a:p xmlns:a="http://schemas.openxmlformats.org/drawingml/2006/main">
             <a:pPr>
-              <a:defRPr sz="1650" b="1">
+              <a:defRPr sz="2025" b="1">
                 <a:solidFill>
                   <a:srgbClr val="126FCE"/>
                 </a:solidFill>
@@ -4925,7 +4808,7 @@
               </a:defRPr>
             </a:pPr>
             <a:r>
-              <a:rPr sz="1650" b="1">
+              <a:rPr sz="2025" b="1">
                 <a:solidFill>
                   <a:srgbClr val="126FCE"/>
                 </a:solidFill>
@@ -4933,30 +4816,7 @@
                 <a:ea typeface="Helvetica Neue"/>
                 <a:cs typeface="Helvetica Neue"/>
               </a:rPr>
-              <a:t>Team</a:t>
-            </a:r>
-          </a:p>
-          <a:p xmlns:a="http://schemas.openxmlformats.org/drawingml/2006/main">
-            <a:pPr>
-              <a:defRPr sz="1650" b="1">
-                <a:solidFill>
-                  <a:srgbClr val="126FCE"/>
-                </a:solidFill>
-                <a:latin typeface="Helvetica Neue"/>
-                <a:ea typeface="Helvetica Neue"/>
-                <a:cs typeface="Helvetica Neue"/>
-              </a:defRPr>
-            </a:pPr>
-            <a:r>
-              <a:rPr sz="1650" b="1">
-                <a:solidFill>
-                  <a:srgbClr val="126FCE"/>
-                </a:solidFill>
-                <a:latin typeface="Helvetica Neue"/>
-                <a:ea typeface="Helvetica Neue"/>
-                <a:cs typeface="Helvetica Neue"/>
-              </a:rPr>
-              <a:t>workspace</a:t>
+              <a:t>Saved briefs</a:t>
             </a:r>
           </a:p>
         </p:txBody>
@@ -4966,19 +4826,19 @@
           <p:cNvPr id="6" name="">
             <a:extLst xmlns:a="http://schemas.openxmlformats.org/drawingml/2006/main">
               <a:ext uri="{FF2B5EF4-FFF2-40B4-BE49-F238E27FC236}">
-                <a16:creationId xmlns:a16="http://schemas.microsoft.com/office/drawing/2014/main" id="{0CE8E354-6057-42DC-A7EB-7687C9B3BD72}"/>
-              </a:ext>
-            </a:extLst>
-          </p:cNvPr>
-          <p:cNvSpPr>
-            <a:spLocks xmlns:a="http://schemas.openxmlformats.org/drawingml/2006/main" noGrp="1"/>
-          </p:cNvSpPr>
-          <p:nvPr/>
-        </p:nvSpPr>
-        <p:spPr>
-          <a:xfrm xmlns:a="http://schemas.openxmlformats.org/drawingml/2006/main">
-            <a:off x="590550" y="6400800"/>
-            <a:ext cx="9525000" cy="247650"/>
+                <a16:creationId xmlns:a16="http://schemas.microsoft.com/office/drawing/2014/main" id="{3A88ED9A-9505-482C-9495-930128A2EFF1}"/>
+              </a:ext>
+            </a:extLst>
+          </p:cNvPr>
+          <p:cNvSpPr>
+            <a:spLocks xmlns:a="http://schemas.openxmlformats.org/drawingml/2006/main" noGrp="1"/>
+          </p:cNvSpPr>
+          <p:nvPr/>
+        </p:nvSpPr>
+        <p:spPr>
+          <a:xfrm xmlns:a="http://schemas.openxmlformats.org/drawingml/2006/main">
+            <a:off x="8953500" y="3962400"/>
+            <a:ext cx="2619375" cy="971550"/>
           </a:xfrm>
           <a:prstGeom xmlns:a="http://schemas.openxmlformats.org/drawingml/2006/main" prst="rect">
             <a:avLst/>
@@ -4995,25 +4855,139 @@
           <a:lstStyle xmlns:a="http://schemas.openxmlformats.org/drawingml/2006/main"/>
           <a:p xmlns:a="http://schemas.openxmlformats.org/drawingml/2006/main">
             <a:pPr>
-              <a:defRPr sz="1350" b="0">
-                <a:solidFill>
-                  <a:srgbClr val="58718B"/>
-                </a:solidFill>
-                <a:latin typeface="Helvetica Neue"/>
-                <a:ea typeface="Helvetica Neue"/>
-                <a:cs typeface="Helvetica Neue"/>
-              </a:defRPr>
-            </a:pPr>
-            <a:r>
-              <a:rPr sz="1350" b="0">
-                <a:solidFill>
-                  <a:srgbClr val="58718B"/>
-                </a:solidFill>
-                <a:latin typeface="Helvetica Neue"/>
-                <a:ea typeface="Helvetica Neue"/>
-                <a:cs typeface="Helvetica Neue"/>
-              </a:rPr>
-              <a:t>Actual desktop demo</a:t>
+              <a:defRPr sz="1875" b="0">
+                <a:solidFill>
+                  <a:srgbClr val="123363"/>
+                </a:solidFill>
+                <a:latin typeface="Helvetica Neue"/>
+                <a:ea typeface="Helvetica Neue"/>
+                <a:cs typeface="Helvetica Neue"/>
+              </a:defRPr>
+            </a:pPr>
+            <a:r>
+              <a:rPr sz="1875" b="0">
+                <a:solidFill>
+                  <a:srgbClr val="123363"/>
+                </a:solidFill>
+                <a:latin typeface="Helvetica Neue"/>
+                <a:ea typeface="Helvetica Neue"/>
+                <a:cs typeface="Helvetica Neue"/>
+              </a:rPr>
+              <a:t>Open the latest research and continue preparing.</a:t>
+            </a:r>
+          </a:p>
+        </p:txBody>
+      </p:sp>
+      <p:sp>
+        <p:nvSpPr>
+          <p:cNvPr id="7" name="">
+            <a:extLst xmlns:a="http://schemas.openxmlformats.org/drawingml/2006/main">
+              <a:ext uri="{FF2B5EF4-FFF2-40B4-BE49-F238E27FC236}">
+                <a16:creationId xmlns:a16="http://schemas.microsoft.com/office/drawing/2014/main" id="{5245E354-F539-4A0C-A96E-733686BC0350}"/>
+              </a:ext>
+            </a:extLst>
+          </p:cNvPr>
+          <p:cNvSpPr>
+            <a:spLocks xmlns:a="http://schemas.openxmlformats.org/drawingml/2006/main" noGrp="1"/>
+          </p:cNvSpPr>
+          <p:nvPr/>
+        </p:nvSpPr>
+        <p:spPr>
+          <a:xfrm xmlns:a="http://schemas.openxmlformats.org/drawingml/2006/main">
+            <a:off x="8953500" y="5229225"/>
+            <a:ext cx="2619375" cy="447675"/>
+          </a:xfrm>
+          <a:prstGeom xmlns:a="http://schemas.openxmlformats.org/drawingml/2006/main" prst="rect">
+            <a:avLst/>
+          </a:prstGeom>
+          <a:noFill xmlns:a="http://schemas.openxmlformats.org/drawingml/2006/main"/>
+          <a:ln xmlns:a="http://schemas.openxmlformats.org/drawingml/2006/main" w="0">
+            <a:noFill/>
+          </a:ln>
+        </p:spPr>
+        <p:txBody>
+          <a:bodyPr xmlns:a="http://schemas.openxmlformats.org/drawingml/2006/main">
+            <a:noAutofit/>
+          </a:bodyPr>
+          <a:lstStyle xmlns:a="http://schemas.openxmlformats.org/drawingml/2006/main"/>
+          <a:p xmlns:a="http://schemas.openxmlformats.org/drawingml/2006/main">
+            <a:pPr>
+              <a:defRPr sz="2025" b="1">
+                <a:solidFill>
+                  <a:srgbClr val="126FCE"/>
+                </a:solidFill>
+                <a:latin typeface="Helvetica Neue"/>
+                <a:ea typeface="Helvetica Neue"/>
+                <a:cs typeface="Helvetica Neue"/>
+              </a:defRPr>
+            </a:pPr>
+            <a:r>
+              <a:rPr sz="2025" b="1">
+                <a:solidFill>
+                  <a:srgbClr val="126FCE"/>
+                </a:solidFill>
+                <a:latin typeface="Helvetica Neue"/>
+                <a:ea typeface="Helvetica Neue"/>
+                <a:cs typeface="Helvetica Neue"/>
+              </a:rPr>
+              <a:t>Team workspace</a:t>
+            </a:r>
+          </a:p>
+        </p:txBody>
+      </p:sp>
+      <p:sp>
+        <p:nvSpPr>
+          <p:cNvPr id="8" name="">
+            <a:extLst xmlns:a="http://schemas.openxmlformats.org/drawingml/2006/main">
+              <a:ext uri="{FF2B5EF4-FFF2-40B4-BE49-F238E27FC236}">
+                <a16:creationId xmlns:a16="http://schemas.microsoft.com/office/drawing/2014/main" id="{29849976-896E-48F3-8FF4-10B5E1151B39}"/>
+              </a:ext>
+            </a:extLst>
+          </p:cNvPr>
+          <p:cNvSpPr>
+            <a:spLocks xmlns:a="http://schemas.openxmlformats.org/drawingml/2006/main" noGrp="1"/>
+          </p:cNvSpPr>
+          <p:nvPr/>
+        </p:nvSpPr>
+        <p:spPr>
+          <a:xfrm xmlns:a="http://schemas.openxmlformats.org/drawingml/2006/main">
+            <a:off x="8953500" y="5762625"/>
+            <a:ext cx="2619375" cy="762000"/>
+          </a:xfrm>
+          <a:prstGeom xmlns:a="http://schemas.openxmlformats.org/drawingml/2006/main" prst="rect">
+            <a:avLst/>
+          </a:prstGeom>
+          <a:noFill xmlns:a="http://schemas.openxmlformats.org/drawingml/2006/main"/>
+          <a:ln xmlns:a="http://schemas.openxmlformats.org/drawingml/2006/main" w="0">
+            <a:noFill/>
+          </a:ln>
+        </p:spPr>
+        <p:txBody>
+          <a:bodyPr xmlns:a="http://schemas.openxmlformats.org/drawingml/2006/main">
+            <a:noAutofit/>
+          </a:bodyPr>
+          <a:lstStyle xmlns:a="http://schemas.openxmlformats.org/drawingml/2006/main"/>
+          <a:p xmlns:a="http://schemas.openxmlformats.org/drawingml/2006/main">
+            <a:pPr>
+              <a:defRPr sz="1875" b="0">
+                <a:solidFill>
+                  <a:srgbClr val="123363"/>
+                </a:solidFill>
+                <a:latin typeface="Helvetica Neue"/>
+                <a:ea typeface="Helvetica Neue"/>
+                <a:cs typeface="Helvetica Neue"/>
+              </a:defRPr>
+            </a:pPr>
+            <a:r>
+              <a:rPr sz="1875" b="0">
+                <a:solidFill>
+                  <a:srgbClr val="123363"/>
+                </a:solidFill>
+                <a:latin typeface="Helvetica Neue"/>
+                <a:ea typeface="Helvetica Neue"/>
+                <a:cs typeface="Helvetica Neue"/>
+              </a:rPr>
+              <a:t>Keep prospect research together.</a:t>
             </a:r>
           </a:p>
         </p:txBody>
@@ -5021,7 +4995,7 @@
     </p:spTree>
     <p:extLst>
       <p:ext uri="{BB962C8B-B14F-4D97-AF65-F5344CB8AC3E}">
-        <p14:creationId xmlns:p14="http://schemas.microsoft.com/office/powerpoint/2010/main" val="1764491624"/>
+        <p14:creationId xmlns:p14="http://schemas.microsoft.com/office/powerpoint/2010/main" val="381628285"/>
       </p:ext>
     </p:extLst>
   </p:cSld>
@@ -5034,7 +5008,7 @@
     <p:bg>
       <p:bgPr>
         <a:solidFill xmlns:a="http://schemas.openxmlformats.org/drawingml/2006/main">
-          <a:srgbClr val="0B214A"/>
+          <a:srgbClr val="FFFFFF"/>
         </a:solidFill>
       </p:bgPr>
     </p:bg>
@@ -5049,22 +5023,22 @@
       </p:grpSpPr>
       <p:sp>
         <p:nvSpPr>
-          <p:cNvPr id="4" name="">
-            <a:extLst xmlns:a="http://schemas.openxmlformats.org/drawingml/2006/main">
-              <a:ext uri="{FF2B5EF4-FFF2-40B4-BE49-F238E27FC236}">
-                <a16:creationId xmlns:a16="http://schemas.microsoft.com/office/drawing/2014/main" id="{F03C1AAC-2FB0-4ACF-8A86-20CF92113FA7}"/>
-              </a:ext>
-            </a:extLst>
-          </p:cNvPr>
-          <p:cNvSpPr>
-            <a:spLocks xmlns:a="http://schemas.openxmlformats.org/drawingml/2006/main" noGrp="1"/>
-          </p:cNvSpPr>
-          <p:nvPr/>
-        </p:nvSpPr>
-        <p:spPr>
-          <a:xfrm xmlns:a="http://schemas.openxmlformats.org/drawingml/2006/main">
-            <a:off x="523875" y="371475"/>
-            <a:ext cx="11144250" cy="742950"/>
+          <p:cNvPr id="11" name="">
+            <a:extLst xmlns:a="http://schemas.openxmlformats.org/drawingml/2006/main">
+              <a:ext uri="{FF2B5EF4-FFF2-40B4-BE49-F238E27FC236}">
+                <a16:creationId xmlns:a16="http://schemas.microsoft.com/office/drawing/2014/main" id="{A7863CEE-2475-45B2-ABB5-4B8FD2B27792}"/>
+              </a:ext>
+            </a:extLst>
+          </p:cNvPr>
+          <p:cNvSpPr>
+            <a:spLocks xmlns:a="http://schemas.openxmlformats.org/drawingml/2006/main" noGrp="1"/>
+          </p:cNvSpPr>
+          <p:nvPr/>
+        </p:nvSpPr>
+        <p:spPr>
+          <a:xfrm xmlns:a="http://schemas.openxmlformats.org/drawingml/2006/main">
+            <a:off x="609600" y="457200"/>
+            <a:ext cx="10972800" cy="762000"/>
           </a:xfrm>
           <a:prstGeom xmlns:a="http://schemas.openxmlformats.org/drawingml/2006/main" prst="rect">
             <a:avLst/>
@@ -5081,19 +5055,19 @@
           <a:lstStyle xmlns:a="http://schemas.openxmlformats.org/drawingml/2006/main"/>
           <a:p xmlns:a="http://schemas.openxmlformats.org/drawingml/2006/main">
             <a:pPr>
-              <a:defRPr sz="3825" b="1">
-                <a:solidFill>
-                  <a:srgbClr val="FFFFFF"/>
-                </a:solidFill>
-                <a:latin typeface="Helvetica Neue"/>
-                <a:ea typeface="Helvetica Neue"/>
-                <a:cs typeface="Helvetica Neue"/>
-              </a:defRPr>
-            </a:pPr>
-            <a:r>
-              <a:rPr sz="3825" b="1">
-                <a:solidFill>
-                  <a:srgbClr val="FFFFFF"/>
+              <a:defRPr sz="3525" b="1">
+                <a:solidFill>
+                  <a:srgbClr val="0B214A"/>
+                </a:solidFill>
+                <a:latin typeface="Helvetica Neue"/>
+                <a:ea typeface="Helvetica Neue"/>
+                <a:cs typeface="Helvetica Neue"/>
+              </a:defRPr>
+            </a:pPr>
+            <a:r>
+              <a:rPr sz="3525" b="1">
+                <a:solidFill>
+                  <a:srgbClr val="0B214A"/>
                 </a:solidFill>
                 <a:latin typeface="Helvetica Neue"/>
                 <a:ea typeface="Helvetica Neue"/>
@@ -5109,19 +5083,19 @@
           <p:cNvPr id="2" name="">
             <a:extLst xmlns:a="http://schemas.openxmlformats.org/drawingml/2006/main">
               <a:ext uri="{FF2B5EF4-FFF2-40B4-BE49-F238E27FC236}">
-                <a16:creationId xmlns:a16="http://schemas.microsoft.com/office/drawing/2014/main" id="{EAF47995-3839-4937-B6F5-0469D206AB9A}"/>
-              </a:ext>
-            </a:extLst>
-          </p:cNvPr>
-          <p:cNvSpPr>
-            <a:spLocks xmlns:a="http://schemas.openxmlformats.org/drawingml/2006/main" noGrp="1"/>
-          </p:cNvSpPr>
-          <p:nvPr/>
-        </p:nvSpPr>
-        <p:spPr>
-          <a:xfrm xmlns:a="http://schemas.openxmlformats.org/drawingml/2006/main">
-            <a:off x="581025" y="1143000"/>
-            <a:ext cx="10944225" cy="476250"/>
+                <a16:creationId xmlns:a16="http://schemas.microsoft.com/office/drawing/2014/main" id="{949CC28D-91EF-4A02-9703-A4D4217664DD}"/>
+              </a:ext>
+            </a:extLst>
+          </p:cNvPr>
+          <p:cNvSpPr>
+            <a:spLocks xmlns:a="http://schemas.openxmlformats.org/drawingml/2006/main" noGrp="1"/>
+          </p:cNvSpPr>
+          <p:nvPr/>
+        </p:nvSpPr>
+        <p:spPr>
+          <a:xfrm xmlns:a="http://schemas.openxmlformats.org/drawingml/2006/main">
+            <a:off x="657225" y="1266825"/>
+            <a:ext cx="10896600" cy="457200"/>
           </a:xfrm>
           <a:prstGeom xmlns:a="http://schemas.openxmlformats.org/drawingml/2006/main" prst="rect">
             <a:avLst/>
@@ -5138,7 +5112,379 @@
           <a:lstStyle xmlns:a="http://schemas.openxmlformats.org/drawingml/2006/main"/>
           <a:p xmlns:a="http://schemas.openxmlformats.org/drawingml/2006/main">
             <a:pPr>
-              <a:defRPr sz="1725" b="0">
+              <a:defRPr sz="1875" b="0">
+                <a:solidFill>
+                  <a:srgbClr val="58718B"/>
+                </a:solidFill>
+                <a:latin typeface="Helvetica Neue"/>
+                <a:ea typeface="Helvetica Neue"/>
+                <a:cs typeface="Helvetica Neue"/>
+              </a:defRPr>
+            </a:pPr>
+            <a:r>
+              <a:rPr sz="1875" b="0">
+                <a:solidFill>
+                  <a:srgbClr val="58718B"/>
+                </a:solidFill>
+                <a:latin typeface="Helvetica Neue"/>
+                <a:ea typeface="Helvetica Neue"/>
+                <a:cs typeface="Helvetica Neue"/>
+              </a:rPr>
+              <a:t>Vercel example: product detail</a:t>
+            </a:r>
+          </a:p>
+        </p:txBody>
+      </p:sp>
+      <p:sp>
+        <p:nvSpPr>
+          <p:cNvPr id="3" name="">
+            <a:extLst xmlns:a="http://schemas.openxmlformats.org/drawingml/2006/main">
+              <a:ext uri="{FF2B5EF4-FFF2-40B4-BE49-F238E27FC236}">
+                <a16:creationId xmlns:a16="http://schemas.microsoft.com/office/drawing/2014/main" id="{792B2997-B961-46E9-83A3-877776FE407A}"/>
+              </a:ext>
+            </a:extLst>
+          </p:cNvPr>
+          <p:cNvSpPr>
+            <a:spLocks xmlns:a="http://schemas.openxmlformats.org/drawingml/2006/main" noGrp="1"/>
+          </p:cNvSpPr>
+          <p:nvPr/>
+        </p:nvSpPr>
+        <p:spPr>
+          <a:xfrm xmlns:a="http://schemas.openxmlformats.org/drawingml/2006/main">
+            <a:off x="657225" y="2085975"/>
+            <a:ext cx="4524375" cy="457200"/>
+          </a:xfrm>
+          <a:prstGeom xmlns:a="http://schemas.openxmlformats.org/drawingml/2006/main" prst="rect">
+            <a:avLst/>
+          </a:prstGeom>
+          <a:noFill xmlns:a="http://schemas.openxmlformats.org/drawingml/2006/main"/>
+          <a:ln xmlns:a="http://schemas.openxmlformats.org/drawingml/2006/main" w="0">
+            <a:noFill/>
+          </a:ln>
+        </p:spPr>
+        <p:txBody>
+          <a:bodyPr xmlns:a="http://schemas.openxmlformats.org/drawingml/2006/main">
+            <a:noAutofit/>
+          </a:bodyPr>
+          <a:lstStyle xmlns:a="http://schemas.openxmlformats.org/drawingml/2006/main"/>
+          <a:p xmlns:a="http://schemas.openxmlformats.org/drawingml/2006/main">
+            <a:pPr>
+              <a:defRPr sz="2025" b="1">
+                <a:solidFill>
+                  <a:srgbClr val="126FCE"/>
+                </a:solidFill>
+                <a:latin typeface="Helvetica Neue"/>
+                <a:ea typeface="Helvetica Neue"/>
+                <a:cs typeface="Helvetica Neue"/>
+              </a:defRPr>
+            </a:pPr>
+            <a:r>
+              <a:rPr sz="2025" b="1">
+                <a:solidFill>
+                  <a:srgbClr val="126FCE"/>
+                </a:solidFill>
+                <a:latin typeface="Helvetica Neue"/>
+                <a:ea typeface="Helvetica Neue"/>
+                <a:cs typeface="Helvetica Neue"/>
+              </a:rPr>
+              <a:t>Source claim</a:t>
+            </a:r>
+          </a:p>
+        </p:txBody>
+      </p:sp>
+      <p:sp>
+        <p:nvSpPr>
+          <p:cNvPr id="4" name="">
+            <a:extLst xmlns:a="http://schemas.openxmlformats.org/drawingml/2006/main">
+              <a:ext uri="{FF2B5EF4-FFF2-40B4-BE49-F238E27FC236}">
+                <a16:creationId xmlns:a16="http://schemas.microsoft.com/office/drawing/2014/main" id="{B9E67B4F-A628-4DCC-A2CD-E92B9747D68A}"/>
+              </a:ext>
+            </a:extLst>
+          </p:cNvPr>
+          <p:cNvSpPr>
+            <a:spLocks xmlns:a="http://schemas.openxmlformats.org/drawingml/2006/main" noGrp="1"/>
+          </p:cNvSpPr>
+          <p:nvPr/>
+        </p:nvSpPr>
+        <p:spPr>
+          <a:xfrm xmlns:a="http://schemas.openxmlformats.org/drawingml/2006/main">
+            <a:off x="657225" y="2657475"/>
+            <a:ext cx="4419600" cy="1600200"/>
+          </a:xfrm>
+          <a:prstGeom xmlns:a="http://schemas.openxmlformats.org/drawingml/2006/main" prst="rect">
+            <a:avLst/>
+          </a:prstGeom>
+          <a:noFill xmlns:a="http://schemas.openxmlformats.org/drawingml/2006/main"/>
+          <a:ln xmlns:a="http://schemas.openxmlformats.org/drawingml/2006/main" w="0">
+            <a:noFill/>
+          </a:ln>
+        </p:spPr>
+        <p:txBody>
+          <a:bodyPr xmlns:a="http://schemas.openxmlformats.org/drawingml/2006/main">
+            <a:noAutofit/>
+          </a:bodyPr>
+          <a:lstStyle xmlns:a="http://schemas.openxmlformats.org/drawingml/2006/main"/>
+          <a:p xmlns:a="http://schemas.openxmlformats.org/drawingml/2006/main">
+            <a:pPr>
+              <a:defRPr sz="2100" b="0">
+                <a:solidFill>
+                  <a:srgbClr val="123363"/>
+                </a:solidFill>
+                <a:latin typeface="Helvetica Neue"/>
+                <a:ea typeface="Helvetica Neue"/>
+                <a:cs typeface="Helvetica Neue"/>
+              </a:defRPr>
+            </a:pPr>
+            <a:r>
+              <a:rPr sz="2100" b="0">
+                <a:solidFill>
+                  <a:srgbClr val="123363"/>
+                </a:solidFill>
+                <a:latin typeface="Helvetica Neue"/>
+                <a:ea typeface="Helvetica Neue"/>
+                <a:cs typeface="Helvetica Neue"/>
+              </a:rPr>
+              <a:t>Guillermo Rauch created Next.js and Vercel with a focus on developer experience (DX) to make the Web faster.</a:t>
+            </a:r>
+          </a:p>
+        </p:txBody>
+      </p:sp>
+      <p:sp>
+        <p:nvSpPr>
+          <p:cNvPr id="5" name="">
+            <a:extLst xmlns:a="http://schemas.openxmlformats.org/drawingml/2006/main">
+              <a:ext uri="{FF2B5EF4-FFF2-40B4-BE49-F238E27FC236}">
+                <a16:creationId xmlns:a16="http://schemas.microsoft.com/office/drawing/2014/main" id="{EE73F43A-AF2D-47A3-B91D-5D536385EC71}"/>
+              </a:ext>
+            </a:extLst>
+          </p:cNvPr>
+          <p:cNvSpPr>
+            <a:spLocks xmlns:a="http://schemas.openxmlformats.org/drawingml/2006/main" noGrp="1"/>
+          </p:cNvSpPr>
+          <p:nvPr/>
+        </p:nvSpPr>
+        <p:spPr>
+          <a:xfrm xmlns:a="http://schemas.openxmlformats.org/drawingml/2006/main">
+            <a:off x="5905500" y="2085975"/>
+            <a:ext cx="5638800" cy="457200"/>
+          </a:xfrm>
+          <a:prstGeom xmlns:a="http://schemas.openxmlformats.org/drawingml/2006/main" prst="rect">
+            <a:avLst/>
+          </a:prstGeom>
+          <a:noFill xmlns:a="http://schemas.openxmlformats.org/drawingml/2006/main"/>
+          <a:ln xmlns:a="http://schemas.openxmlformats.org/drawingml/2006/main" w="0">
+            <a:noFill/>
+          </a:ln>
+        </p:spPr>
+        <p:txBody>
+          <a:bodyPr xmlns:a="http://schemas.openxmlformats.org/drawingml/2006/main">
+            <a:noAutofit/>
+          </a:bodyPr>
+          <a:lstStyle xmlns:a="http://schemas.openxmlformats.org/drawingml/2006/main"/>
+          <a:p xmlns:a="http://schemas.openxmlformats.org/drawingml/2006/main">
+            <a:pPr>
+              <a:defRPr sz="2025" b="1">
+                <a:solidFill>
+                  <a:srgbClr val="126FCE"/>
+                </a:solidFill>
+                <a:latin typeface="Helvetica Neue"/>
+                <a:ea typeface="Helvetica Neue"/>
+                <a:cs typeface="Helvetica Neue"/>
+              </a:defRPr>
+            </a:pPr>
+            <a:r>
+              <a:rPr sz="2025" b="1">
+                <a:solidFill>
+                  <a:srgbClr val="126FCE"/>
+                </a:solidFill>
+                <a:latin typeface="Helvetica Neue"/>
+                <a:ea typeface="Helvetica Neue"/>
+                <a:cs typeface="Helvetica Neue"/>
+              </a:rPr>
+              <a:t>Why it could matter</a:t>
+            </a:r>
+          </a:p>
+        </p:txBody>
+      </p:sp>
+      <p:sp>
+        <p:nvSpPr>
+          <p:cNvPr id="6" name="">
+            <a:extLst xmlns:a="http://schemas.openxmlformats.org/drawingml/2006/main">
+              <a:ext uri="{FF2B5EF4-FFF2-40B4-BE49-F238E27FC236}">
+                <a16:creationId xmlns:a16="http://schemas.microsoft.com/office/drawing/2014/main" id="{3DD3735F-EB53-4637-BD14-CD8D91341E74}"/>
+              </a:ext>
+            </a:extLst>
+          </p:cNvPr>
+          <p:cNvSpPr>
+            <a:spLocks xmlns:a="http://schemas.openxmlformats.org/drawingml/2006/main" noGrp="1"/>
+          </p:cNvSpPr>
+          <p:nvPr/>
+        </p:nvSpPr>
+        <p:spPr>
+          <a:xfrm xmlns:a="http://schemas.openxmlformats.org/drawingml/2006/main">
+            <a:off x="5905500" y="2657475"/>
+            <a:ext cx="5562600" cy="2124075"/>
+          </a:xfrm>
+          <a:prstGeom xmlns:a="http://schemas.openxmlformats.org/drawingml/2006/main" prst="rect">
+            <a:avLst/>
+          </a:prstGeom>
+          <a:noFill xmlns:a="http://schemas.openxmlformats.org/drawingml/2006/main"/>
+          <a:ln xmlns:a="http://schemas.openxmlformats.org/drawingml/2006/main" w="0">
+            <a:noFill/>
+          </a:ln>
+        </p:spPr>
+        <p:txBody>
+          <a:bodyPr xmlns:a="http://schemas.openxmlformats.org/drawingml/2006/main">
+            <a:noAutofit/>
+          </a:bodyPr>
+          <a:lstStyle xmlns:a="http://schemas.openxmlformats.org/drawingml/2006/main"/>
+          <a:p xmlns:a="http://schemas.openxmlformats.org/drawingml/2006/main">
+            <a:pPr>
+              <a:defRPr sz="1875" b="0">
+                <a:solidFill>
+                  <a:srgbClr val="123363"/>
+                </a:solidFill>
+                <a:latin typeface="Helvetica Neue"/>
+                <a:ea typeface="Helvetica Neue"/>
+                <a:cs typeface="Helvetica Neue"/>
+              </a:defRPr>
+            </a:pPr>
+            <a:r>
+              <a:rPr sz="1875" b="0">
+                <a:solidFill>
+                  <a:srgbClr val="123363"/>
+                </a:solidFill>
+                <a:latin typeface="Helvetica Neue"/>
+                <a:ea typeface="Helvetica Neue"/>
+                <a:cs typeface="Helvetica Neue"/>
+              </a:rPr>
+              <a:t>If the stated focus on developer experience to make the Web faster means Vercel actively tracks where new users struggle, then onboarding funnel analytics combining usage metrics and session feedback might help prioritize documentation and product fixes more effectively.</a:t>
+            </a:r>
+          </a:p>
+        </p:txBody>
+      </p:sp>
+      <p:sp>
+        <p:nvSpPr>
+          <p:cNvPr id="7" name="">
+            <a:extLst xmlns:a="http://schemas.openxmlformats.org/drawingml/2006/main">
+              <a:ext uri="{FF2B5EF4-FFF2-40B4-BE49-F238E27FC236}">
+                <a16:creationId xmlns:a16="http://schemas.microsoft.com/office/drawing/2014/main" id="{FA706C2D-6BA5-400B-9430-C98A0B31C10F}"/>
+              </a:ext>
+            </a:extLst>
+          </p:cNvPr>
+          <p:cNvSpPr>
+            <a:spLocks xmlns:a="http://schemas.openxmlformats.org/drawingml/2006/main" noGrp="1"/>
+          </p:cNvSpPr>
+          <p:nvPr/>
+        </p:nvSpPr>
+        <p:spPr>
+          <a:xfrm xmlns:a="http://schemas.openxmlformats.org/drawingml/2006/main">
+            <a:off x="5905500" y="4848225"/>
+            <a:ext cx="5562600" cy="381000"/>
+          </a:xfrm>
+          <a:prstGeom xmlns:a="http://schemas.openxmlformats.org/drawingml/2006/main" prst="rect">
+            <a:avLst/>
+          </a:prstGeom>
+          <a:noFill xmlns:a="http://schemas.openxmlformats.org/drawingml/2006/main"/>
+          <a:ln xmlns:a="http://schemas.openxmlformats.org/drawingml/2006/main" w="0">
+            <a:noFill/>
+          </a:ln>
+        </p:spPr>
+        <p:txBody>
+          <a:bodyPr xmlns:a="http://schemas.openxmlformats.org/drawingml/2006/main">
+            <a:noAutofit/>
+          </a:bodyPr>
+          <a:lstStyle xmlns:a="http://schemas.openxmlformats.org/drawingml/2006/main"/>
+          <a:p xmlns:a="http://schemas.openxmlformats.org/drawingml/2006/main">
+            <a:pPr>
+              <a:defRPr sz="1575" b="0">
+                <a:solidFill>
+                  <a:srgbClr val="58718B"/>
+                </a:solidFill>
+                <a:latin typeface="Helvetica Neue"/>
+                <a:ea typeface="Helvetica Neue"/>
+                <a:cs typeface="Helvetica Neue"/>
+              </a:defRPr>
+            </a:pPr>
+            <a:r>
+              <a:rPr sz="1575" b="0">
+                <a:solidFill>
+                  <a:srgbClr val="58718B"/>
+                </a:solidFill>
+                <a:latin typeface="Helvetica Neue"/>
+                <a:ea typeface="Helvetica Neue"/>
+                <a:cs typeface="Helvetica Neue"/>
+              </a:rPr>
+              <a:t>Hypothesis to validate</a:t>
+            </a:r>
+          </a:p>
+        </p:txBody>
+      </p:sp>
+      <p:sp>
+        <p:nvSpPr>
+          <p:cNvPr id="8" name="">
+            <a:extLst xmlns:a="http://schemas.openxmlformats.org/drawingml/2006/main">
+              <a:ext uri="{FF2B5EF4-FFF2-40B4-BE49-F238E27FC236}">
+                <a16:creationId xmlns:a16="http://schemas.microsoft.com/office/drawing/2014/main" id="{7A77A900-6897-477F-8089-1D0F18D56ACD}"/>
+              </a:ext>
+            </a:extLst>
+          </p:cNvPr>
+          <p:cNvSpPr>
+            <a:spLocks xmlns:a="http://schemas.openxmlformats.org/drawingml/2006/main" noGrp="1"/>
+          </p:cNvSpPr>
+          <p:nvPr/>
+        </p:nvSpPr>
+        <p:spPr>
+          <a:xfrm xmlns:a="http://schemas.openxmlformats.org/drawingml/2006/main">
+            <a:off x="609600" y="5276850"/>
+            <a:ext cx="10972800" cy="1352550"/>
+          </a:xfrm>
+          <a:prstGeom xmlns:a="http://schemas.openxmlformats.org/drawingml/2006/main" prst="rect">
+            <a:avLst/>
+          </a:prstGeom>
+          <a:solidFill xmlns:a="http://schemas.openxmlformats.org/drawingml/2006/main">
+            <a:srgbClr val="0B214A"/>
+          </a:solidFill>
+          <a:ln xmlns:a="http://schemas.openxmlformats.org/drawingml/2006/main" w="0">
+            <a:noFill/>
+          </a:ln>
+        </p:spPr>
+      </p:sp>
+      <p:sp>
+        <p:nvSpPr>
+          <p:cNvPr id="9" name="">
+            <a:extLst xmlns:a="http://schemas.openxmlformats.org/drawingml/2006/main">
+              <a:ext uri="{FF2B5EF4-FFF2-40B4-BE49-F238E27FC236}">
+                <a16:creationId xmlns:a16="http://schemas.microsoft.com/office/drawing/2014/main" id="{6CC8A373-F186-4ACB-BAD6-EF992BE66607}"/>
+              </a:ext>
+            </a:extLst>
+          </p:cNvPr>
+          <p:cNvSpPr>
+            <a:spLocks xmlns:a="http://schemas.openxmlformats.org/drawingml/2006/main" noGrp="1"/>
+          </p:cNvSpPr>
+          <p:nvPr/>
+        </p:nvSpPr>
+        <p:spPr>
+          <a:xfrm xmlns:a="http://schemas.openxmlformats.org/drawingml/2006/main">
+            <a:off x="790575" y="5410200"/>
+            <a:ext cx="10534650" cy="333375"/>
+          </a:xfrm>
+          <a:prstGeom xmlns:a="http://schemas.openxmlformats.org/drawingml/2006/main" prst="rect">
+            <a:avLst/>
+          </a:prstGeom>
+          <a:noFill xmlns:a="http://schemas.openxmlformats.org/drawingml/2006/main"/>
+          <a:ln xmlns:a="http://schemas.openxmlformats.org/drawingml/2006/main" w="0">
+            <a:noFill/>
+          </a:ln>
+        </p:spPr>
+        <p:txBody>
+          <a:bodyPr xmlns:a="http://schemas.openxmlformats.org/drawingml/2006/main">
+            <a:noAutofit/>
+          </a:bodyPr>
+          <a:lstStyle xmlns:a="http://schemas.openxmlformats.org/drawingml/2006/main"/>
+          <a:p xmlns:a="http://schemas.openxmlformats.org/drawingml/2006/main">
+            <a:pPr>
+              <a:defRPr sz="1575" b="1">
                 <a:solidFill>
                   <a:srgbClr val="63D7F2"/>
                 </a:solidFill>
@@ -5148,7 +5494,7 @@
               </a:defRPr>
             </a:pPr>
             <a:r>
-              <a:rPr sz="1725" b="0">
+              <a:rPr sz="1575" b="1">
                 <a:solidFill>
                   <a:srgbClr val="63D7F2"/>
                 </a:solidFill>
@@ -5156,37 +5502,72 @@
                 <a:ea typeface="Helvetica Neue"/>
                 <a:cs typeface="Helvetica Neue"/>
               </a:rPr>
-              <a:t>Actual local Vercel research. Hypotheses remain for the seller to validate.</a:t>
-            </a:r>
-          </a:p>
-        </p:txBody>
-      </p:sp>
-      <p:pic>
-        <p:nvPicPr>
-          <p:cNvPr id="6" name=""/>
-          <p:cNvPicPr>
-            <a:picLocks xmlns:a="http://schemas.openxmlformats.org/drawingml/2006/main" noChangeAspect="1"/>
-          </p:cNvPicPr>
-          <p:nvPr/>
-        </p:nvPicPr>
-        <p:blipFill>
-          <a:blip xmlns:r="http://schemas.openxmlformats.org/officeDocument/2006/relationships" xmlns:a="http://schemas.openxmlformats.org/drawingml/2006/main" r:embed="R306aa3eb7b7d4e33"/>
-          <a:stretch xmlns:a="http://schemas.openxmlformats.org/drawingml/2006/main"/>
-        </p:blipFill>
-        <p:spPr>
-          <a:xfrm xmlns:a="http://schemas.openxmlformats.org/drawingml/2006/main">
-            <a:off x="948801" y="1724025"/>
-            <a:ext cx="10294398" cy="4819650"/>
-          </a:xfrm>
-          <a:prstGeom xmlns:a="http://schemas.openxmlformats.org/drawingml/2006/main" prst="rect">
-            <a:avLst/>
-          </a:prstGeom>
-        </p:spPr>
-      </p:pic>
+              <a:t>Ask in the conversation</a:t>
+            </a:r>
+          </a:p>
+        </p:txBody>
+      </p:sp>
+      <p:sp>
+        <p:nvSpPr>
+          <p:cNvPr id="10" name="">
+            <a:extLst xmlns:a="http://schemas.openxmlformats.org/drawingml/2006/main">
+              <a:ext uri="{FF2B5EF4-FFF2-40B4-BE49-F238E27FC236}">
+                <a16:creationId xmlns:a16="http://schemas.microsoft.com/office/drawing/2014/main" id="{C2DDC1BD-8060-4444-AC0E-785CCE3B69AB}"/>
+              </a:ext>
+            </a:extLst>
+          </p:cNvPr>
+          <p:cNvSpPr>
+            <a:spLocks xmlns:a="http://schemas.openxmlformats.org/drawingml/2006/main" noGrp="1"/>
+          </p:cNvSpPr>
+          <p:nvPr/>
+        </p:nvSpPr>
+        <p:spPr>
+          <a:xfrm xmlns:a="http://schemas.openxmlformats.org/drawingml/2006/main">
+            <a:off x="790575" y="5810250"/>
+            <a:ext cx="10467975" cy="695325"/>
+          </a:xfrm>
+          <a:prstGeom xmlns:a="http://schemas.openxmlformats.org/drawingml/2006/main" prst="rect">
+            <a:avLst/>
+          </a:prstGeom>
+          <a:noFill xmlns:a="http://schemas.openxmlformats.org/drawingml/2006/main"/>
+          <a:ln xmlns:a="http://schemas.openxmlformats.org/drawingml/2006/main" w="0">
+            <a:noFill/>
+          </a:ln>
+        </p:spPr>
+        <p:txBody>
+          <a:bodyPr xmlns:a="http://schemas.openxmlformats.org/drawingml/2006/main">
+            <a:noAutofit/>
+          </a:bodyPr>
+          <a:lstStyle xmlns:a="http://schemas.openxmlformats.org/drawingml/2006/main"/>
+          <a:p xmlns:a="http://schemas.openxmlformats.org/drawingml/2006/main">
+            <a:pPr>
+              <a:defRPr sz="2025" b="0">
+                <a:solidFill>
+                  <a:srgbClr val="FFFFFF"/>
+                </a:solidFill>
+                <a:latin typeface="Helvetica Neue"/>
+                <a:ea typeface="Helvetica Neue"/>
+                <a:cs typeface="Helvetica Neue"/>
+              </a:defRPr>
+            </a:pPr>
+            <a:r>
+              <a:rPr sz="2025" b="0">
+                <a:solidFill>
+                  <a:srgbClr val="FFFFFF"/>
+                </a:solidFill>
+                <a:latin typeface="Helvetica Neue"/>
+                <a:ea typeface="Helvetica Neue"/>
+                <a:cs typeface="Helvetica Neue"/>
+              </a:rPr>
+              <a:t>How do you currently identify which parts of the initial developer setup cause the most friction?</a:t>
+            </a:r>
+          </a:p>
+        </p:txBody>
+      </p:sp>
     </p:spTree>
     <p:extLst>
       <p:ext uri="{BB962C8B-B14F-4D97-AF65-F5344CB8AC3E}">
-        <p14:creationId xmlns:p14="http://schemas.microsoft.com/office/powerpoint/2010/main" val="2105340469"/>
+        <p14:creationId xmlns:p14="http://schemas.microsoft.com/office/powerpoint/2010/main" val="61989414"/>
       </p:ext>
     </p:extLst>
   </p:cSld>
@@ -5217,7 +5598,7 @@
           <p:cNvPr id="8" name="">
             <a:extLst xmlns:a="http://schemas.openxmlformats.org/drawingml/2006/main">
               <a:ext uri="{FF2B5EF4-FFF2-40B4-BE49-F238E27FC236}">
-                <a16:creationId xmlns:a16="http://schemas.microsoft.com/office/drawing/2014/main" id="{DFE03C7D-F8E5-46D9-989E-CFACB421AA9B}"/>
+                <a16:creationId xmlns:a16="http://schemas.microsoft.com/office/drawing/2014/main" id="{84C1C47D-CEA3-474E-A0A2-80768375263E}"/>
               </a:ext>
             </a:extLst>
           </p:cNvPr>
@@ -5278,7 +5659,7 @@
           <p:nvPr/>
         </p:nvPicPr>
         <p:blipFill>
-          <a:blip xmlns:r="http://schemas.openxmlformats.org/officeDocument/2006/relationships" xmlns:a="http://schemas.openxmlformats.org/drawingml/2006/main" r:embed="R44b897ab1ff641d2"/>
+          <a:blip xmlns:r="http://schemas.openxmlformats.org/officeDocument/2006/relationships" xmlns:a="http://schemas.openxmlformats.org/drawingml/2006/main" r:embed="Rad7bfa14ae8e45a0"/>
           <a:stretch xmlns:a="http://schemas.openxmlformats.org/drawingml/2006/main"/>
         </p:blipFill>
         <p:spPr>
@@ -5296,7 +5677,7 @@
           <p:cNvPr id="3" name="">
             <a:extLst xmlns:a="http://schemas.openxmlformats.org/drawingml/2006/main">
               <a:ext uri="{FF2B5EF4-FFF2-40B4-BE49-F238E27FC236}">
-                <a16:creationId xmlns:a16="http://schemas.microsoft.com/office/drawing/2014/main" id="{549564D7-3522-49C0-BFEB-433A063B7A57}"/>
+                <a16:creationId xmlns:a16="http://schemas.microsoft.com/office/drawing/2014/main" id="{78D65A8C-22FB-4D55-9E22-3C4C793A09F1}"/>
               </a:ext>
             </a:extLst>
           </p:cNvPr>
@@ -5353,7 +5734,7 @@
           <p:cNvPr id="4" name="">
             <a:extLst xmlns:a="http://schemas.openxmlformats.org/drawingml/2006/main">
               <a:ext uri="{FF2B5EF4-FFF2-40B4-BE49-F238E27FC236}">
-                <a16:creationId xmlns:a16="http://schemas.microsoft.com/office/drawing/2014/main" id="{6A4F49C3-2F7B-4D9F-BC30-9FEBC4BE82AF}"/>
+                <a16:creationId xmlns:a16="http://schemas.microsoft.com/office/drawing/2014/main" id="{B8D1E0BD-D389-4AC8-BC91-4C8003E11278}"/>
               </a:ext>
             </a:extLst>
           </p:cNvPr>
@@ -5410,7 +5791,7 @@
           <p:cNvPr id="5" name="">
             <a:extLst xmlns:a="http://schemas.openxmlformats.org/drawingml/2006/main">
               <a:ext uri="{FF2B5EF4-FFF2-40B4-BE49-F238E27FC236}">
-                <a16:creationId xmlns:a16="http://schemas.microsoft.com/office/drawing/2014/main" id="{FBDABBF3-731B-4656-A903-02AA6553FF80}"/>
+                <a16:creationId xmlns:a16="http://schemas.microsoft.com/office/drawing/2014/main" id="{1C2A85CC-DC6B-49E1-9DC9-04E9C5980718}"/>
               </a:ext>
             </a:extLst>
           </p:cNvPr>
@@ -5467,7 +5848,7 @@
           <p:cNvPr id="6" name="">
             <a:extLst xmlns:a="http://schemas.openxmlformats.org/drawingml/2006/main">
               <a:ext uri="{FF2B5EF4-FFF2-40B4-BE49-F238E27FC236}">
-                <a16:creationId xmlns:a16="http://schemas.microsoft.com/office/drawing/2014/main" id="{ED02EF0C-FA0E-4A86-8822-FFFA6320AB9A}"/>
+                <a16:creationId xmlns:a16="http://schemas.microsoft.com/office/drawing/2014/main" id="{214D6593-7AB4-469B-8F0D-CD556D11701D}"/>
               </a:ext>
             </a:extLst>
           </p:cNvPr>
@@ -5524,7 +5905,7 @@
           <p:cNvPr id="7" name="">
             <a:extLst xmlns:a="http://schemas.openxmlformats.org/drawingml/2006/main">
               <a:ext uri="{FF2B5EF4-FFF2-40B4-BE49-F238E27FC236}">
-                <a16:creationId xmlns:a16="http://schemas.microsoft.com/office/drawing/2014/main" id="{CF0A57F6-2D5C-4CCB-8744-CD790AD97FB8}"/>
+                <a16:creationId xmlns:a16="http://schemas.microsoft.com/office/drawing/2014/main" id="{BAC76CFB-D60A-4ADE-9133-988383E9C840}"/>
               </a:ext>
             </a:extLst>
           </p:cNvPr>
@@ -5579,7 +5960,7 @@
     </p:spTree>
     <p:extLst>
       <p:ext uri="{BB962C8B-B14F-4D97-AF65-F5344CB8AC3E}">
-        <p14:creationId xmlns:p14="http://schemas.microsoft.com/office/powerpoint/2010/main" val="966644827"/>
+        <p14:creationId xmlns:p14="http://schemas.microsoft.com/office/powerpoint/2010/main" val="980344414"/>
       </p:ext>
     </p:extLst>
   </p:cSld>
@@ -5610,7 +5991,7 @@
           <p:cNvPr id="21" name="">
             <a:extLst xmlns:a="http://schemas.openxmlformats.org/drawingml/2006/main">
               <a:ext uri="{FF2B5EF4-FFF2-40B4-BE49-F238E27FC236}">
-                <a16:creationId xmlns:a16="http://schemas.microsoft.com/office/drawing/2014/main" id="{C2163F17-3B9C-43AB-ACBB-40E5B5ED0AD2}"/>
+                <a16:creationId xmlns:a16="http://schemas.microsoft.com/office/drawing/2014/main" id="{E34D2A5B-7EA8-4D91-9715-CB1FBE1AE3E0}"/>
               </a:ext>
             </a:extLst>
           </p:cNvPr>
@@ -5667,7 +6048,7 @@
           <p:cNvPr id="2" name="">
             <a:extLst xmlns:a="http://schemas.openxmlformats.org/drawingml/2006/main">
               <a:ext uri="{FF2B5EF4-FFF2-40B4-BE49-F238E27FC236}">
-                <a16:creationId xmlns:a16="http://schemas.microsoft.com/office/drawing/2014/main" id="{DC8B1B3B-08DF-4600-8468-5EA20B3EABE5}"/>
+                <a16:creationId xmlns:a16="http://schemas.microsoft.com/office/drawing/2014/main" id="{BDA3959E-B73C-40AF-A4BD-D27394A7C4FD}"/>
               </a:ext>
             </a:extLst>
           </p:cNvPr>
@@ -5724,7 +6105,7 @@
           <p:cNvPr id="3" name="">
             <a:extLst xmlns:a="http://schemas.openxmlformats.org/drawingml/2006/main">
               <a:ext uri="{FF2B5EF4-FFF2-40B4-BE49-F238E27FC236}">
-                <a16:creationId xmlns:a16="http://schemas.microsoft.com/office/drawing/2014/main" id="{9D46CE80-BDCC-403C-8708-D91319F42AA8}"/>
+                <a16:creationId xmlns:a16="http://schemas.microsoft.com/office/drawing/2014/main" id="{6FA01A71-8254-467B-9A05-D907B86B8C91}"/>
               </a:ext>
             </a:extLst>
           </p:cNvPr>
@@ -5756,7 +6137,7 @@
           <p:cNvPr id="4" name="">
             <a:extLst xmlns:a="http://schemas.openxmlformats.org/drawingml/2006/main">
               <a:ext uri="{FF2B5EF4-FFF2-40B4-BE49-F238E27FC236}">
-                <a16:creationId xmlns:a16="http://schemas.microsoft.com/office/drawing/2014/main" id="{E88F1EA6-9E43-45B9-8EB9-129BA7FE1F08}"/>
+                <a16:creationId xmlns:a16="http://schemas.microsoft.com/office/drawing/2014/main" id="{103007D9-3262-4D52-935A-984CE5A53EF2}"/>
               </a:ext>
             </a:extLst>
           </p:cNvPr>
@@ -5836,7 +6217,7 @@
           <p:cNvPr id="5" name="">
             <a:extLst xmlns:a="http://schemas.openxmlformats.org/drawingml/2006/main">
               <a:ext uri="{FF2B5EF4-FFF2-40B4-BE49-F238E27FC236}">
-                <a16:creationId xmlns:a16="http://schemas.microsoft.com/office/drawing/2014/main" id="{C00C8AB1-7E2F-41E7-B90E-D90EAC5A4252}"/>
+                <a16:creationId xmlns:a16="http://schemas.microsoft.com/office/drawing/2014/main" id="{1B63651E-979B-4235-A233-4752FBE68B1F}"/>
               </a:ext>
             </a:extLst>
           </p:cNvPr>
@@ -5868,7 +6249,7 @@
           <p:cNvPr id="6" name="">
             <a:extLst xmlns:a="http://schemas.openxmlformats.org/drawingml/2006/main">
               <a:ext uri="{FF2B5EF4-FFF2-40B4-BE49-F238E27FC236}">
-                <a16:creationId xmlns:a16="http://schemas.microsoft.com/office/drawing/2014/main" id="{FC544E58-8ABF-4584-9B46-BE5A63355764}"/>
+                <a16:creationId xmlns:a16="http://schemas.microsoft.com/office/drawing/2014/main" id="{DEA2E039-5F8B-4DB1-A501-15BC02D56002}"/>
               </a:ext>
             </a:extLst>
           </p:cNvPr>
@@ -5948,7 +6329,7 @@
           <p:cNvPr id="7" name="">
             <a:extLst xmlns:a="http://schemas.openxmlformats.org/drawingml/2006/main">
               <a:ext uri="{FF2B5EF4-FFF2-40B4-BE49-F238E27FC236}">
-                <a16:creationId xmlns:a16="http://schemas.microsoft.com/office/drawing/2014/main" id="{9362DC3C-4BA0-48DD-AA47-F41CF0EC4DF1}"/>
+                <a16:creationId xmlns:a16="http://schemas.microsoft.com/office/drawing/2014/main" id="{4B53BC19-E947-4569-99FD-4D263C5C522D}"/>
               </a:ext>
             </a:extLst>
           </p:cNvPr>
@@ -5980,7 +6361,7 @@
           <p:cNvPr id="8" name="">
             <a:extLst xmlns:a="http://schemas.openxmlformats.org/drawingml/2006/main">
               <a:ext uri="{FF2B5EF4-FFF2-40B4-BE49-F238E27FC236}">
-                <a16:creationId xmlns:a16="http://schemas.microsoft.com/office/drawing/2014/main" id="{CC9014DA-C930-43FF-A3F8-43C20CA3BA81}"/>
+                <a16:creationId xmlns:a16="http://schemas.microsoft.com/office/drawing/2014/main" id="{6DF7742A-6FB3-4E78-BDD3-66DA40272B33}"/>
               </a:ext>
             </a:extLst>
           </p:cNvPr>
@@ -6060,7 +6441,7 @@
           <p:cNvPr id="9" name="">
             <a:extLst xmlns:a="http://schemas.openxmlformats.org/drawingml/2006/main">
               <a:ext uri="{FF2B5EF4-FFF2-40B4-BE49-F238E27FC236}">
-                <a16:creationId xmlns:a16="http://schemas.microsoft.com/office/drawing/2014/main" id="{54E84E87-5C52-46EC-BDB2-79ECF189C1CD}"/>
+                <a16:creationId xmlns:a16="http://schemas.microsoft.com/office/drawing/2014/main" id="{A9A8B23D-B613-4E40-BC37-4CFD05C592FB}"/>
               </a:ext>
             </a:extLst>
           </p:cNvPr>
@@ -6092,7 +6473,7 @@
           <p:cNvPr id="10" name="">
             <a:extLst xmlns:a="http://schemas.openxmlformats.org/drawingml/2006/main">
               <a:ext uri="{FF2B5EF4-FFF2-40B4-BE49-F238E27FC236}">
-                <a16:creationId xmlns:a16="http://schemas.microsoft.com/office/drawing/2014/main" id="{2D4B6048-6A81-41AE-8362-E81840C791D7}"/>
+                <a16:creationId xmlns:a16="http://schemas.microsoft.com/office/drawing/2014/main" id="{7DBD7BCC-D27E-4339-93E6-43D2B03A6D10}"/>
               </a:ext>
             </a:extLst>
           </p:cNvPr>
@@ -6172,7 +6553,7 @@
           <p:cNvPr id="11" name="">
             <a:extLst xmlns:a="http://schemas.openxmlformats.org/drawingml/2006/main">
               <a:ext uri="{FF2B5EF4-FFF2-40B4-BE49-F238E27FC236}">
-                <a16:creationId xmlns:a16="http://schemas.microsoft.com/office/drawing/2014/main" id="{A4A415E9-340E-450A-8B2D-A3E6E5E6F080}"/>
+                <a16:creationId xmlns:a16="http://schemas.microsoft.com/office/drawing/2014/main" id="{7F37F7E5-FCB0-4FBD-8ED1-731BCC5CFA62}"/>
               </a:ext>
             </a:extLst>
           </p:cNvPr>
@@ -6204,7 +6585,7 @@
           <p:cNvPr id="12" name="">
             <a:extLst xmlns:a="http://schemas.openxmlformats.org/drawingml/2006/main">
               <a:ext uri="{FF2B5EF4-FFF2-40B4-BE49-F238E27FC236}">
-                <a16:creationId xmlns:a16="http://schemas.microsoft.com/office/drawing/2014/main" id="{B07CEDE6-3259-4664-BBBA-F95798BCA8FF}"/>
+                <a16:creationId xmlns:a16="http://schemas.microsoft.com/office/drawing/2014/main" id="{3959C943-5E20-4549-A89B-41EDF1B9BB8D}"/>
               </a:ext>
             </a:extLst>
           </p:cNvPr>
@@ -6284,7 +6665,7 @@
           <p:cNvPr id="13" name="">
             <a:extLst xmlns:a="http://schemas.openxmlformats.org/drawingml/2006/main">
               <a:ext uri="{FF2B5EF4-FFF2-40B4-BE49-F238E27FC236}">
-                <a16:creationId xmlns:a16="http://schemas.microsoft.com/office/drawing/2014/main" id="{71C899CD-C0B3-4382-BD1A-796BC4C7414D}"/>
+                <a16:creationId xmlns:a16="http://schemas.microsoft.com/office/drawing/2014/main" id="{ABA4EC4A-FE72-4328-B6E6-AF54E148B7D8}"/>
               </a:ext>
             </a:extLst>
           </p:cNvPr>
@@ -6316,7 +6697,7 @@
           <p:cNvPr id="14" name="">
             <a:extLst xmlns:a="http://schemas.openxmlformats.org/drawingml/2006/main">
               <a:ext uri="{FF2B5EF4-FFF2-40B4-BE49-F238E27FC236}">
-                <a16:creationId xmlns:a16="http://schemas.microsoft.com/office/drawing/2014/main" id="{514AC9F6-2ED4-4C2A-A8E7-36468F1A7A5A}"/>
+                <a16:creationId xmlns:a16="http://schemas.microsoft.com/office/drawing/2014/main" id="{6A1F2D27-A22D-41F2-BA34-260E752E896B}"/>
               </a:ext>
             </a:extLst>
           </p:cNvPr>
@@ -6549,7 +6930,7 @@
           <p:cNvPr id="20" name="">
             <a:extLst xmlns:a="http://schemas.openxmlformats.org/drawingml/2006/main">
               <a:ext uri="{FF2B5EF4-FFF2-40B4-BE49-F238E27FC236}">
-                <a16:creationId xmlns:a16="http://schemas.microsoft.com/office/drawing/2014/main" id="{7EB7FDB8-C59E-45BD-B7D5-501D416E63A6}"/>
+                <a16:creationId xmlns:a16="http://schemas.microsoft.com/office/drawing/2014/main" id="{ECCD2644-CBCC-4329-B716-A40F232E0A62}"/>
               </a:ext>
             </a:extLst>
           </p:cNvPr>
@@ -6604,7 +6985,7 @@
     </p:spTree>
     <p:extLst>
       <p:ext uri="{BB962C8B-B14F-4D97-AF65-F5344CB8AC3E}">
-        <p14:creationId xmlns:p14="http://schemas.microsoft.com/office/powerpoint/2010/main" val="1304257298"/>
+        <p14:creationId xmlns:p14="http://schemas.microsoft.com/office/powerpoint/2010/main" val="1113105654"/>
       </p:ext>
     </p:extLst>
   </p:cSld>
@@ -6632,10 +7013,10 @@
       </p:grpSpPr>
       <p:sp>
         <p:nvSpPr>
-          <p:cNvPr id="5" name="">
-            <a:extLst xmlns:a="http://schemas.openxmlformats.org/drawingml/2006/main">
-              <a:ext uri="{FF2B5EF4-FFF2-40B4-BE49-F238E27FC236}">
-                <a16:creationId xmlns:a16="http://schemas.microsoft.com/office/drawing/2014/main" id="{EAD5B432-B185-4B5D-8646-97C676B85A1A}"/>
+          <p:cNvPr id="8" name="">
+            <a:extLst xmlns:a="http://schemas.openxmlformats.org/drawingml/2006/main">
+              <a:ext uri="{FF2B5EF4-FFF2-40B4-BE49-F238E27FC236}">
+                <a16:creationId xmlns:a16="http://schemas.microsoft.com/office/drawing/2014/main" id="{1BE8D7F7-5B1F-4DC0-BBBF-D586352E1F34}"/>
               </a:ext>
             </a:extLst>
           </p:cNvPr>
@@ -6692,7 +7073,7 @@
           <p:cNvPr id="2" name="">
             <a:extLst xmlns:a="http://schemas.openxmlformats.org/drawingml/2006/main">
               <a:ext uri="{FF2B5EF4-FFF2-40B4-BE49-F238E27FC236}">
-                <a16:creationId xmlns:a16="http://schemas.microsoft.com/office/drawing/2014/main" id="{934585F3-6166-4582-AAF0-E9699F94F246}"/>
+                <a16:creationId xmlns:a16="http://schemas.microsoft.com/office/drawing/2014/main" id="{BF6B1CCC-7EC0-4393-8788-A356D9BE9A8B}"/>
               </a:ext>
             </a:extLst>
           </p:cNvPr>
@@ -6744,46 +7125,24 @@
           </a:p>
         </p:txBody>
       </p:sp>
-      <p:pic>
-        <p:nvPicPr>
-          <p:cNvPr id="7" name=""/>
-          <p:cNvPicPr>
-            <a:picLocks xmlns:a="http://schemas.openxmlformats.org/drawingml/2006/main" noChangeAspect="1"/>
-          </p:cNvPicPr>
-          <p:nvPr/>
-        </p:nvPicPr>
-        <p:blipFill>
-          <a:blip xmlns:r="http://schemas.openxmlformats.org/officeDocument/2006/relationships" xmlns:a="http://schemas.openxmlformats.org/drawingml/2006/main" r:embed="Rd5f13d97ab124de7"/>
-          <a:stretch xmlns:a="http://schemas.openxmlformats.org/drawingml/2006/main"/>
-        </p:blipFill>
-        <p:spPr>
-          <a:xfrm xmlns:a="http://schemas.openxmlformats.org/drawingml/2006/main">
-            <a:off x="571500" y="2277096"/>
-            <a:ext cx="11049000" cy="3723033"/>
-          </a:xfrm>
-          <a:prstGeom xmlns:a="http://schemas.openxmlformats.org/drawingml/2006/main" prst="rect">
-            <a:avLst/>
-          </a:prstGeom>
-        </p:spPr>
-      </p:pic>
-      <p:sp>
-        <p:nvSpPr>
-          <p:cNvPr id="4" name="">
-            <a:extLst xmlns:a="http://schemas.openxmlformats.org/drawingml/2006/main">
-              <a:ext uri="{FF2B5EF4-FFF2-40B4-BE49-F238E27FC236}">
-                <a16:creationId xmlns:a16="http://schemas.microsoft.com/office/drawing/2014/main" id="{0ACF01DB-2148-4526-84E3-299298ABA4E7}"/>
-              </a:ext>
-            </a:extLst>
-          </p:cNvPr>
-          <p:cNvSpPr>
-            <a:spLocks xmlns:a="http://schemas.openxmlformats.org/drawingml/2006/main" noGrp="1"/>
-          </p:cNvSpPr>
-          <p:nvPr/>
-        </p:nvSpPr>
-        <p:spPr>
-          <a:xfrm xmlns:a="http://schemas.openxmlformats.org/drawingml/2006/main">
-            <a:off x="590550" y="6315075"/>
-            <a:ext cx="10858500" cy="409575"/>
+      <p:sp>
+        <p:nvSpPr>
+          <p:cNvPr id="3" name="">
+            <a:extLst xmlns:a="http://schemas.openxmlformats.org/drawingml/2006/main">
+              <a:ext uri="{FF2B5EF4-FFF2-40B4-BE49-F238E27FC236}">
+                <a16:creationId xmlns:a16="http://schemas.microsoft.com/office/drawing/2014/main" id="{425D3703-05BD-4BCB-A5E7-700879BC8AF0}"/>
+              </a:ext>
+            </a:extLst>
+          </p:cNvPr>
+          <p:cNvSpPr>
+            <a:spLocks xmlns:a="http://schemas.openxmlformats.org/drawingml/2006/main" noGrp="1"/>
+          </p:cNvSpPr>
+          <p:nvPr/>
+        </p:nvSpPr>
+        <p:spPr>
+          <a:xfrm xmlns:a="http://schemas.openxmlformats.org/drawingml/2006/main">
+            <a:off x="657225" y="2305050"/>
+            <a:ext cx="10829925" cy="390525"/>
           </a:xfrm>
           <a:prstGeom xmlns:a="http://schemas.openxmlformats.org/drawingml/2006/main" prst="rect">
             <a:avLst/>
@@ -6800,6 +7159,257 @@
           <a:lstStyle xmlns:a="http://schemas.openxmlformats.org/drawingml/2006/main"/>
           <a:p xmlns:a="http://schemas.openxmlformats.org/drawingml/2006/main">
             <a:pPr>
+              <a:defRPr sz="1875" b="0">
+                <a:solidFill>
+                  <a:srgbClr val="123363"/>
+                </a:solidFill>
+                <a:latin typeface="Helvetica Neue"/>
+                <a:ea typeface="Helvetica Neue"/>
+                <a:cs typeface="Helvetica Neue"/>
+              </a:defRPr>
+            </a:pPr>
+            <a:r>
+              <a:rPr sz="1875" b="0">
+                <a:solidFill>
+                  <a:srgbClr val="123363"/>
+                </a:solidFill>
+                <a:latin typeface="Helvetica Neue"/>
+                <a:ea typeface="Helvetica Neue"/>
+                <a:cs typeface="Helvetica Neue"/>
+              </a:rPr>
+              <a:t>Hi Guillermo,</a:t>
+            </a:r>
+          </a:p>
+        </p:txBody>
+      </p:sp>
+      <p:sp>
+        <p:nvSpPr>
+          <p:cNvPr id="4" name="">
+            <a:extLst xmlns:a="http://schemas.openxmlformats.org/drawingml/2006/main">
+              <a:ext uri="{FF2B5EF4-FFF2-40B4-BE49-F238E27FC236}">
+                <a16:creationId xmlns:a16="http://schemas.microsoft.com/office/drawing/2014/main" id="{E3721BE4-D65B-44D2-913A-1FD0D1C2343A}"/>
+              </a:ext>
+            </a:extLst>
+          </p:cNvPr>
+          <p:cNvSpPr>
+            <a:spLocks xmlns:a="http://schemas.openxmlformats.org/drawingml/2006/main" noGrp="1"/>
+          </p:cNvSpPr>
+          <p:nvPr/>
+        </p:nvSpPr>
+        <p:spPr>
+          <a:xfrm xmlns:a="http://schemas.openxmlformats.org/drawingml/2006/main">
+            <a:off x="657225" y="2886075"/>
+            <a:ext cx="10829925" cy="1343025"/>
+          </a:xfrm>
+          <a:prstGeom xmlns:a="http://schemas.openxmlformats.org/drawingml/2006/main" prst="rect">
+            <a:avLst/>
+          </a:prstGeom>
+          <a:noFill xmlns:a="http://schemas.openxmlformats.org/drawingml/2006/main"/>
+          <a:ln xmlns:a="http://schemas.openxmlformats.org/drawingml/2006/main" w="0">
+            <a:noFill/>
+          </a:ln>
+        </p:spPr>
+        <p:txBody>
+          <a:bodyPr xmlns:a="http://schemas.openxmlformats.org/drawingml/2006/main">
+            <a:noAutofit/>
+          </a:bodyPr>
+          <a:lstStyle xmlns:a="http://schemas.openxmlformats.org/drawingml/2006/main"/>
+          <a:p xmlns:a="http://schemas.openxmlformats.org/drawingml/2006/main">
+            <a:pPr>
+              <a:defRPr sz="1875" b="0">
+                <a:solidFill>
+                  <a:srgbClr val="123363"/>
+                </a:solidFill>
+                <a:latin typeface="Helvetica Neue"/>
+                <a:ea typeface="Helvetica Neue"/>
+                <a:cs typeface="Helvetica Neue"/>
+              </a:defRPr>
+            </a:pPr>
+            <a:r>
+              <a:rPr sz="1875" b="0">
+                <a:solidFill>
+                  <a:srgbClr val="123363"/>
+                </a:solidFill>
+                <a:latin typeface="Helvetica Neue"/>
+                <a:ea typeface="Helvetica Neue"/>
+                <a:cs typeface="Helvetica Neue"/>
+              </a:rPr>
+              <a:t>I noticed Vercel’s stated vision includes providing analytics as part of an end-to-end platform. With 3 product tiers and technical Account Executives working alongside developers, I’m curious how your team identifies where developers get stuck during onboarding.</a:t>
+            </a:r>
+          </a:p>
+        </p:txBody>
+      </p:sp>
+      <p:sp>
+        <p:nvSpPr>
+          <p:cNvPr id="5" name="">
+            <a:extLst xmlns:a="http://schemas.openxmlformats.org/drawingml/2006/main">
+              <a:ext uri="{FF2B5EF4-FFF2-40B4-BE49-F238E27FC236}">
+                <a16:creationId xmlns:a16="http://schemas.microsoft.com/office/drawing/2014/main" id="{F0FC8601-A985-4591-A9D2-AAD1A6F60EBB}"/>
+              </a:ext>
+            </a:extLst>
+          </p:cNvPr>
+          <p:cNvSpPr>
+            <a:spLocks xmlns:a="http://schemas.openxmlformats.org/drawingml/2006/main" noGrp="1"/>
+          </p:cNvSpPr>
+          <p:nvPr/>
+        </p:nvSpPr>
+        <p:spPr>
+          <a:xfrm xmlns:a="http://schemas.openxmlformats.org/drawingml/2006/main">
+            <a:off x="657225" y="4324350"/>
+            <a:ext cx="10829925" cy="1047750"/>
+          </a:xfrm>
+          <a:prstGeom xmlns:a="http://schemas.openxmlformats.org/drawingml/2006/main" prst="rect">
+            <a:avLst/>
+          </a:prstGeom>
+          <a:noFill xmlns:a="http://schemas.openxmlformats.org/drawingml/2006/main"/>
+          <a:ln xmlns:a="http://schemas.openxmlformats.org/drawingml/2006/main" w="0">
+            <a:noFill/>
+          </a:ln>
+        </p:spPr>
+        <p:txBody>
+          <a:bodyPr xmlns:a="http://schemas.openxmlformats.org/drawingml/2006/main">
+            <a:noAutofit/>
+          </a:bodyPr>
+          <a:lstStyle xmlns:a="http://schemas.openxmlformats.org/drawingml/2006/main"/>
+          <a:p xmlns:a="http://schemas.openxmlformats.org/drawingml/2006/main">
+            <a:pPr>
+              <a:defRPr sz="1875" b="0">
+                <a:solidFill>
+                  <a:srgbClr val="123363"/>
+                </a:solidFill>
+                <a:latin typeface="Helvetica Neue"/>
+                <a:ea typeface="Helvetica Neue"/>
+                <a:cs typeface="Helvetica Neue"/>
+              </a:defRPr>
+            </a:pPr>
+            <a:r>
+              <a:rPr sz="1875" b="0">
+                <a:solidFill>
+                  <a:srgbClr val="123363"/>
+                </a:solidFill>
+                <a:latin typeface="Helvetica Neue"/>
+                <a:ea typeface="Helvetica Neue"/>
+                <a:cs typeface="Helvetica Neue"/>
+              </a:rPr>
+              <a:t>We help developer platforms combine usage metrics and session feedback to prioritize documentation and product fixes. If improving onboarding visibility is a current focus, would it make sense to connect?</a:t>
+            </a:r>
+          </a:p>
+        </p:txBody>
+      </p:sp>
+      <p:sp>
+        <p:nvSpPr>
+          <p:cNvPr id="6" name="">
+            <a:extLst xmlns:a="http://schemas.openxmlformats.org/drawingml/2006/main">
+              <a:ext uri="{FF2B5EF4-FFF2-40B4-BE49-F238E27FC236}">
+                <a16:creationId xmlns:a16="http://schemas.microsoft.com/office/drawing/2014/main" id="{866FC527-9622-42D4-BEE6-DF4F2B91D9C0}"/>
+              </a:ext>
+            </a:extLst>
+          </p:cNvPr>
+          <p:cNvSpPr>
+            <a:spLocks xmlns:a="http://schemas.openxmlformats.org/drawingml/2006/main" noGrp="1"/>
+          </p:cNvSpPr>
+          <p:nvPr/>
+        </p:nvSpPr>
+        <p:spPr>
+          <a:xfrm xmlns:a="http://schemas.openxmlformats.org/drawingml/2006/main">
+            <a:off x="657225" y="5467350"/>
+            <a:ext cx="10829925" cy="733425"/>
+          </a:xfrm>
+          <a:prstGeom xmlns:a="http://schemas.openxmlformats.org/drawingml/2006/main" prst="rect">
+            <a:avLst/>
+          </a:prstGeom>
+          <a:noFill xmlns:a="http://schemas.openxmlformats.org/drawingml/2006/main"/>
+          <a:ln xmlns:a="http://schemas.openxmlformats.org/drawingml/2006/main" w="0">
+            <a:noFill/>
+          </a:ln>
+        </p:spPr>
+        <p:txBody>
+          <a:bodyPr xmlns:a="http://schemas.openxmlformats.org/drawingml/2006/main">
+            <a:noAutofit/>
+          </a:bodyPr>
+          <a:lstStyle xmlns:a="http://schemas.openxmlformats.org/drawingml/2006/main"/>
+          <a:p xmlns:a="http://schemas.openxmlformats.org/drawingml/2006/main">
+            <a:pPr>
+              <a:defRPr sz="1800" b="0">
+                <a:solidFill>
+                  <a:srgbClr val="58718B"/>
+                </a:solidFill>
+                <a:latin typeface="Helvetica Neue"/>
+                <a:ea typeface="Helvetica Neue"/>
+                <a:cs typeface="Helvetica Neue"/>
+              </a:defRPr>
+            </a:pPr>
+            <a:r>
+              <a:rPr sz="1800" b="0">
+                <a:solidFill>
+                  <a:srgbClr val="58718B"/>
+                </a:solidFill>
+                <a:latin typeface="Helvetica Neue"/>
+                <a:ea typeface="Helvetica Neue"/>
+                <a:cs typeface="Helvetica Neue"/>
+              </a:rPr>
+              <a:t>Best,</a:t>
+            </a:r>
+          </a:p>
+          <a:p xmlns:a="http://schemas.openxmlformats.org/drawingml/2006/main">
+            <a:pPr>
+              <a:defRPr sz="1800" b="0">
+                <a:solidFill>
+                  <a:srgbClr val="58718B"/>
+                </a:solidFill>
+                <a:latin typeface="Helvetica Neue"/>
+                <a:ea typeface="Helvetica Neue"/>
+                <a:cs typeface="Helvetica Neue"/>
+              </a:defRPr>
+            </a:pPr>
+            <a:r>
+              <a:rPr sz="1800" b="0">
+                <a:solidFill>
+                  <a:srgbClr val="58718B"/>
+                </a:solidFill>
+                <a:latin typeface="Helvetica Neue"/>
+                <a:ea typeface="Helvetica Neue"/>
+                <a:cs typeface="Helvetica Neue"/>
+              </a:rPr>
+              <a:t>E2E Tester</a:t>
+            </a:r>
+          </a:p>
+        </p:txBody>
+      </p:sp>
+      <p:sp>
+        <p:nvSpPr>
+          <p:cNvPr id="7" name="">
+            <a:extLst xmlns:a="http://schemas.openxmlformats.org/drawingml/2006/main">
+              <a:ext uri="{FF2B5EF4-FFF2-40B4-BE49-F238E27FC236}">
+                <a16:creationId xmlns:a16="http://schemas.microsoft.com/office/drawing/2014/main" id="{19AE429C-87E2-4E84-8610-E1DF3EB8C1F8}"/>
+              </a:ext>
+            </a:extLst>
+          </p:cNvPr>
+          <p:cNvSpPr>
+            <a:spLocks xmlns:a="http://schemas.openxmlformats.org/drawingml/2006/main" noGrp="1"/>
+          </p:cNvSpPr>
+          <p:nvPr/>
+        </p:nvSpPr>
+        <p:spPr>
+          <a:xfrm xmlns:a="http://schemas.openxmlformats.org/drawingml/2006/main">
+            <a:off x="590550" y="6315075"/>
+            <a:ext cx="10858500" cy="409575"/>
+          </a:xfrm>
+          <a:prstGeom xmlns:a="http://schemas.openxmlformats.org/drawingml/2006/main" prst="rect">
+            <a:avLst/>
+          </a:prstGeom>
+          <a:noFill xmlns:a="http://schemas.openxmlformats.org/drawingml/2006/main"/>
+          <a:ln xmlns:a="http://schemas.openxmlformats.org/drawingml/2006/main" w="0">
+            <a:noFill/>
+          </a:ln>
+        </p:spPr>
+        <p:txBody>
+          <a:bodyPr xmlns:a="http://schemas.openxmlformats.org/drawingml/2006/main">
+            <a:noAutofit/>
+          </a:bodyPr>
+          <a:lstStyle xmlns:a="http://schemas.openxmlformats.org/drawingml/2006/main"/>
+          <a:p xmlns:a="http://schemas.openxmlformats.org/drawingml/2006/main">
+            <a:pPr>
               <a:defRPr sz="1800" b="1">
                 <a:solidFill>
                   <a:srgbClr val="123363"/>
@@ -6826,7 +7436,7 @@
     </p:spTree>
     <p:extLst>
       <p:ext uri="{BB962C8B-B14F-4D97-AF65-F5344CB8AC3E}">
-        <p14:creationId xmlns:p14="http://schemas.microsoft.com/office/powerpoint/2010/main" val="943544727"/>
+        <p14:creationId xmlns:p14="http://schemas.microsoft.com/office/powerpoint/2010/main" val="1597425485"/>
       </p:ext>
     </p:extLst>
   </p:cSld>

</xml_diff>